<commit_message>
Territory review template: blank numbers, no watermark, lead time on losses
Replace the sample chart with a blank quarterly table (bookings, quotes,
hit rate, quoted lead time), drop the shield background on light layouts,
and add a lead time line to each loss card.

Co-Authored-By: Claude Fable 5.1 <noreply@anthropic.com>
Claude-Session: https://claude.ai/code/session_01NccKroytcPyz54UophNQtq
</commit_message>
<xml_diff>
--- a/decks/territory-review/Territory Review Template - Market (Mac).pptx
+++ b/decks/territory-review/Territory Review Template - Market (Mac).pptx
@@ -111,243 +111,6 @@
     </a:lvl9pPr>
   </p:defaultTextStyle>
 </p:presentation>
-</file>
-
-<file path=ppt/charts/chart1.xml><?xml version="1.0" encoding="utf-8"?>
-<c:chartSpace xmlns:c="http://schemas.openxmlformats.org/drawingml/2006/chart" xmlns:a="http://schemas.openxmlformats.org/drawingml/2006/main" xmlns:r="http://schemas.openxmlformats.org/officeDocument/2006/relationships">
-  <c:date1904 val="0"/>
-  <c:chart>
-    <c:autoTitleDeleted val="1"/>
-    <c:plotArea>
-      <c:barChart>
-        <c:barDir val="col"/>
-        <c:grouping val="clustered"/>
-        <c:ser>
-          <c:idx val="0"/>
-          <c:order val="0"/>
-          <c:tx>
-            <c:strRef>
-              <c:f>Sheet1!$B$1</c:f>
-              <c:strCache>
-                <c:ptCount val="1"/>
-                <c:pt idx="0">
-                  <c:v>Bookings</c:v>
-                </c:pt>
-              </c:strCache>
-            </c:strRef>
-          </c:tx>
-          <c:spPr>
-            <a:solidFill>
-              <a:srgbClr val="3C7D4D"/>
-            </a:solidFill>
-          </c:spPr>
-          <c:cat>
-            <c:strRef>
-              <c:f>Sheet1!$A$2:$A$5</c:f>
-              <c:strCache>
-                <c:ptCount val="4"/>
-                <c:pt idx="0">
-                  <c:v>Q4 2025</c:v>
-                </c:pt>
-                <c:pt idx="1">
-                  <c:v>Q1 2026</c:v>
-                </c:pt>
-                <c:pt idx="2">
-                  <c:v>Q2 2026</c:v>
-                </c:pt>
-                <c:pt idx="3">
-                  <c:v>Q3 2026</c:v>
-                </c:pt>
-              </c:strCache>
-            </c:strRef>
-          </c:cat>
-          <c:val>
-            <c:numRef>
-              <c:f>Sheet1!$B$2:$B$5</c:f>
-              <c:numCache>
-                <c:formatCode>General</c:formatCode>
-                <c:ptCount val="4"/>
-                <c:pt idx="0">
-                  <c:v>850</c:v>
-                </c:pt>
-                <c:pt idx="1">
-                  <c:v>920</c:v>
-                </c:pt>
-                <c:pt idx="2">
-                  <c:v>780</c:v>
-                </c:pt>
-                <c:pt idx="3">
-                  <c:v>1010</c:v>
-                </c:pt>
-              </c:numCache>
-            </c:numRef>
-          </c:val>
-        </c:ser>
-        <c:ser>
-          <c:idx val="1"/>
-          <c:order val="1"/>
-          <c:tx>
-            <c:strRef>
-              <c:f>Sheet1!$C$1</c:f>
-              <c:strCache>
-                <c:ptCount val="1"/>
-                <c:pt idx="0">
-                  <c:v>Quotes</c:v>
-                </c:pt>
-              </c:strCache>
-            </c:strRef>
-          </c:tx>
-          <c:spPr>
-            <a:solidFill>
-              <a:srgbClr val="5B6670"/>
-            </a:solidFill>
-          </c:spPr>
-          <c:cat>
-            <c:strRef>
-              <c:f>Sheet1!$A$2:$A$5</c:f>
-              <c:strCache>
-                <c:ptCount val="4"/>
-                <c:pt idx="0">
-                  <c:v>Q4 2025</c:v>
-                </c:pt>
-                <c:pt idx="1">
-                  <c:v>Q1 2026</c:v>
-                </c:pt>
-                <c:pt idx="2">
-                  <c:v>Q2 2026</c:v>
-                </c:pt>
-                <c:pt idx="3">
-                  <c:v>Q3 2026</c:v>
-                </c:pt>
-              </c:strCache>
-            </c:strRef>
-          </c:cat>
-          <c:val>
-            <c:numRef>
-              <c:f>Sheet1!$C$2:$C$5</c:f>
-              <c:numCache>
-                <c:formatCode>General</c:formatCode>
-                <c:ptCount val="4"/>
-                <c:pt idx="0">
-                  <c:v>2400</c:v>
-                </c:pt>
-                <c:pt idx="1">
-                  <c:v>2650</c:v>
-                </c:pt>
-                <c:pt idx="2">
-                  <c:v>2100</c:v>
-                </c:pt>
-                <c:pt idx="3">
-                  <c:v>2900</c:v>
-                </c:pt>
-              </c:numCache>
-            </c:numRef>
-          </c:val>
-        </c:ser>
-        <c:dLbls>
-          <c:numFmt formatCode="$#,##0&quot;K&quot;" sourceLinked="0"/>
-          <c:txPr>
-            <a:bodyPr/>
-            <a:lstStyle/>
-            <a:p>
-              <a:pPr>
-                <a:defRPr sz="900">
-                  <a:latin typeface="Arial"/>
-                </a:defRPr>
-              </a:pPr>
-            </a:p>
-          </c:txPr>
-          <c:showLegendKey val="0"/>
-          <c:showVal val="1"/>
-          <c:showCatName val="0"/>
-          <c:showSerName val="0"/>
-          <c:showPercent val="0"/>
-          <c:showBubbleSize val="0"/>
-          <c:showLeaderLines val="1"/>
-        </c:dLbls>
-        <c:gapWidth val="55"/>
-        <c:overlap val="-10"/>
-        <c:axId val="-2068027336"/>
-        <c:axId val="-2113994440"/>
-      </c:barChart>
-      <c:catAx>
-        <c:axId val="-2068027336"/>
-        <c:scaling>
-          <c:orientation val="minMax"/>
-        </c:scaling>
-        <c:delete val="0"/>
-        <c:axPos val="b"/>
-        <c:majorTickMark val="out"/>
-        <c:minorTickMark val="none"/>
-        <c:tickLblPos val="nextTo"/>
-        <c:spPr>
-          <a:ln>
-            <a:solidFill>
-              <a:srgbClr val="E2E6E3"/>
-            </a:solidFill>
-          </a:ln>
-        </c:spPr>
-        <c:txPr>
-          <a:bodyPr/>
-          <a:lstStyle/>
-          <a:p>
-            <a:pPr>
-              <a:defRPr sz="1000">
-                <a:latin typeface="Arial"/>
-              </a:defRPr>
-            </a:pPr>
-          </a:p>
-        </c:txPr>
-        <c:crossAx val="-2113994440"/>
-        <c:crosses val="autoZero"/>
-        <c:auto val="1"/>
-        <c:lblAlgn val="ctr"/>
-        <c:lblOffset val="100"/>
-        <c:noMultiLvlLbl val="0"/>
-      </c:catAx>
-      <c:valAx>
-        <c:axId val="-2113994440"/>
-        <c:scaling/>
-        <c:delete/>
-        <c:axPos val="l"/>
-        <c:majorTickMark val="out"/>
-        <c:minorTickMark val="none"/>
-        <c:tickLblPos val="nextTo"/>
-        <c:crossAx val="-2068027336"/>
-        <c:crosses val="autoZero"/>
-      </c:valAx>
-    </c:plotArea>
-    <c:legend>
-      <c:legendPos val="b"/>
-      <c:overlay val="0"/>
-      <c:txPr>
-        <a:bodyPr/>
-        <a:lstStyle/>
-        <a:p>
-          <a:pPr>
-            <a:defRPr sz="1000">
-              <a:latin typeface="Arial"/>
-            </a:defRPr>
-          </a:pPr>
-        </a:p>
-      </c:txPr>
-    </c:legend>
-    <c:dispBlanksAs val="gap"/>
-  </c:chart>
-  <c:txPr>
-    <a:bodyPr/>
-    <a:lstStyle/>
-    <a:p>
-      <a:pPr>
-        <a:defRPr sz="1800"/>
-      </a:pPr>
-      <a:endParaRPr lang="en-US"/>
-    </a:p>
-  </c:txPr>
-  <c:externalData r:id="rId1">
-    <c:autoUpdate val="0"/>
-  </c:externalData>
-</c:chartSpace>
 </file>
 
 <file path=ppt/notesMasters/notesMaster1.xml><?xml version="1.0" encoding="utf-8"?>
@@ -1024,7 +787,7 @@
           <a:lstStyle/>
           <a:p>
             <a:r>
-              <a:t>Slide 4. Three losses. One on price, one on product, one on speed and support. Who won, why, and whether we'd lose it again today. On the price loss, include the competitor's number if you have it. If you don't, say unknown. If you don't have a loss in one of the three buckets, say so on the slide.</a:t>
+              <a:t>Slide 4. Three losses. One on price, one on product, one on speed and support. Who won, why, and whether we'd lose it again today. On the price loss, include the competitor's number if you have it. If you don't, say unknown. On every loss, the lead time we quoted and the lead time the winner delivered. If you don't have a loss in one of the three buckets, say so on the slide.</a:t>
             </a:r>
           </a:p>
         </p:txBody>
@@ -1224,15 +987,9 @@
   <p:cSld name="FULL_VISUAL">
     <p:bg>
       <p:bgPr>
-        <a:blipFill dpi="0" rotWithShape="1">
-          <a:blip r:embed="rId2">
-            <a:lum/>
-          </a:blip>
-          <a:srcRect/>
-          <a:stretch>
-            <a:fillRect/>
-          </a:stretch>
-        </a:blipFill>
+        <a:solidFill>
+          <a:srgbClr val="FFFFFF"/>
+        </a:solidFill>
         <a:effectLst/>
       </p:bgPr>
     </p:bg>
@@ -1590,15 +1347,9 @@
   <p:cSld name="COMPARISON">
     <p:bg>
       <p:bgPr>
-        <a:blipFill dpi="0" rotWithShape="1">
-          <a:blip r:embed="rId2">
-            <a:lum/>
-          </a:blip>
-          <a:srcRect/>
-          <a:stretch>
-            <a:fillRect/>
-          </a:stretch>
-        </a:blipFill>
+        <a:solidFill>
+          <a:srgbClr val="FFFFFF"/>
+        </a:solidFill>
         <a:effectLst/>
       </p:bgPr>
     </p:bg>
@@ -2258,15 +2009,9 @@
   <p:cSld name="TIMELINE">
     <p:bg>
       <p:bgPr>
-        <a:blipFill dpi="0" rotWithShape="1">
-          <a:blip r:embed="rId2">
-            <a:lum/>
-          </a:blip>
-          <a:srcRect/>
-          <a:stretch>
-            <a:fillRect/>
-          </a:stretch>
-        </a:blipFill>
+        <a:solidFill>
+          <a:srgbClr val="FFFFFF"/>
+        </a:solidFill>
         <a:effectLst/>
       </p:bgPr>
     </p:bg>
@@ -3718,15 +3463,9 @@
   <p:cSld name="NEXT_STEPS">
     <p:bg>
       <p:bgPr>
-        <a:blipFill dpi="0" rotWithShape="1">
-          <a:blip r:embed="rId2">
-            <a:lum/>
-          </a:blip>
-          <a:srcRect/>
-          <a:stretch>
-            <a:fillRect/>
-          </a:stretch>
-        </a:blipFill>
+        <a:solidFill>
+          <a:srgbClr val="FFFFFF"/>
+        </a:solidFill>
         <a:effectLst/>
       </p:bgPr>
     </p:bg>
@@ -5186,15 +4925,9 @@
   <p:cSld name="AGENDA">
     <p:bg>
       <p:bgPr>
-        <a:blipFill dpi="0" rotWithShape="1">
-          <a:blip r:embed="rId2">
-            <a:lum/>
-          </a:blip>
-          <a:srcRect/>
-          <a:stretch>
-            <a:fillRect/>
-          </a:stretch>
-        </a:blipFill>
+        <a:solidFill>
+          <a:srgbClr val="FFFFFF"/>
+        </a:solidFill>
         <a:effectLst/>
       </p:bgPr>
     </p:bg>
@@ -6296,15 +6029,9 @@
   <p:cSld name="TITLE_CONTENT">
     <p:bg>
       <p:bgPr>
-        <a:blipFill dpi="0" rotWithShape="1">
-          <a:blip r:embed="rId2">
-            <a:lum/>
-          </a:blip>
-          <a:srcRect/>
-          <a:stretch>
-            <a:fillRect/>
-          </a:stretch>
-        </a:blipFill>
+        <a:solidFill>
+          <a:srgbClr val="FFFFFF"/>
+        </a:solidFill>
         <a:effectLst/>
       </p:bgPr>
     </p:bg>
@@ -6672,15 +6399,9 @@
   <p:cSld name="TWO_CONTENT">
     <p:bg>
       <p:bgPr>
-        <a:blipFill dpi="0" rotWithShape="1">
-          <a:blip r:embed="rId2">
-            <a:lum/>
-          </a:blip>
-          <a:srcRect/>
-          <a:stretch>
-            <a:fillRect/>
-          </a:stretch>
-        </a:blipFill>
+        <a:solidFill>
+          <a:srgbClr val="FFFFFF"/>
+        </a:solidFill>
         <a:effectLst/>
       </p:bgPr>
     </p:bg>
@@ -7253,15 +6974,9 @@
   <p:cSld name="THREE_CARDS">
     <p:bg>
       <p:bgPr>
-        <a:blipFill dpi="0" rotWithShape="1">
-          <a:blip r:embed="rId2">
-            <a:lum/>
-          </a:blip>
-          <a:srcRect/>
-          <a:stretch>
-            <a:fillRect/>
-          </a:stretch>
-        </a:blipFill>
+        <a:solidFill>
+          <a:srgbClr val="FFFFFF"/>
+        </a:solidFill>
         <a:effectLst/>
       </p:bgPr>
     </p:bg>
@@ -8131,15 +7846,9 @@
   <p:cSld name="BIG_NUMBERS">
     <p:bg>
       <p:bgPr>
-        <a:blipFill dpi="0" rotWithShape="1">
-          <a:blip r:embed="rId2">
-            <a:lum/>
-          </a:blip>
-          <a:srcRect/>
-          <a:stretch>
-            <a:fillRect/>
-          </a:stretch>
-        </a:blipFill>
+        <a:solidFill>
+          <a:srgbClr val="FFFFFF"/>
+        </a:solidFill>
         <a:effectLst/>
       </p:bgPr>
     </p:bg>
@@ -9053,15 +8762,9 @@
   <p:cSld name="CONTENT_VISUAL">
     <p:bg>
       <p:bgPr>
-        <a:blipFill dpi="0" rotWithShape="1">
-          <a:blip r:embed="rId2">
-            <a:lum/>
-          </a:blip>
-          <a:srcRect/>
-          <a:stretch>
-            <a:fillRect/>
-          </a:stretch>
-        </a:blipFill>
+        <a:solidFill>
+          <a:srgbClr val="FFFFFF"/>
+        </a:solidFill>
         <a:effectLst/>
       </p:bgPr>
     </p:bg>
@@ -9998,7 +9701,7 @@
           <a:lstStyle/>
           <a:p>
             <a:r>
-              <a:t>Source: bookings and quotes from [system], pulled [date]. Pre-filled by Nate.</a:t>
+              <a:t>Source: [system], pulled [date]. Hit rate is bookings divided by quotes. Lead time is the average we quoted that quarter.</a:t>
             </a:r>
           </a:p>
         </p:txBody>
@@ -10032,14 +9735,14 @@
                 </a:solidFill>
                 <a:latin typeface="Arial"/>
               </a:rPr>
-              <a:t>BOOKINGS AND QUOTES BY QUARTER ($K)  ·  PRE-FILLED</a:t>
+              <a:t>BY QUARTER  ·  PRE-FILLED</a:t>
             </a:r>
           </a:p>
         </p:txBody>
       </p:sp>
       <p:graphicFrame>
         <p:nvGraphicFramePr>
-          <p:cNvPr id="8" name="Chart 7"/>
+          <p:cNvPr id="8" name="Table 7"/>
           <p:cNvGraphicFramePr>
             <a:graphicFrameLocks noGrp="1"/>
           </p:cNvGraphicFramePr>
@@ -10047,11 +9750,1180 @@
         </p:nvGraphicFramePr>
         <p:xfrm>
           <a:off x="731520" y="2377440"/>
-          <a:ext cx="5120640" cy="1828800"/>
+          <a:ext cx="5120640" cy="1335024"/>
         </p:xfrm>
         <a:graphic>
-          <a:graphicData uri="http://schemas.openxmlformats.org/drawingml/2006/chart">
-            <c:chart xmlns:c="http://schemas.openxmlformats.org/drawingml/2006/chart" r:id="rId2"/>
+          <a:graphicData uri="http://schemas.openxmlformats.org/drawingml/2006/table">
+            <a:tbl>
+              <a:tblPr firstRow="0" bandRow="0"/>
+              <a:tblGrid>
+                <a:gridCol w="1005840"/>
+                <a:gridCol w="1005840"/>
+                <a:gridCol w="1005840"/>
+                <a:gridCol w="868680"/>
+                <a:gridCol w="1234440"/>
+              </a:tblGrid>
+              <a:tr h="274320">
+                <a:tc>
+                  <a:txBody>
+                    <a:bodyPr/>
+                    <a:lstStyle/>
+                    <a:p>
+                      <a:r>
+                        <a:rPr sz="1000" b="1">
+                          <a:solidFill>
+                            <a:srgbClr val="FFFFFF"/>
+                          </a:solidFill>
+                          <a:latin typeface="Arial"/>
+                        </a:rPr>
+                        <a:t>Quarter</a:t>
+                      </a:r>
+                    </a:p>
+                  </a:txBody>
+                  <a:tcPr marL="73152" marR="73152" marT="27432" marB="27432" anchor="ctr">
+                    <a:solidFill>
+                      <a:srgbClr val="3C7D4D"/>
+                    </a:solidFill>
+                    <a:lnL w="6350" cap="flat" cmpd="sng" algn="ctr">
+                      <a:solidFill>
+                        <a:srgbClr val="3C7D4D"/>
+                      </a:solidFill>
+                      <a:prstDash val="solid"/>
+                    </a:lnL>
+                    <a:lnR w="6350" cap="flat" cmpd="sng" algn="ctr">
+                      <a:solidFill>
+                        <a:srgbClr val="3C7D4D"/>
+                      </a:solidFill>
+                      <a:prstDash val="solid"/>
+                    </a:lnR>
+                    <a:lnT w="6350" cap="flat" cmpd="sng" algn="ctr">
+                      <a:solidFill>
+                        <a:srgbClr val="3C7D4D"/>
+                      </a:solidFill>
+                      <a:prstDash val="solid"/>
+                    </a:lnT>
+                    <a:lnB w="6350" cap="flat" cmpd="sng" algn="ctr">
+                      <a:solidFill>
+                        <a:srgbClr val="3C7D4D"/>
+                      </a:solidFill>
+                      <a:prstDash val="solid"/>
+                    </a:lnB>
+                  </a:tcPr>
+                </a:tc>
+                <a:tc>
+                  <a:txBody>
+                    <a:bodyPr/>
+                    <a:lstStyle/>
+                    <a:p>
+                      <a:r>
+                        <a:rPr sz="1000" b="1">
+                          <a:solidFill>
+                            <a:srgbClr val="FFFFFF"/>
+                          </a:solidFill>
+                          <a:latin typeface="Arial"/>
+                        </a:rPr>
+                        <a:t>Bookings</a:t>
+                      </a:r>
+                    </a:p>
+                  </a:txBody>
+                  <a:tcPr marL="73152" marR="73152" marT="27432" marB="27432" anchor="ctr">
+                    <a:solidFill>
+                      <a:srgbClr val="3C7D4D"/>
+                    </a:solidFill>
+                    <a:lnL w="6350" cap="flat" cmpd="sng" algn="ctr">
+                      <a:solidFill>
+                        <a:srgbClr val="3C7D4D"/>
+                      </a:solidFill>
+                      <a:prstDash val="solid"/>
+                    </a:lnL>
+                    <a:lnR w="6350" cap="flat" cmpd="sng" algn="ctr">
+                      <a:solidFill>
+                        <a:srgbClr val="3C7D4D"/>
+                      </a:solidFill>
+                      <a:prstDash val="solid"/>
+                    </a:lnR>
+                    <a:lnT w="6350" cap="flat" cmpd="sng" algn="ctr">
+                      <a:solidFill>
+                        <a:srgbClr val="3C7D4D"/>
+                      </a:solidFill>
+                      <a:prstDash val="solid"/>
+                    </a:lnT>
+                    <a:lnB w="6350" cap="flat" cmpd="sng" algn="ctr">
+                      <a:solidFill>
+                        <a:srgbClr val="3C7D4D"/>
+                      </a:solidFill>
+                      <a:prstDash val="solid"/>
+                    </a:lnB>
+                  </a:tcPr>
+                </a:tc>
+                <a:tc>
+                  <a:txBody>
+                    <a:bodyPr/>
+                    <a:lstStyle/>
+                    <a:p>
+                      <a:r>
+                        <a:rPr sz="1000" b="1">
+                          <a:solidFill>
+                            <a:srgbClr val="FFFFFF"/>
+                          </a:solidFill>
+                          <a:latin typeface="Arial"/>
+                        </a:rPr>
+                        <a:t>Quotes</a:t>
+                      </a:r>
+                    </a:p>
+                  </a:txBody>
+                  <a:tcPr marL="73152" marR="73152" marT="27432" marB="27432" anchor="ctr">
+                    <a:solidFill>
+                      <a:srgbClr val="3C7D4D"/>
+                    </a:solidFill>
+                    <a:lnL w="6350" cap="flat" cmpd="sng" algn="ctr">
+                      <a:solidFill>
+                        <a:srgbClr val="3C7D4D"/>
+                      </a:solidFill>
+                      <a:prstDash val="solid"/>
+                    </a:lnL>
+                    <a:lnR w="6350" cap="flat" cmpd="sng" algn="ctr">
+                      <a:solidFill>
+                        <a:srgbClr val="3C7D4D"/>
+                      </a:solidFill>
+                      <a:prstDash val="solid"/>
+                    </a:lnR>
+                    <a:lnT w="6350" cap="flat" cmpd="sng" algn="ctr">
+                      <a:solidFill>
+                        <a:srgbClr val="3C7D4D"/>
+                      </a:solidFill>
+                      <a:prstDash val="solid"/>
+                    </a:lnT>
+                    <a:lnB w="6350" cap="flat" cmpd="sng" algn="ctr">
+                      <a:solidFill>
+                        <a:srgbClr val="3C7D4D"/>
+                      </a:solidFill>
+                      <a:prstDash val="solid"/>
+                    </a:lnB>
+                  </a:tcPr>
+                </a:tc>
+                <a:tc>
+                  <a:txBody>
+                    <a:bodyPr/>
+                    <a:lstStyle/>
+                    <a:p>
+                      <a:r>
+                        <a:rPr sz="1000" b="1">
+                          <a:solidFill>
+                            <a:srgbClr val="FFFFFF"/>
+                          </a:solidFill>
+                          <a:latin typeface="Arial"/>
+                        </a:rPr>
+                        <a:t>Hit rate</a:t>
+                      </a:r>
+                    </a:p>
+                  </a:txBody>
+                  <a:tcPr marL="73152" marR="73152" marT="27432" marB="27432" anchor="ctr">
+                    <a:solidFill>
+                      <a:srgbClr val="3C7D4D"/>
+                    </a:solidFill>
+                    <a:lnL w="6350" cap="flat" cmpd="sng" algn="ctr">
+                      <a:solidFill>
+                        <a:srgbClr val="3C7D4D"/>
+                      </a:solidFill>
+                      <a:prstDash val="solid"/>
+                    </a:lnL>
+                    <a:lnR w="6350" cap="flat" cmpd="sng" algn="ctr">
+                      <a:solidFill>
+                        <a:srgbClr val="3C7D4D"/>
+                      </a:solidFill>
+                      <a:prstDash val="solid"/>
+                    </a:lnR>
+                    <a:lnT w="6350" cap="flat" cmpd="sng" algn="ctr">
+                      <a:solidFill>
+                        <a:srgbClr val="3C7D4D"/>
+                      </a:solidFill>
+                      <a:prstDash val="solid"/>
+                    </a:lnT>
+                    <a:lnB w="6350" cap="flat" cmpd="sng" algn="ctr">
+                      <a:solidFill>
+                        <a:srgbClr val="3C7D4D"/>
+                      </a:solidFill>
+                      <a:prstDash val="solid"/>
+                    </a:lnB>
+                  </a:tcPr>
+                </a:tc>
+                <a:tc>
+                  <a:txBody>
+                    <a:bodyPr/>
+                    <a:lstStyle/>
+                    <a:p>
+                      <a:r>
+                        <a:rPr sz="1000" b="1">
+                          <a:solidFill>
+                            <a:srgbClr val="FFFFFF"/>
+                          </a:solidFill>
+                          <a:latin typeface="Arial"/>
+                        </a:rPr>
+                        <a:t>Quoted lead time</a:t>
+                      </a:r>
+                    </a:p>
+                  </a:txBody>
+                  <a:tcPr marL="73152" marR="73152" marT="27432" marB="27432" anchor="ctr">
+                    <a:solidFill>
+                      <a:srgbClr val="3C7D4D"/>
+                    </a:solidFill>
+                    <a:lnL w="6350" cap="flat" cmpd="sng" algn="ctr">
+                      <a:solidFill>
+                        <a:srgbClr val="3C7D4D"/>
+                      </a:solidFill>
+                      <a:prstDash val="solid"/>
+                    </a:lnL>
+                    <a:lnR w="6350" cap="flat" cmpd="sng" algn="ctr">
+                      <a:solidFill>
+                        <a:srgbClr val="3C7D4D"/>
+                      </a:solidFill>
+                      <a:prstDash val="solid"/>
+                    </a:lnR>
+                    <a:lnT w="6350" cap="flat" cmpd="sng" algn="ctr">
+                      <a:solidFill>
+                        <a:srgbClr val="3C7D4D"/>
+                      </a:solidFill>
+                      <a:prstDash val="solid"/>
+                    </a:lnT>
+                    <a:lnB w="6350" cap="flat" cmpd="sng" algn="ctr">
+                      <a:solidFill>
+                        <a:srgbClr val="3C7D4D"/>
+                      </a:solidFill>
+                      <a:prstDash val="solid"/>
+                    </a:lnB>
+                  </a:tcPr>
+                </a:tc>
+              </a:tr>
+              <a:tr h="265176">
+                <a:tc>
+                  <a:txBody>
+                    <a:bodyPr/>
+                    <a:lstStyle/>
+                    <a:p>
+                      <a:r>
+                        <a:rPr sz="1000" b="1">
+                          <a:solidFill>
+                            <a:srgbClr val="15181A"/>
+                          </a:solidFill>
+                          <a:latin typeface="Arial"/>
+                        </a:rPr>
+                        <a:t>Q4 2025</a:t>
+                      </a:r>
+                    </a:p>
+                  </a:txBody>
+                  <a:tcPr marL="73152" marR="73152" marT="27432" marB="27432" anchor="t">
+                    <a:solidFill>
+                      <a:srgbClr val="FFFFFF"/>
+                    </a:solidFill>
+                    <a:lnL w="6350" cap="flat" cmpd="sng" algn="ctr">
+                      <a:solidFill>
+                        <a:srgbClr val="E2E6E3"/>
+                      </a:solidFill>
+                      <a:prstDash val="solid"/>
+                    </a:lnL>
+                    <a:lnR w="6350" cap="flat" cmpd="sng" algn="ctr">
+                      <a:solidFill>
+                        <a:srgbClr val="E2E6E3"/>
+                      </a:solidFill>
+                      <a:prstDash val="solid"/>
+                    </a:lnR>
+                    <a:lnT w="6350" cap="flat" cmpd="sng" algn="ctr">
+                      <a:solidFill>
+                        <a:srgbClr val="E2E6E3"/>
+                      </a:solidFill>
+                      <a:prstDash val="solid"/>
+                    </a:lnT>
+                    <a:lnB w="6350" cap="flat" cmpd="sng" algn="ctr">
+                      <a:solidFill>
+                        <a:srgbClr val="E2E6E3"/>
+                      </a:solidFill>
+                      <a:prstDash val="solid"/>
+                    </a:lnB>
+                  </a:tcPr>
+                </a:tc>
+                <a:tc>
+                  <a:txBody>
+                    <a:bodyPr/>
+                    <a:lstStyle/>
+                    <a:p>
+                      <a:r>
+                        <a:rPr sz="1000" b="0">
+                          <a:solidFill>
+                            <a:srgbClr val="5B6670"/>
+                          </a:solidFill>
+                          <a:latin typeface="Arial"/>
+                        </a:rPr>
+                        <a:t/>
+                      </a:r>
+                    </a:p>
+                  </a:txBody>
+                  <a:tcPr marL="73152" marR="73152" marT="27432" marB="27432" anchor="t">
+                    <a:solidFill>
+                      <a:srgbClr val="FFFFFF"/>
+                    </a:solidFill>
+                    <a:lnL w="6350" cap="flat" cmpd="sng" algn="ctr">
+                      <a:solidFill>
+                        <a:srgbClr val="E2E6E3"/>
+                      </a:solidFill>
+                      <a:prstDash val="solid"/>
+                    </a:lnL>
+                    <a:lnR w="6350" cap="flat" cmpd="sng" algn="ctr">
+                      <a:solidFill>
+                        <a:srgbClr val="E2E6E3"/>
+                      </a:solidFill>
+                      <a:prstDash val="solid"/>
+                    </a:lnR>
+                    <a:lnT w="6350" cap="flat" cmpd="sng" algn="ctr">
+                      <a:solidFill>
+                        <a:srgbClr val="E2E6E3"/>
+                      </a:solidFill>
+                      <a:prstDash val="solid"/>
+                    </a:lnT>
+                    <a:lnB w="6350" cap="flat" cmpd="sng" algn="ctr">
+                      <a:solidFill>
+                        <a:srgbClr val="E2E6E3"/>
+                      </a:solidFill>
+                      <a:prstDash val="solid"/>
+                    </a:lnB>
+                  </a:tcPr>
+                </a:tc>
+                <a:tc>
+                  <a:txBody>
+                    <a:bodyPr/>
+                    <a:lstStyle/>
+                    <a:p>
+                      <a:r>
+                        <a:rPr sz="1000" b="0">
+                          <a:solidFill>
+                            <a:srgbClr val="5B6670"/>
+                          </a:solidFill>
+                          <a:latin typeface="Arial"/>
+                        </a:rPr>
+                        <a:t/>
+                      </a:r>
+                    </a:p>
+                  </a:txBody>
+                  <a:tcPr marL="73152" marR="73152" marT="27432" marB="27432" anchor="t">
+                    <a:solidFill>
+                      <a:srgbClr val="FFFFFF"/>
+                    </a:solidFill>
+                    <a:lnL w="6350" cap="flat" cmpd="sng" algn="ctr">
+                      <a:solidFill>
+                        <a:srgbClr val="E2E6E3"/>
+                      </a:solidFill>
+                      <a:prstDash val="solid"/>
+                    </a:lnL>
+                    <a:lnR w="6350" cap="flat" cmpd="sng" algn="ctr">
+                      <a:solidFill>
+                        <a:srgbClr val="E2E6E3"/>
+                      </a:solidFill>
+                      <a:prstDash val="solid"/>
+                    </a:lnR>
+                    <a:lnT w="6350" cap="flat" cmpd="sng" algn="ctr">
+                      <a:solidFill>
+                        <a:srgbClr val="E2E6E3"/>
+                      </a:solidFill>
+                      <a:prstDash val="solid"/>
+                    </a:lnT>
+                    <a:lnB w="6350" cap="flat" cmpd="sng" algn="ctr">
+                      <a:solidFill>
+                        <a:srgbClr val="E2E6E3"/>
+                      </a:solidFill>
+                      <a:prstDash val="solid"/>
+                    </a:lnB>
+                  </a:tcPr>
+                </a:tc>
+                <a:tc>
+                  <a:txBody>
+                    <a:bodyPr/>
+                    <a:lstStyle/>
+                    <a:p>
+                      <a:r>
+                        <a:rPr sz="1000" b="0">
+                          <a:solidFill>
+                            <a:srgbClr val="5B6670"/>
+                          </a:solidFill>
+                          <a:latin typeface="Arial"/>
+                        </a:rPr>
+                        <a:t/>
+                      </a:r>
+                    </a:p>
+                  </a:txBody>
+                  <a:tcPr marL="73152" marR="73152" marT="27432" marB="27432" anchor="t">
+                    <a:solidFill>
+                      <a:srgbClr val="FFFFFF"/>
+                    </a:solidFill>
+                    <a:lnL w="6350" cap="flat" cmpd="sng" algn="ctr">
+                      <a:solidFill>
+                        <a:srgbClr val="E2E6E3"/>
+                      </a:solidFill>
+                      <a:prstDash val="solid"/>
+                    </a:lnL>
+                    <a:lnR w="6350" cap="flat" cmpd="sng" algn="ctr">
+                      <a:solidFill>
+                        <a:srgbClr val="E2E6E3"/>
+                      </a:solidFill>
+                      <a:prstDash val="solid"/>
+                    </a:lnR>
+                    <a:lnT w="6350" cap="flat" cmpd="sng" algn="ctr">
+                      <a:solidFill>
+                        <a:srgbClr val="E2E6E3"/>
+                      </a:solidFill>
+                      <a:prstDash val="solid"/>
+                    </a:lnT>
+                    <a:lnB w="6350" cap="flat" cmpd="sng" algn="ctr">
+                      <a:solidFill>
+                        <a:srgbClr val="E2E6E3"/>
+                      </a:solidFill>
+                      <a:prstDash val="solid"/>
+                    </a:lnB>
+                  </a:tcPr>
+                </a:tc>
+                <a:tc>
+                  <a:txBody>
+                    <a:bodyPr/>
+                    <a:lstStyle/>
+                    <a:p>
+                      <a:r>
+                        <a:rPr sz="1000" b="0">
+                          <a:solidFill>
+                            <a:srgbClr val="5B6670"/>
+                          </a:solidFill>
+                          <a:latin typeface="Arial"/>
+                        </a:rPr>
+                        <a:t/>
+                      </a:r>
+                    </a:p>
+                  </a:txBody>
+                  <a:tcPr marL="73152" marR="73152" marT="27432" marB="27432" anchor="t">
+                    <a:solidFill>
+                      <a:srgbClr val="FFFFFF"/>
+                    </a:solidFill>
+                    <a:lnL w="6350" cap="flat" cmpd="sng" algn="ctr">
+                      <a:solidFill>
+                        <a:srgbClr val="E2E6E3"/>
+                      </a:solidFill>
+                      <a:prstDash val="solid"/>
+                    </a:lnL>
+                    <a:lnR w="6350" cap="flat" cmpd="sng" algn="ctr">
+                      <a:solidFill>
+                        <a:srgbClr val="E2E6E3"/>
+                      </a:solidFill>
+                      <a:prstDash val="solid"/>
+                    </a:lnR>
+                    <a:lnT w="6350" cap="flat" cmpd="sng" algn="ctr">
+                      <a:solidFill>
+                        <a:srgbClr val="E2E6E3"/>
+                      </a:solidFill>
+                      <a:prstDash val="solid"/>
+                    </a:lnT>
+                    <a:lnB w="6350" cap="flat" cmpd="sng" algn="ctr">
+                      <a:solidFill>
+                        <a:srgbClr val="E2E6E3"/>
+                      </a:solidFill>
+                      <a:prstDash val="solid"/>
+                    </a:lnB>
+                  </a:tcPr>
+                </a:tc>
+              </a:tr>
+              <a:tr h="265176">
+                <a:tc>
+                  <a:txBody>
+                    <a:bodyPr/>
+                    <a:lstStyle/>
+                    <a:p>
+                      <a:r>
+                        <a:rPr sz="1000" b="1">
+                          <a:solidFill>
+                            <a:srgbClr val="15181A"/>
+                          </a:solidFill>
+                          <a:latin typeface="Arial"/>
+                        </a:rPr>
+                        <a:t>Q1 2026</a:t>
+                      </a:r>
+                    </a:p>
+                  </a:txBody>
+                  <a:tcPr marL="73152" marR="73152" marT="27432" marB="27432" anchor="t">
+                    <a:solidFill>
+                      <a:srgbClr val="FFFFFF"/>
+                    </a:solidFill>
+                    <a:lnL w="6350" cap="flat" cmpd="sng" algn="ctr">
+                      <a:solidFill>
+                        <a:srgbClr val="E2E6E3"/>
+                      </a:solidFill>
+                      <a:prstDash val="solid"/>
+                    </a:lnL>
+                    <a:lnR w="6350" cap="flat" cmpd="sng" algn="ctr">
+                      <a:solidFill>
+                        <a:srgbClr val="E2E6E3"/>
+                      </a:solidFill>
+                      <a:prstDash val="solid"/>
+                    </a:lnR>
+                    <a:lnT w="6350" cap="flat" cmpd="sng" algn="ctr">
+                      <a:solidFill>
+                        <a:srgbClr val="E2E6E3"/>
+                      </a:solidFill>
+                      <a:prstDash val="solid"/>
+                    </a:lnT>
+                    <a:lnB w="6350" cap="flat" cmpd="sng" algn="ctr">
+                      <a:solidFill>
+                        <a:srgbClr val="E2E6E3"/>
+                      </a:solidFill>
+                      <a:prstDash val="solid"/>
+                    </a:lnB>
+                  </a:tcPr>
+                </a:tc>
+                <a:tc>
+                  <a:txBody>
+                    <a:bodyPr/>
+                    <a:lstStyle/>
+                    <a:p>
+                      <a:r>
+                        <a:rPr sz="1000" b="0">
+                          <a:solidFill>
+                            <a:srgbClr val="5B6670"/>
+                          </a:solidFill>
+                          <a:latin typeface="Arial"/>
+                        </a:rPr>
+                        <a:t/>
+                      </a:r>
+                    </a:p>
+                  </a:txBody>
+                  <a:tcPr marL="73152" marR="73152" marT="27432" marB="27432" anchor="t">
+                    <a:solidFill>
+                      <a:srgbClr val="FFFFFF"/>
+                    </a:solidFill>
+                    <a:lnL w="6350" cap="flat" cmpd="sng" algn="ctr">
+                      <a:solidFill>
+                        <a:srgbClr val="E2E6E3"/>
+                      </a:solidFill>
+                      <a:prstDash val="solid"/>
+                    </a:lnL>
+                    <a:lnR w="6350" cap="flat" cmpd="sng" algn="ctr">
+                      <a:solidFill>
+                        <a:srgbClr val="E2E6E3"/>
+                      </a:solidFill>
+                      <a:prstDash val="solid"/>
+                    </a:lnR>
+                    <a:lnT w="6350" cap="flat" cmpd="sng" algn="ctr">
+                      <a:solidFill>
+                        <a:srgbClr val="E2E6E3"/>
+                      </a:solidFill>
+                      <a:prstDash val="solid"/>
+                    </a:lnT>
+                    <a:lnB w="6350" cap="flat" cmpd="sng" algn="ctr">
+                      <a:solidFill>
+                        <a:srgbClr val="E2E6E3"/>
+                      </a:solidFill>
+                      <a:prstDash val="solid"/>
+                    </a:lnB>
+                  </a:tcPr>
+                </a:tc>
+                <a:tc>
+                  <a:txBody>
+                    <a:bodyPr/>
+                    <a:lstStyle/>
+                    <a:p>
+                      <a:r>
+                        <a:rPr sz="1000" b="0">
+                          <a:solidFill>
+                            <a:srgbClr val="5B6670"/>
+                          </a:solidFill>
+                          <a:latin typeface="Arial"/>
+                        </a:rPr>
+                        <a:t/>
+                      </a:r>
+                    </a:p>
+                  </a:txBody>
+                  <a:tcPr marL="73152" marR="73152" marT="27432" marB="27432" anchor="t">
+                    <a:solidFill>
+                      <a:srgbClr val="FFFFFF"/>
+                    </a:solidFill>
+                    <a:lnL w="6350" cap="flat" cmpd="sng" algn="ctr">
+                      <a:solidFill>
+                        <a:srgbClr val="E2E6E3"/>
+                      </a:solidFill>
+                      <a:prstDash val="solid"/>
+                    </a:lnL>
+                    <a:lnR w="6350" cap="flat" cmpd="sng" algn="ctr">
+                      <a:solidFill>
+                        <a:srgbClr val="E2E6E3"/>
+                      </a:solidFill>
+                      <a:prstDash val="solid"/>
+                    </a:lnR>
+                    <a:lnT w="6350" cap="flat" cmpd="sng" algn="ctr">
+                      <a:solidFill>
+                        <a:srgbClr val="E2E6E3"/>
+                      </a:solidFill>
+                      <a:prstDash val="solid"/>
+                    </a:lnT>
+                    <a:lnB w="6350" cap="flat" cmpd="sng" algn="ctr">
+                      <a:solidFill>
+                        <a:srgbClr val="E2E6E3"/>
+                      </a:solidFill>
+                      <a:prstDash val="solid"/>
+                    </a:lnB>
+                  </a:tcPr>
+                </a:tc>
+                <a:tc>
+                  <a:txBody>
+                    <a:bodyPr/>
+                    <a:lstStyle/>
+                    <a:p>
+                      <a:r>
+                        <a:rPr sz="1000" b="0">
+                          <a:solidFill>
+                            <a:srgbClr val="5B6670"/>
+                          </a:solidFill>
+                          <a:latin typeface="Arial"/>
+                        </a:rPr>
+                        <a:t/>
+                      </a:r>
+                    </a:p>
+                  </a:txBody>
+                  <a:tcPr marL="73152" marR="73152" marT="27432" marB="27432" anchor="t">
+                    <a:solidFill>
+                      <a:srgbClr val="FFFFFF"/>
+                    </a:solidFill>
+                    <a:lnL w="6350" cap="flat" cmpd="sng" algn="ctr">
+                      <a:solidFill>
+                        <a:srgbClr val="E2E6E3"/>
+                      </a:solidFill>
+                      <a:prstDash val="solid"/>
+                    </a:lnL>
+                    <a:lnR w="6350" cap="flat" cmpd="sng" algn="ctr">
+                      <a:solidFill>
+                        <a:srgbClr val="E2E6E3"/>
+                      </a:solidFill>
+                      <a:prstDash val="solid"/>
+                    </a:lnR>
+                    <a:lnT w="6350" cap="flat" cmpd="sng" algn="ctr">
+                      <a:solidFill>
+                        <a:srgbClr val="E2E6E3"/>
+                      </a:solidFill>
+                      <a:prstDash val="solid"/>
+                    </a:lnT>
+                    <a:lnB w="6350" cap="flat" cmpd="sng" algn="ctr">
+                      <a:solidFill>
+                        <a:srgbClr val="E2E6E3"/>
+                      </a:solidFill>
+                      <a:prstDash val="solid"/>
+                    </a:lnB>
+                  </a:tcPr>
+                </a:tc>
+                <a:tc>
+                  <a:txBody>
+                    <a:bodyPr/>
+                    <a:lstStyle/>
+                    <a:p>
+                      <a:r>
+                        <a:rPr sz="1000" b="0">
+                          <a:solidFill>
+                            <a:srgbClr val="5B6670"/>
+                          </a:solidFill>
+                          <a:latin typeface="Arial"/>
+                        </a:rPr>
+                        <a:t/>
+                      </a:r>
+                    </a:p>
+                  </a:txBody>
+                  <a:tcPr marL="73152" marR="73152" marT="27432" marB="27432" anchor="t">
+                    <a:solidFill>
+                      <a:srgbClr val="FFFFFF"/>
+                    </a:solidFill>
+                    <a:lnL w="6350" cap="flat" cmpd="sng" algn="ctr">
+                      <a:solidFill>
+                        <a:srgbClr val="E2E6E3"/>
+                      </a:solidFill>
+                      <a:prstDash val="solid"/>
+                    </a:lnL>
+                    <a:lnR w="6350" cap="flat" cmpd="sng" algn="ctr">
+                      <a:solidFill>
+                        <a:srgbClr val="E2E6E3"/>
+                      </a:solidFill>
+                      <a:prstDash val="solid"/>
+                    </a:lnR>
+                    <a:lnT w="6350" cap="flat" cmpd="sng" algn="ctr">
+                      <a:solidFill>
+                        <a:srgbClr val="E2E6E3"/>
+                      </a:solidFill>
+                      <a:prstDash val="solid"/>
+                    </a:lnT>
+                    <a:lnB w="6350" cap="flat" cmpd="sng" algn="ctr">
+                      <a:solidFill>
+                        <a:srgbClr val="E2E6E3"/>
+                      </a:solidFill>
+                      <a:prstDash val="solid"/>
+                    </a:lnB>
+                  </a:tcPr>
+                </a:tc>
+              </a:tr>
+              <a:tr h="265176">
+                <a:tc>
+                  <a:txBody>
+                    <a:bodyPr/>
+                    <a:lstStyle/>
+                    <a:p>
+                      <a:r>
+                        <a:rPr sz="1000" b="1">
+                          <a:solidFill>
+                            <a:srgbClr val="15181A"/>
+                          </a:solidFill>
+                          <a:latin typeface="Arial"/>
+                        </a:rPr>
+                        <a:t>Q2 2026</a:t>
+                      </a:r>
+                    </a:p>
+                  </a:txBody>
+                  <a:tcPr marL="73152" marR="73152" marT="27432" marB="27432" anchor="t">
+                    <a:solidFill>
+                      <a:srgbClr val="FFFFFF"/>
+                    </a:solidFill>
+                    <a:lnL w="6350" cap="flat" cmpd="sng" algn="ctr">
+                      <a:solidFill>
+                        <a:srgbClr val="E2E6E3"/>
+                      </a:solidFill>
+                      <a:prstDash val="solid"/>
+                    </a:lnL>
+                    <a:lnR w="6350" cap="flat" cmpd="sng" algn="ctr">
+                      <a:solidFill>
+                        <a:srgbClr val="E2E6E3"/>
+                      </a:solidFill>
+                      <a:prstDash val="solid"/>
+                    </a:lnR>
+                    <a:lnT w="6350" cap="flat" cmpd="sng" algn="ctr">
+                      <a:solidFill>
+                        <a:srgbClr val="E2E6E3"/>
+                      </a:solidFill>
+                      <a:prstDash val="solid"/>
+                    </a:lnT>
+                    <a:lnB w="6350" cap="flat" cmpd="sng" algn="ctr">
+                      <a:solidFill>
+                        <a:srgbClr val="E2E6E3"/>
+                      </a:solidFill>
+                      <a:prstDash val="solid"/>
+                    </a:lnB>
+                  </a:tcPr>
+                </a:tc>
+                <a:tc>
+                  <a:txBody>
+                    <a:bodyPr/>
+                    <a:lstStyle/>
+                    <a:p>
+                      <a:r>
+                        <a:rPr sz="1000" b="0">
+                          <a:solidFill>
+                            <a:srgbClr val="5B6670"/>
+                          </a:solidFill>
+                          <a:latin typeface="Arial"/>
+                        </a:rPr>
+                        <a:t/>
+                      </a:r>
+                    </a:p>
+                  </a:txBody>
+                  <a:tcPr marL="73152" marR="73152" marT="27432" marB="27432" anchor="t">
+                    <a:solidFill>
+                      <a:srgbClr val="FFFFFF"/>
+                    </a:solidFill>
+                    <a:lnL w="6350" cap="flat" cmpd="sng" algn="ctr">
+                      <a:solidFill>
+                        <a:srgbClr val="E2E6E3"/>
+                      </a:solidFill>
+                      <a:prstDash val="solid"/>
+                    </a:lnL>
+                    <a:lnR w="6350" cap="flat" cmpd="sng" algn="ctr">
+                      <a:solidFill>
+                        <a:srgbClr val="E2E6E3"/>
+                      </a:solidFill>
+                      <a:prstDash val="solid"/>
+                    </a:lnR>
+                    <a:lnT w="6350" cap="flat" cmpd="sng" algn="ctr">
+                      <a:solidFill>
+                        <a:srgbClr val="E2E6E3"/>
+                      </a:solidFill>
+                      <a:prstDash val="solid"/>
+                    </a:lnT>
+                    <a:lnB w="6350" cap="flat" cmpd="sng" algn="ctr">
+                      <a:solidFill>
+                        <a:srgbClr val="E2E6E3"/>
+                      </a:solidFill>
+                      <a:prstDash val="solid"/>
+                    </a:lnB>
+                  </a:tcPr>
+                </a:tc>
+                <a:tc>
+                  <a:txBody>
+                    <a:bodyPr/>
+                    <a:lstStyle/>
+                    <a:p>
+                      <a:r>
+                        <a:rPr sz="1000" b="0">
+                          <a:solidFill>
+                            <a:srgbClr val="5B6670"/>
+                          </a:solidFill>
+                          <a:latin typeface="Arial"/>
+                        </a:rPr>
+                        <a:t/>
+                      </a:r>
+                    </a:p>
+                  </a:txBody>
+                  <a:tcPr marL="73152" marR="73152" marT="27432" marB="27432" anchor="t">
+                    <a:solidFill>
+                      <a:srgbClr val="FFFFFF"/>
+                    </a:solidFill>
+                    <a:lnL w="6350" cap="flat" cmpd="sng" algn="ctr">
+                      <a:solidFill>
+                        <a:srgbClr val="E2E6E3"/>
+                      </a:solidFill>
+                      <a:prstDash val="solid"/>
+                    </a:lnL>
+                    <a:lnR w="6350" cap="flat" cmpd="sng" algn="ctr">
+                      <a:solidFill>
+                        <a:srgbClr val="E2E6E3"/>
+                      </a:solidFill>
+                      <a:prstDash val="solid"/>
+                    </a:lnR>
+                    <a:lnT w="6350" cap="flat" cmpd="sng" algn="ctr">
+                      <a:solidFill>
+                        <a:srgbClr val="E2E6E3"/>
+                      </a:solidFill>
+                      <a:prstDash val="solid"/>
+                    </a:lnT>
+                    <a:lnB w="6350" cap="flat" cmpd="sng" algn="ctr">
+                      <a:solidFill>
+                        <a:srgbClr val="E2E6E3"/>
+                      </a:solidFill>
+                      <a:prstDash val="solid"/>
+                    </a:lnB>
+                  </a:tcPr>
+                </a:tc>
+                <a:tc>
+                  <a:txBody>
+                    <a:bodyPr/>
+                    <a:lstStyle/>
+                    <a:p>
+                      <a:r>
+                        <a:rPr sz="1000" b="0">
+                          <a:solidFill>
+                            <a:srgbClr val="5B6670"/>
+                          </a:solidFill>
+                          <a:latin typeface="Arial"/>
+                        </a:rPr>
+                        <a:t/>
+                      </a:r>
+                    </a:p>
+                  </a:txBody>
+                  <a:tcPr marL="73152" marR="73152" marT="27432" marB="27432" anchor="t">
+                    <a:solidFill>
+                      <a:srgbClr val="FFFFFF"/>
+                    </a:solidFill>
+                    <a:lnL w="6350" cap="flat" cmpd="sng" algn="ctr">
+                      <a:solidFill>
+                        <a:srgbClr val="E2E6E3"/>
+                      </a:solidFill>
+                      <a:prstDash val="solid"/>
+                    </a:lnL>
+                    <a:lnR w="6350" cap="flat" cmpd="sng" algn="ctr">
+                      <a:solidFill>
+                        <a:srgbClr val="E2E6E3"/>
+                      </a:solidFill>
+                      <a:prstDash val="solid"/>
+                    </a:lnR>
+                    <a:lnT w="6350" cap="flat" cmpd="sng" algn="ctr">
+                      <a:solidFill>
+                        <a:srgbClr val="E2E6E3"/>
+                      </a:solidFill>
+                      <a:prstDash val="solid"/>
+                    </a:lnT>
+                    <a:lnB w="6350" cap="flat" cmpd="sng" algn="ctr">
+                      <a:solidFill>
+                        <a:srgbClr val="E2E6E3"/>
+                      </a:solidFill>
+                      <a:prstDash val="solid"/>
+                    </a:lnB>
+                  </a:tcPr>
+                </a:tc>
+                <a:tc>
+                  <a:txBody>
+                    <a:bodyPr/>
+                    <a:lstStyle/>
+                    <a:p>
+                      <a:r>
+                        <a:rPr sz="1000" b="0">
+                          <a:solidFill>
+                            <a:srgbClr val="5B6670"/>
+                          </a:solidFill>
+                          <a:latin typeface="Arial"/>
+                        </a:rPr>
+                        <a:t/>
+                      </a:r>
+                    </a:p>
+                  </a:txBody>
+                  <a:tcPr marL="73152" marR="73152" marT="27432" marB="27432" anchor="t">
+                    <a:solidFill>
+                      <a:srgbClr val="FFFFFF"/>
+                    </a:solidFill>
+                    <a:lnL w="6350" cap="flat" cmpd="sng" algn="ctr">
+                      <a:solidFill>
+                        <a:srgbClr val="E2E6E3"/>
+                      </a:solidFill>
+                      <a:prstDash val="solid"/>
+                    </a:lnL>
+                    <a:lnR w="6350" cap="flat" cmpd="sng" algn="ctr">
+                      <a:solidFill>
+                        <a:srgbClr val="E2E6E3"/>
+                      </a:solidFill>
+                      <a:prstDash val="solid"/>
+                    </a:lnR>
+                    <a:lnT w="6350" cap="flat" cmpd="sng" algn="ctr">
+                      <a:solidFill>
+                        <a:srgbClr val="E2E6E3"/>
+                      </a:solidFill>
+                      <a:prstDash val="solid"/>
+                    </a:lnT>
+                    <a:lnB w="6350" cap="flat" cmpd="sng" algn="ctr">
+                      <a:solidFill>
+                        <a:srgbClr val="E2E6E3"/>
+                      </a:solidFill>
+                      <a:prstDash val="solid"/>
+                    </a:lnB>
+                  </a:tcPr>
+                </a:tc>
+              </a:tr>
+              <a:tr h="265176">
+                <a:tc>
+                  <a:txBody>
+                    <a:bodyPr/>
+                    <a:lstStyle/>
+                    <a:p>
+                      <a:r>
+                        <a:rPr sz="1000" b="1">
+                          <a:solidFill>
+                            <a:srgbClr val="15181A"/>
+                          </a:solidFill>
+                          <a:latin typeface="Arial"/>
+                        </a:rPr>
+                        <a:t>Q3 2026</a:t>
+                      </a:r>
+                    </a:p>
+                  </a:txBody>
+                  <a:tcPr marL="73152" marR="73152" marT="27432" marB="27432" anchor="t">
+                    <a:solidFill>
+                      <a:srgbClr val="FFFFFF"/>
+                    </a:solidFill>
+                    <a:lnL w="6350" cap="flat" cmpd="sng" algn="ctr">
+                      <a:solidFill>
+                        <a:srgbClr val="E2E6E3"/>
+                      </a:solidFill>
+                      <a:prstDash val="solid"/>
+                    </a:lnL>
+                    <a:lnR w="6350" cap="flat" cmpd="sng" algn="ctr">
+                      <a:solidFill>
+                        <a:srgbClr val="E2E6E3"/>
+                      </a:solidFill>
+                      <a:prstDash val="solid"/>
+                    </a:lnR>
+                    <a:lnT w="6350" cap="flat" cmpd="sng" algn="ctr">
+                      <a:solidFill>
+                        <a:srgbClr val="E2E6E3"/>
+                      </a:solidFill>
+                      <a:prstDash val="solid"/>
+                    </a:lnT>
+                    <a:lnB w="6350" cap="flat" cmpd="sng" algn="ctr">
+                      <a:solidFill>
+                        <a:srgbClr val="E2E6E3"/>
+                      </a:solidFill>
+                      <a:prstDash val="solid"/>
+                    </a:lnB>
+                  </a:tcPr>
+                </a:tc>
+                <a:tc>
+                  <a:txBody>
+                    <a:bodyPr/>
+                    <a:lstStyle/>
+                    <a:p>
+                      <a:r>
+                        <a:rPr sz="1000" b="0">
+                          <a:solidFill>
+                            <a:srgbClr val="5B6670"/>
+                          </a:solidFill>
+                          <a:latin typeface="Arial"/>
+                        </a:rPr>
+                        <a:t/>
+                      </a:r>
+                    </a:p>
+                  </a:txBody>
+                  <a:tcPr marL="73152" marR="73152" marT="27432" marB="27432" anchor="t">
+                    <a:solidFill>
+                      <a:srgbClr val="FFFFFF"/>
+                    </a:solidFill>
+                    <a:lnL w="6350" cap="flat" cmpd="sng" algn="ctr">
+                      <a:solidFill>
+                        <a:srgbClr val="E2E6E3"/>
+                      </a:solidFill>
+                      <a:prstDash val="solid"/>
+                    </a:lnL>
+                    <a:lnR w="6350" cap="flat" cmpd="sng" algn="ctr">
+                      <a:solidFill>
+                        <a:srgbClr val="E2E6E3"/>
+                      </a:solidFill>
+                      <a:prstDash val="solid"/>
+                    </a:lnR>
+                    <a:lnT w="6350" cap="flat" cmpd="sng" algn="ctr">
+                      <a:solidFill>
+                        <a:srgbClr val="E2E6E3"/>
+                      </a:solidFill>
+                      <a:prstDash val="solid"/>
+                    </a:lnT>
+                    <a:lnB w="6350" cap="flat" cmpd="sng" algn="ctr">
+                      <a:solidFill>
+                        <a:srgbClr val="E2E6E3"/>
+                      </a:solidFill>
+                      <a:prstDash val="solid"/>
+                    </a:lnB>
+                  </a:tcPr>
+                </a:tc>
+                <a:tc>
+                  <a:txBody>
+                    <a:bodyPr/>
+                    <a:lstStyle/>
+                    <a:p>
+                      <a:r>
+                        <a:rPr sz="1000" b="0">
+                          <a:solidFill>
+                            <a:srgbClr val="5B6670"/>
+                          </a:solidFill>
+                          <a:latin typeface="Arial"/>
+                        </a:rPr>
+                        <a:t/>
+                      </a:r>
+                    </a:p>
+                  </a:txBody>
+                  <a:tcPr marL="73152" marR="73152" marT="27432" marB="27432" anchor="t">
+                    <a:solidFill>
+                      <a:srgbClr val="FFFFFF"/>
+                    </a:solidFill>
+                    <a:lnL w="6350" cap="flat" cmpd="sng" algn="ctr">
+                      <a:solidFill>
+                        <a:srgbClr val="E2E6E3"/>
+                      </a:solidFill>
+                      <a:prstDash val="solid"/>
+                    </a:lnL>
+                    <a:lnR w="6350" cap="flat" cmpd="sng" algn="ctr">
+                      <a:solidFill>
+                        <a:srgbClr val="E2E6E3"/>
+                      </a:solidFill>
+                      <a:prstDash val="solid"/>
+                    </a:lnR>
+                    <a:lnT w="6350" cap="flat" cmpd="sng" algn="ctr">
+                      <a:solidFill>
+                        <a:srgbClr val="E2E6E3"/>
+                      </a:solidFill>
+                      <a:prstDash val="solid"/>
+                    </a:lnT>
+                    <a:lnB w="6350" cap="flat" cmpd="sng" algn="ctr">
+                      <a:solidFill>
+                        <a:srgbClr val="E2E6E3"/>
+                      </a:solidFill>
+                      <a:prstDash val="solid"/>
+                    </a:lnB>
+                  </a:tcPr>
+                </a:tc>
+                <a:tc>
+                  <a:txBody>
+                    <a:bodyPr/>
+                    <a:lstStyle/>
+                    <a:p>
+                      <a:r>
+                        <a:rPr sz="1000" b="0">
+                          <a:solidFill>
+                            <a:srgbClr val="5B6670"/>
+                          </a:solidFill>
+                          <a:latin typeface="Arial"/>
+                        </a:rPr>
+                        <a:t/>
+                      </a:r>
+                    </a:p>
+                  </a:txBody>
+                  <a:tcPr marL="73152" marR="73152" marT="27432" marB="27432" anchor="t">
+                    <a:solidFill>
+                      <a:srgbClr val="FFFFFF"/>
+                    </a:solidFill>
+                    <a:lnL w="6350" cap="flat" cmpd="sng" algn="ctr">
+                      <a:solidFill>
+                        <a:srgbClr val="E2E6E3"/>
+                      </a:solidFill>
+                      <a:prstDash val="solid"/>
+                    </a:lnL>
+                    <a:lnR w="6350" cap="flat" cmpd="sng" algn="ctr">
+                      <a:solidFill>
+                        <a:srgbClr val="E2E6E3"/>
+                      </a:solidFill>
+                      <a:prstDash val="solid"/>
+                    </a:lnR>
+                    <a:lnT w="6350" cap="flat" cmpd="sng" algn="ctr">
+                      <a:solidFill>
+                        <a:srgbClr val="E2E6E3"/>
+                      </a:solidFill>
+                      <a:prstDash val="solid"/>
+                    </a:lnT>
+                    <a:lnB w="6350" cap="flat" cmpd="sng" algn="ctr">
+                      <a:solidFill>
+                        <a:srgbClr val="E2E6E3"/>
+                      </a:solidFill>
+                      <a:prstDash val="solid"/>
+                    </a:lnB>
+                  </a:tcPr>
+                </a:tc>
+                <a:tc>
+                  <a:txBody>
+                    <a:bodyPr/>
+                    <a:lstStyle/>
+                    <a:p>
+                      <a:r>
+                        <a:rPr sz="1000" b="0">
+                          <a:solidFill>
+                            <a:srgbClr val="5B6670"/>
+                          </a:solidFill>
+                          <a:latin typeface="Arial"/>
+                        </a:rPr>
+                        <a:t/>
+                      </a:r>
+                    </a:p>
+                  </a:txBody>
+                  <a:tcPr marL="73152" marR="73152" marT="27432" marB="27432" anchor="t">
+                    <a:solidFill>
+                      <a:srgbClr val="FFFFFF"/>
+                    </a:solidFill>
+                    <a:lnL w="6350" cap="flat" cmpd="sng" algn="ctr">
+                      <a:solidFill>
+                        <a:srgbClr val="E2E6E3"/>
+                      </a:solidFill>
+                      <a:prstDash val="solid"/>
+                    </a:lnL>
+                    <a:lnR w="6350" cap="flat" cmpd="sng" algn="ctr">
+                      <a:solidFill>
+                        <a:srgbClr val="E2E6E3"/>
+                      </a:solidFill>
+                      <a:prstDash val="solid"/>
+                    </a:lnR>
+                    <a:lnT w="6350" cap="flat" cmpd="sng" algn="ctr">
+                      <a:solidFill>
+                        <a:srgbClr val="E2E6E3"/>
+                      </a:solidFill>
+                      <a:prstDash val="solid"/>
+                    </a:lnT>
+                    <a:lnB w="6350" cap="flat" cmpd="sng" algn="ctr">
+                      <a:solidFill>
+                        <a:srgbClr val="E2E6E3"/>
+                      </a:solidFill>
+                      <a:prstDash val="solid"/>
+                    </a:lnB>
+                  </a:tcPr>
+                </a:tc>
+              </a:tr>
+            </a:tbl>
           </a:graphicData>
         </a:graphic>
       </p:graphicFrame>
@@ -10063,7 +10935,7 @@
         </p:nvSpPr>
         <p:spPr>
           <a:xfrm>
-            <a:off x="731520" y="4315968"/>
+            <a:off x="731520" y="3931920"/>
             <a:ext cx="5120640" cy="237744"/>
           </a:xfrm>
           <a:prstGeom prst="rect">
@@ -10097,8 +10969,8 @@
         </p:nvSpPr>
         <p:spPr>
           <a:xfrm>
-            <a:off x="731520" y="4572000"/>
-            <a:ext cx="5120640" cy="1463040"/>
+            <a:off x="731520" y="4187952"/>
+            <a:ext cx="5120640" cy="1847088"/>
           </a:xfrm>
           <a:prstGeom prst="rect">
             <a:avLst/>
@@ -12497,32 +13369,38 @@
           <a:lstStyle/>
           <a:p>
             <a:r>
-              <a:t>Job: [dealer, account, job name]</a:t>
-            </a:r>
-          </a:p>
-          <a:p>
-            <a:r>
+              <a:rPr sz="1400"/>
+              <a:t>Job: [dealer, account, job]</a:t>
+            </a:r>
+          </a:p>
+          <a:p>
+            <a:r>
+              <a:rPr sz="1400"/>
               <a:t>Who won: [competitor]</a:t>
             </a:r>
           </a:p>
           <a:p>
             <a:r>
-              <a:t>Their number: [$ or unknown]</a:t>
-            </a:r>
-          </a:p>
-          <a:p>
-            <a:r>
-              <a:t>Our number: [$]</a:t>
-            </a:r>
-          </a:p>
-          <a:p>
-            <a:r>
+              <a:rPr sz="1400"/>
+              <a:t>Their price: [$ or unknown]</a:t>
+            </a:r>
+          </a:p>
+          <a:p>
+            <a:r>
+              <a:rPr sz="1400"/>
+              <a:t>Lead time: ours / theirs [wks]</a:t>
+            </a:r>
+          </a:p>
+          <a:p>
+            <a:r>
+              <a:rPr sz="1400"/>
               <a:t>Why: [ ]</a:t>
             </a:r>
           </a:p>
           <a:p>
             <a:r>
-              <a:t>Lose it again today: [yes or no]</a:t>
+              <a:rPr sz="1400"/>
+              <a:t>Lose it again today: [yes/no]</a:t>
             </a:r>
           </a:p>
         </p:txBody>
@@ -12564,26 +13442,37 @@
           <a:lstStyle/>
           <a:p>
             <a:r>
-              <a:t>Job: [dealer, account, job name]</a:t>
-            </a:r>
-          </a:p>
-          <a:p>
-            <a:r>
+              <a:rPr sz="1400"/>
+              <a:t>Job: [dealer, account, job]</a:t>
+            </a:r>
+          </a:p>
+          <a:p>
+            <a:r>
+              <a:rPr sz="1400"/>
               <a:t>Who won: [competitor]</a:t>
             </a:r>
           </a:p>
           <a:p>
             <a:r>
-              <a:t>Why: [what they had that we didn't]</a:t>
-            </a:r>
-          </a:p>
-          <a:p>
-            <a:r>
-              <a:t>Lose it again today: [yes or no]</a:t>
-            </a:r>
-          </a:p>
-          <a:p>
-            <a:r>
+              <a:rPr sz="1400"/>
+              <a:t>Why: [what they had, we didn't]</a:t>
+            </a:r>
+          </a:p>
+          <a:p>
+            <a:r>
+              <a:rPr sz="1400"/>
+              <a:t>Lead time: ours / theirs [wks]</a:t>
+            </a:r>
+          </a:p>
+          <a:p>
+            <a:r>
+              <a:rPr sz="1400"/>
+              <a:t>Lose it again today: [yes/no]</a:t>
+            </a:r>
+          </a:p>
+          <a:p>
+            <a:r>
+              <a:rPr sz="1400"/>
               <a:t>No product loss? Say so here.</a:t>
             </a:r>
           </a:p>
@@ -12626,26 +13515,37 @@
           <a:lstStyle/>
           <a:p>
             <a:r>
-              <a:t>Job: [dealer, account, job name]</a:t>
-            </a:r>
-          </a:p>
-          <a:p>
-            <a:r>
+              <a:rPr sz="1400"/>
+              <a:t>Job: [dealer, account, job]</a:t>
+            </a:r>
+          </a:p>
+          <a:p>
+            <a:r>
+              <a:rPr sz="1400"/>
               <a:t>Who won: [competitor]</a:t>
             </a:r>
           </a:p>
           <a:p>
             <a:r>
-              <a:t>Why: [lead time, quoting, service]</a:t>
-            </a:r>
-          </a:p>
-          <a:p>
-            <a:r>
-              <a:t>Lose it again today: [yes or no]</a:t>
-            </a:r>
-          </a:p>
-          <a:p>
-            <a:r>
+              <a:rPr sz="1400"/>
+              <a:t>Lead time: ours / theirs [wks]</a:t>
+            </a:r>
+          </a:p>
+          <a:p>
+            <a:r>
+              <a:rPr sz="1400"/>
+              <a:t>Why: [quoting or service]</a:t>
+            </a:r>
+          </a:p>
+          <a:p>
+            <a:r>
+              <a:rPr sz="1400"/>
+              <a:t>Lose it again today: [yes/no]</a:t>
+            </a:r>
+          </a:p>
+          <a:p>
+            <a:r>
+              <a:rPr sz="1400"/>
               <a:t>No speed loss? Say so here.</a:t>
             </a:r>
           </a:p>

</xml_diff>

<commit_message>
Territory review: seven-slide structure, opener deck, and audit
Add dealer scorecard and dealers-to-move slides, a two-slide opener for
Nate, Chad's share-of-wallet slide, Mac's inherited-accounts slide, and
the audit memo behind the structure.

Co-Authored-By: Claude Fable 5.1 <noreply@anthropic.com>
Claude-Session: https://claude.ai/code/session_01NccKroytcPyz54UophNQtq
</commit_message>
<xml_diff>
--- a/decks/territory-review/Territory Review Template - Market (Mac).pptx
+++ b/decks/territory-review/Territory Review Template - Market (Mac).pptx
@@ -12,6 +12,7 @@
     <p:sldId id="260" r:id="rId11"/>
     <p:sldId id="261" r:id="rId12"/>
     <p:sldId id="262" r:id="rId13"/>
+    <p:sldId id="263" r:id="rId14"/>
   </p:sldIdLst>
   <p:notesMasterIdLst>
     <p:notesMasterId r:id="rId17"/>
@@ -507,7 +508,7 @@
           <a:lstStyle/>
           <a:p>
             <a:r>
-              <a:t>Ten minutes. Six slides. Real dealer, account, and job names. No new data pulls.</a:t>
+              <a:t>Twelve minutes, hard stop, then questions. Seven slides. Real dealer, account, and job names. Slides 1 and 2 are pre-filled by Nate. You bring the story.</a:t>
             </a:r>
           </a:p>
         </p:txBody>
@@ -577,7 +578,7 @@
           <a:lstStyle/>
           <a:p>
             <a:r>
-              <a:t>Slide 1. Bookings and quotes by quarter, top accounts, Excalibur dealers. Pre-filled. Add a couple of sentences on what the numbers don't show.</a:t>
+              <a:t>Slide 1. Pre-filled. Bookings by quarter this year against last year, quote count, and the company lead time that quarter. Lead times were 30-plus weeks in the first half and have been back to 5 to 10 weeks since summer. Add a couple of sentences on what the numbers don't show.</a:t>
             </a:r>
           </a:p>
         </p:txBody>
@@ -717,7 +718,7 @@
           <a:lstStyle/>
           <a:p>
             <a:r>
-              <a:t>Slide 3. Three wins. One on price, one on product, one on speed and support. Why we won, and whether it's repeatable.</a:t>
+              <a:t>Slide 3 for Mac. The accounts that came over with the role. Numbers pre-filled, status and next move are yours.</a:t>
             </a:r>
           </a:p>
         </p:txBody>
@@ -787,7 +788,7 @@
           <a:lstStyle/>
           <a:p>
             <a:r>
-              <a:t>Slide 4. Three losses. One on price, one on product, one on speed and support. Who won, why, and whether we'd lose it again today. On the price loss, include the competitor's number if you have it. If you don't, say unknown. On every loss, the lead time we quoted and the lead time the winner delivered. If you don't have a loss in one of the three buckets, say so on the slide.</a:t>
+              <a:t>Slide 4. Three wins. One on price, one on product, one on speed and support. Why we won, and whether it's repeatable.</a:t>
             </a:r>
           </a:p>
         </p:txBody>
@@ -857,7 +858,7 @@
           <a:lstStyle/>
           <a:p>
             <a:r>
-              <a:t>Slide 5. What we do well and what we don't. One of each for the company, for marketing, and for sales direction. Nate: I mean that last one. I'd rather hear it in the room than not at all.</a:t>
+              <a:t>Slide 5. Three losses. One on price, one on product, one on speed and support. Who won, why, and whether we'd lose it again today. On the price loss, include the competitor's number if you have it. If you don't, say unknown. On every loss, the lead time we quoted and the lead time the winner delivered. If you don't have a loss in one of the three buckets, say so on the slide.</a:t>
             </a:r>
           </a:p>
         </p:txBody>
@@ -927,7 +928,77 @@
           <a:lstStyle/>
           <a:p>
             <a:r>
-              <a:t>Slide 6 for Mac. Where you'd focus us and what you need to get there.</a:t>
+              <a:t>Slide 6. What we do well and what we don't. One of each for the company, for marketing, and for sales direction. Nate: I mean that last one. I'd rather hear it in the room than not at all.</a:t>
+            </a:r>
+          </a:p>
+        </p:txBody>
+      </p:sp>
+      <p:sp>
+        <p:nvSpPr>
+          <p:cNvPr id="4" name="Slide Number Placeholder 3"/>
+          <p:cNvSpPr>
+            <a:spLocks noGrp="1"/>
+          </p:cNvSpPr>
+          <p:nvPr>
+            <p:ph type="sldNum" idx="5" sz="quarter"/>
+          </p:nvPr>
+        </p:nvSpPr>
+        <p:spPr/>
+      </p:sp>
+    </p:spTree>
+  </p:cSld>
+  <p:clrMapOvr>
+    <a:masterClrMapping/>
+  </p:clrMapOvr>
+</p:notes>
+</file>
+
+<file path=ppt/notesSlides/notesSlide8.xml><?xml version="1.0" encoding="utf-8"?>
+<p:notes xmlns:a="http://schemas.openxmlformats.org/drawingml/2006/main" xmlns:p="http://schemas.openxmlformats.org/presentationml/2006/main" xmlns:r="http://schemas.openxmlformats.org/officeDocument/2006/relationships">
+  <p:cSld>
+    <p:spTree>
+      <p:nvGrpSpPr>
+        <p:cNvPr id="1" name=""/>
+        <p:cNvGrpSpPr/>
+        <p:nvPr/>
+      </p:nvGrpSpPr>
+      <p:grpSpPr>
+        <a:xfrm>
+          <a:off x="0" y="0"/>
+          <a:ext cx="0" cy="0"/>
+          <a:chOff x="0" y="0"/>
+          <a:chExt cx="0" cy="0"/>
+        </a:xfrm>
+      </p:grpSpPr>
+      <p:sp>
+        <p:nvSpPr>
+          <p:cNvPr id="2" name="Slide Image Placeholder 1"/>
+          <p:cNvSpPr>
+            <a:spLocks noGrp="1"/>
+          </p:cNvSpPr>
+          <p:nvPr>
+            <p:ph type="sldImg" idx="2"/>
+          </p:nvPr>
+        </p:nvSpPr>
+        <p:spPr/>
+      </p:sp>
+      <p:sp>
+        <p:nvSpPr>
+          <p:cNvPr id="3" name="Notes Placeholder 2"/>
+          <p:cNvSpPr>
+            <a:spLocks noGrp="1"/>
+          </p:cNvSpPr>
+          <p:nvPr>
+            <p:ph type="body" idx="3" sz="quarter"/>
+          </p:nvPr>
+        </p:nvSpPr>
+        <p:spPr/>
+        <p:txBody>
+          <a:bodyPr/>
+          <a:lstStyle/>
+          <a:p>
+            <a:r>
+              <a:t>Slide 7 for Mac. Where you'd focus us and what you need to get there.</a:t>
             </a:r>
           </a:p>
         </p:txBody>
@@ -9638,7 +9709,7 @@
           <a:lstStyle/>
           <a:p>
             <a:r>
-              <a:t>TERRITORY REVIEW  ·  1 OF 6  ·  BY THE NUMBERS</a:t>
+              <a:t>TERRITORY REVIEW  ·  1 OF 7  ·  BY THE NUMBERS</a:t>
             </a:r>
           </a:p>
         </p:txBody>
@@ -9659,7 +9730,7 @@
           <a:lstStyle/>
           <a:p>
             <a:r>
-              <a:t>The market in numbers</a:t>
+              <a:t>National accounts in numbers</a:t>
             </a:r>
           </a:p>
         </p:txBody>
@@ -9701,7 +9772,7 @@
           <a:lstStyle/>
           <a:p>
             <a:r>
-              <a:t>Source: [system], pulled [date]. Hit rate is bookings divided by quotes. Lead time is the average we quoted that quarter.</a:t>
+              <a:t>Source: [system], pulled [date]. Quote count, not quote dollars. Lead time is the quoted lead time from the plant that quarter.</a:t>
             </a:r>
           </a:p>
         </p:txBody>
@@ -9715,7 +9786,7 @@
         <p:spPr>
           <a:xfrm>
             <a:off x="731520" y="2121408"/>
-            <a:ext cx="5120640" cy="237744"/>
+            <a:ext cx="10725912" cy="237744"/>
           </a:xfrm>
           <a:prstGeom prst="rect">
             <a:avLst/>
@@ -9735,7 +9806,7 @@
                 </a:solidFill>
                 <a:latin typeface="Arial"/>
               </a:rPr>
-              <a:t>BY QUARTER  ·  PRE-FILLED</a:t>
+              <a:t>BOOKINGS BY QUARTER, WITH THE COMPANY LEAD TIME THAT QUARTER  ·  PRE-FILLED</a:t>
             </a:r>
           </a:p>
         </p:txBody>
@@ -9750,18 +9821,19 @@
         </p:nvGraphicFramePr>
         <p:xfrm>
           <a:off x="731520" y="2377440"/>
-          <a:ext cx="5120640" cy="1335024"/>
+          <a:ext cx="10725912" cy="1600200"/>
         </p:xfrm>
         <a:graphic>
           <a:graphicData uri="http://schemas.openxmlformats.org/drawingml/2006/table">
             <a:tbl>
               <a:tblPr firstRow="0" bandRow="0"/>
               <a:tblGrid>
-                <a:gridCol w="1005840"/>
-                <a:gridCol w="1005840"/>
-                <a:gridCol w="1005840"/>
-                <a:gridCol w="868680"/>
-                <a:gridCol w="1234440"/>
+                <a:gridCol w="1463040"/>
+                <a:gridCol w="1828800"/>
+                <a:gridCol w="1828800"/>
+                <a:gridCol w="1463040"/>
+                <a:gridCol w="1828800"/>
+                <a:gridCol w="2313432"/>
               </a:tblGrid>
               <a:tr h="274320">
                 <a:tc>
@@ -9822,7 +9894,7 @@
                           </a:solidFill>
                           <a:latin typeface="Arial"/>
                         </a:rPr>
-                        <a:t>Bookings</a:t>
+                        <a:t>Bookings 2025</a:t>
                       </a:r>
                     </a:p>
                   </a:txBody>
@@ -9868,7 +9940,7 @@
                           </a:solidFill>
                           <a:latin typeface="Arial"/>
                         </a:rPr>
-                        <a:t>Quotes</a:t>
+                        <a:t>Bookings 2026</a:t>
                       </a:r>
                     </a:p>
                   </a:txBody>
@@ -9914,7 +9986,7 @@
                           </a:solidFill>
                           <a:latin typeface="Arial"/>
                         </a:rPr>
-                        <a:t>Hit rate</a:t>
+                        <a:t>Change</a:t>
                       </a:r>
                     </a:p>
                   </a:txBody>
@@ -9960,7 +10032,53 @@
                           </a:solidFill>
                           <a:latin typeface="Arial"/>
                         </a:rPr>
-                        <a:t>Quoted lead time</a:t>
+                        <a:t>Quotes 2026 (count)</a:t>
+                      </a:r>
+                    </a:p>
+                  </a:txBody>
+                  <a:tcPr marL="73152" marR="73152" marT="27432" marB="27432" anchor="ctr">
+                    <a:solidFill>
+                      <a:srgbClr val="3C7D4D"/>
+                    </a:solidFill>
+                    <a:lnL w="6350" cap="flat" cmpd="sng" algn="ctr">
+                      <a:solidFill>
+                        <a:srgbClr val="3C7D4D"/>
+                      </a:solidFill>
+                      <a:prstDash val="solid"/>
+                    </a:lnL>
+                    <a:lnR w="6350" cap="flat" cmpd="sng" algn="ctr">
+                      <a:solidFill>
+                        <a:srgbClr val="3C7D4D"/>
+                      </a:solidFill>
+                      <a:prstDash val="solid"/>
+                    </a:lnR>
+                    <a:lnT w="6350" cap="flat" cmpd="sng" algn="ctr">
+                      <a:solidFill>
+                        <a:srgbClr val="3C7D4D"/>
+                      </a:solidFill>
+                      <a:prstDash val="solid"/>
+                    </a:lnT>
+                    <a:lnB w="6350" cap="flat" cmpd="sng" algn="ctr">
+                      <a:solidFill>
+                        <a:srgbClr val="3C7D4D"/>
+                      </a:solidFill>
+                      <a:prstDash val="solid"/>
+                    </a:lnB>
+                  </a:tcPr>
+                </a:tc>
+                <a:tc>
+                  <a:txBody>
+                    <a:bodyPr/>
+                    <a:lstStyle/>
+                    <a:p>
+                      <a:r>
+                        <a:rPr sz="1000" b="1">
+                          <a:solidFill>
+                            <a:srgbClr val="FFFFFF"/>
+                          </a:solidFill>
+                          <a:latin typeface="Arial"/>
+                        </a:rPr>
+                        <a:t>Company lead time (wks)</a:t>
                       </a:r>
                     </a:p>
                   </a:txBody>
@@ -10008,7 +10126,7 @@
                           </a:solidFill>
                           <a:latin typeface="Arial"/>
                         </a:rPr>
-                        <a:t>Q4 2025</a:t>
+                        <a:t>Q1</a:t>
                       </a:r>
                     </a:p>
                   </a:txBody>
@@ -10226,6 +10344,52 @@
                     </a:lnB>
                   </a:tcPr>
                 </a:tc>
+                <a:tc>
+                  <a:txBody>
+                    <a:bodyPr/>
+                    <a:lstStyle/>
+                    <a:p>
+                      <a:r>
+                        <a:rPr sz="1000" b="0">
+                          <a:solidFill>
+                            <a:srgbClr val="5B6670"/>
+                          </a:solidFill>
+                          <a:latin typeface="Arial"/>
+                        </a:rPr>
+                        <a:t/>
+                      </a:r>
+                    </a:p>
+                  </a:txBody>
+                  <a:tcPr marL="73152" marR="73152" marT="27432" marB="27432" anchor="t">
+                    <a:solidFill>
+                      <a:srgbClr val="FFFFFF"/>
+                    </a:solidFill>
+                    <a:lnL w="6350" cap="flat" cmpd="sng" algn="ctr">
+                      <a:solidFill>
+                        <a:srgbClr val="E2E6E3"/>
+                      </a:solidFill>
+                      <a:prstDash val="solid"/>
+                    </a:lnL>
+                    <a:lnR w="6350" cap="flat" cmpd="sng" algn="ctr">
+                      <a:solidFill>
+                        <a:srgbClr val="E2E6E3"/>
+                      </a:solidFill>
+                      <a:prstDash val="solid"/>
+                    </a:lnR>
+                    <a:lnT w="6350" cap="flat" cmpd="sng" algn="ctr">
+                      <a:solidFill>
+                        <a:srgbClr val="E2E6E3"/>
+                      </a:solidFill>
+                      <a:prstDash val="solid"/>
+                    </a:lnT>
+                    <a:lnB w="6350" cap="flat" cmpd="sng" algn="ctr">
+                      <a:solidFill>
+                        <a:srgbClr val="E2E6E3"/>
+                      </a:solidFill>
+                      <a:prstDash val="solid"/>
+                    </a:lnB>
+                  </a:tcPr>
+                </a:tc>
               </a:tr>
               <a:tr h="265176">
                 <a:tc>
@@ -10240,7 +10404,7 @@
                           </a:solidFill>
                           <a:latin typeface="Arial"/>
                         </a:rPr>
-                        <a:t>Q1 2026</a:t>
+                        <a:t>Q2</a:t>
                       </a:r>
                     </a:p>
                   </a:txBody>
@@ -10458,6 +10622,52 @@
                     </a:lnB>
                   </a:tcPr>
                 </a:tc>
+                <a:tc>
+                  <a:txBody>
+                    <a:bodyPr/>
+                    <a:lstStyle/>
+                    <a:p>
+                      <a:r>
+                        <a:rPr sz="1000" b="0">
+                          <a:solidFill>
+                            <a:srgbClr val="5B6670"/>
+                          </a:solidFill>
+                          <a:latin typeface="Arial"/>
+                        </a:rPr>
+                        <a:t/>
+                      </a:r>
+                    </a:p>
+                  </a:txBody>
+                  <a:tcPr marL="73152" marR="73152" marT="27432" marB="27432" anchor="t">
+                    <a:solidFill>
+                      <a:srgbClr val="FFFFFF"/>
+                    </a:solidFill>
+                    <a:lnL w="6350" cap="flat" cmpd="sng" algn="ctr">
+                      <a:solidFill>
+                        <a:srgbClr val="E2E6E3"/>
+                      </a:solidFill>
+                      <a:prstDash val="solid"/>
+                    </a:lnL>
+                    <a:lnR w="6350" cap="flat" cmpd="sng" algn="ctr">
+                      <a:solidFill>
+                        <a:srgbClr val="E2E6E3"/>
+                      </a:solidFill>
+                      <a:prstDash val="solid"/>
+                    </a:lnR>
+                    <a:lnT w="6350" cap="flat" cmpd="sng" algn="ctr">
+                      <a:solidFill>
+                        <a:srgbClr val="E2E6E3"/>
+                      </a:solidFill>
+                      <a:prstDash val="solid"/>
+                    </a:lnT>
+                    <a:lnB w="6350" cap="flat" cmpd="sng" algn="ctr">
+                      <a:solidFill>
+                        <a:srgbClr val="E2E6E3"/>
+                      </a:solidFill>
+                      <a:prstDash val="solid"/>
+                    </a:lnB>
+                  </a:tcPr>
+                </a:tc>
               </a:tr>
               <a:tr h="265176">
                 <a:tc>
@@ -10472,7 +10682,7 @@
                           </a:solidFill>
                           <a:latin typeface="Arial"/>
                         </a:rPr>
-                        <a:t>Q2 2026</a:t>
+                        <a:t>Q3</a:t>
                       </a:r>
                     </a:p>
                   </a:txBody>
@@ -10690,6 +10900,52 @@
                     </a:lnB>
                   </a:tcPr>
                 </a:tc>
+                <a:tc>
+                  <a:txBody>
+                    <a:bodyPr/>
+                    <a:lstStyle/>
+                    <a:p>
+                      <a:r>
+                        <a:rPr sz="1000" b="0">
+                          <a:solidFill>
+                            <a:srgbClr val="5B6670"/>
+                          </a:solidFill>
+                          <a:latin typeface="Arial"/>
+                        </a:rPr>
+                        <a:t/>
+                      </a:r>
+                    </a:p>
+                  </a:txBody>
+                  <a:tcPr marL="73152" marR="73152" marT="27432" marB="27432" anchor="t">
+                    <a:solidFill>
+                      <a:srgbClr val="FFFFFF"/>
+                    </a:solidFill>
+                    <a:lnL w="6350" cap="flat" cmpd="sng" algn="ctr">
+                      <a:solidFill>
+                        <a:srgbClr val="E2E6E3"/>
+                      </a:solidFill>
+                      <a:prstDash val="solid"/>
+                    </a:lnL>
+                    <a:lnR w="6350" cap="flat" cmpd="sng" algn="ctr">
+                      <a:solidFill>
+                        <a:srgbClr val="E2E6E3"/>
+                      </a:solidFill>
+                      <a:prstDash val="solid"/>
+                    </a:lnR>
+                    <a:lnT w="6350" cap="flat" cmpd="sng" algn="ctr">
+                      <a:solidFill>
+                        <a:srgbClr val="E2E6E3"/>
+                      </a:solidFill>
+                      <a:prstDash val="solid"/>
+                    </a:lnT>
+                    <a:lnB w="6350" cap="flat" cmpd="sng" algn="ctr">
+                      <a:solidFill>
+                        <a:srgbClr val="E2E6E3"/>
+                      </a:solidFill>
+                      <a:prstDash val="solid"/>
+                    </a:lnB>
+                  </a:tcPr>
+                </a:tc>
               </a:tr>
               <a:tr h="265176">
                 <a:tc>
@@ -10704,7 +10960,7 @@
                           </a:solidFill>
                           <a:latin typeface="Arial"/>
                         </a:rPr>
-                        <a:t>Q3 2026</a:t>
+                        <a:t>Q4 to date</a:t>
                       </a:r>
                     </a:p>
                   </a:txBody>
@@ -10922,223 +11178,47 @@
                     </a:lnB>
                   </a:tcPr>
                 </a:tc>
-              </a:tr>
-            </a:tbl>
-          </a:graphicData>
-        </a:graphic>
-      </p:graphicFrame>
-      <p:sp>
-        <p:nvSpPr>
-          <p:cNvPr id="9" name="TextBox 8"/>
-          <p:cNvSpPr txBox="1"/>
-          <p:nvPr/>
-        </p:nvSpPr>
-        <p:spPr>
-          <a:xfrm>
-            <a:off x="731520" y="3931920"/>
-            <a:ext cx="5120640" cy="237744"/>
-          </a:xfrm>
-          <a:prstGeom prst="rect">
-            <a:avLst/>
-          </a:prstGeom>
-          <a:noFill/>
-        </p:spPr>
-        <p:txBody>
-          <a:bodyPr wrap="square" anchor="t" lIns="0" rIns="0" tIns="0" bIns="0">
-            <a:noAutofit/>
-          </a:bodyPr>
-          <a:lstStyle/>
-          <a:p>
-            <a:r>
-              <a:rPr sz="1100" b="1">
-                <a:solidFill>
-                  <a:srgbClr val="3C7D4D"/>
-                </a:solidFill>
-                <a:latin typeface="Arial"/>
-              </a:rPr>
-              <a:t>WHAT THE NUMBERS DON'T SHOW  ·  YOU FILL THIS IN</a:t>
-            </a:r>
-          </a:p>
-        </p:txBody>
-      </p:sp>
-      <p:sp>
-        <p:nvSpPr>
-          <p:cNvPr id="10" name="TextBox 9"/>
-          <p:cNvSpPr txBox="1"/>
-          <p:nvPr/>
-        </p:nvSpPr>
-        <p:spPr>
-          <a:xfrm>
-            <a:off x="731520" y="4187952"/>
-            <a:ext cx="5120640" cy="1847088"/>
-          </a:xfrm>
-          <a:prstGeom prst="rect">
-            <a:avLst/>
-          </a:prstGeom>
-          <a:solidFill>
-            <a:srgbClr val="F2F5F2"/>
-          </a:solidFill>
-        </p:spPr>
-        <p:txBody>
-          <a:bodyPr wrap="square" anchor="t" tIns="54864" bIns="54864">
-            <a:noAutofit/>
-          </a:bodyPr>
-          <a:lstStyle/>
-          <a:p>
-            <a:r>
-              <a:rPr sz="1200" b="0">
-                <a:solidFill>
-                  <a:srgbClr val="5B6670"/>
-                </a:solidFill>
-                <a:latin typeface="Arial"/>
-              </a:rPr>
-              <a:t>[Two or three sentences. What is happening in the territory that bookings and quotes don't capture. A dealer in transition, a job that slipped a quarter, a competitor that showed up, a plant issue that cost you.]</a:t>
-            </a:r>
-          </a:p>
-        </p:txBody>
-      </p:sp>
-      <p:sp>
-        <p:nvSpPr>
-          <p:cNvPr id="11" name="TextBox 10"/>
-          <p:cNvSpPr txBox="1"/>
-          <p:nvPr/>
-        </p:nvSpPr>
-        <p:spPr>
-          <a:xfrm>
-            <a:off x="6519672" y="2121408"/>
-            <a:ext cx="4937760" cy="237744"/>
-          </a:xfrm>
-          <a:prstGeom prst="rect">
-            <a:avLst/>
-          </a:prstGeom>
-          <a:noFill/>
-        </p:spPr>
-        <p:txBody>
-          <a:bodyPr wrap="square" anchor="t" lIns="0" rIns="0" tIns="0" bIns="0">
-            <a:noAutofit/>
-          </a:bodyPr>
-          <a:lstStyle/>
-          <a:p>
-            <a:r>
-              <a:rPr sz="1100" b="1">
-                <a:solidFill>
-                  <a:srgbClr val="3C7D4D"/>
-                </a:solidFill>
-                <a:latin typeface="Arial"/>
-              </a:rPr>
-              <a:t>TOP ACCOUNTS, YTD BOOKINGS  ·  PRE-FILLED</a:t>
-            </a:r>
-          </a:p>
-        </p:txBody>
-      </p:sp>
-      <p:graphicFrame>
-        <p:nvGraphicFramePr>
-          <p:cNvPr id="12" name="Table 11"/>
-          <p:cNvGraphicFramePr>
-            <a:graphicFrameLocks noGrp="1"/>
-          </p:cNvGraphicFramePr>
-          <p:nvPr/>
-        </p:nvGraphicFramePr>
-        <p:xfrm>
-          <a:off x="6519672" y="2377440"/>
-          <a:ext cx="4937760" cy="1591056"/>
-        </p:xfrm>
-        <a:graphic>
-          <a:graphicData uri="http://schemas.openxmlformats.org/drawingml/2006/table">
-            <a:tbl>
-              <a:tblPr firstRow="0" bandRow="0"/>
-              <a:tblGrid>
-                <a:gridCol w="3108960"/>
-                <a:gridCol w="1828800"/>
-              </a:tblGrid>
-              <a:tr h="265176">
                 <a:tc>
                   <a:txBody>
                     <a:bodyPr/>
                     <a:lstStyle/>
                     <a:p>
                       <a:r>
-                        <a:rPr sz="1000" b="1">
+                        <a:rPr sz="1000" b="0">
                           <a:solidFill>
-                            <a:srgbClr val="FFFFFF"/>
+                            <a:srgbClr val="5B6670"/>
                           </a:solidFill>
                           <a:latin typeface="Arial"/>
                         </a:rPr>
-                        <a:t>Account</a:t>
+                        <a:t/>
                       </a:r>
                     </a:p>
                   </a:txBody>
-                  <a:tcPr marL="73152" marR="73152" marT="27432" marB="27432" anchor="ctr">
+                  <a:tcPr marL="73152" marR="73152" marT="27432" marB="27432" anchor="t">
                     <a:solidFill>
-                      <a:srgbClr val="3C7D4D"/>
+                      <a:srgbClr val="FFFFFF"/>
                     </a:solidFill>
                     <a:lnL w="6350" cap="flat" cmpd="sng" algn="ctr">
                       <a:solidFill>
-                        <a:srgbClr val="3C7D4D"/>
+                        <a:srgbClr val="E2E6E3"/>
                       </a:solidFill>
                       <a:prstDash val="solid"/>
                     </a:lnL>
                     <a:lnR w="6350" cap="flat" cmpd="sng" algn="ctr">
                       <a:solidFill>
-                        <a:srgbClr val="3C7D4D"/>
+                        <a:srgbClr val="E2E6E3"/>
                       </a:solidFill>
                       <a:prstDash val="solid"/>
                     </a:lnR>
                     <a:lnT w="6350" cap="flat" cmpd="sng" algn="ctr">
                       <a:solidFill>
-                        <a:srgbClr val="3C7D4D"/>
+                        <a:srgbClr val="E2E6E3"/>
                       </a:solidFill>
                       <a:prstDash val="solid"/>
                     </a:lnT>
                     <a:lnB w="6350" cap="flat" cmpd="sng" algn="ctr">
                       <a:solidFill>
-                        <a:srgbClr val="3C7D4D"/>
-                      </a:solidFill>
-                      <a:prstDash val="solid"/>
-                    </a:lnB>
-                  </a:tcPr>
-                </a:tc>
-                <a:tc>
-                  <a:txBody>
-                    <a:bodyPr/>
-                    <a:lstStyle/>
-                    <a:p>
-                      <a:r>
-                        <a:rPr sz="1000" b="1">
-                          <a:solidFill>
-                            <a:srgbClr val="FFFFFF"/>
-                          </a:solidFill>
-                          <a:latin typeface="Arial"/>
-                        </a:rPr>
-                        <a:t>YTD bookings</a:t>
-                      </a:r>
-                    </a:p>
-                  </a:txBody>
-                  <a:tcPr marL="73152" marR="73152" marT="27432" marB="27432" anchor="ctr">
-                    <a:solidFill>
-                      <a:srgbClr val="3C7D4D"/>
-                    </a:solidFill>
-                    <a:lnL w="6350" cap="flat" cmpd="sng" algn="ctr">
-                      <a:solidFill>
-                        <a:srgbClr val="3C7D4D"/>
-                      </a:solidFill>
-                      <a:prstDash val="solid"/>
-                    </a:lnL>
-                    <a:lnR w="6350" cap="flat" cmpd="sng" algn="ctr">
-                      <a:solidFill>
-                        <a:srgbClr val="3C7D4D"/>
-                      </a:solidFill>
-                      <a:prstDash val="solid"/>
-                    </a:lnR>
-                    <a:lnT w="6350" cap="flat" cmpd="sng" algn="ctr">
-                      <a:solidFill>
-                        <a:srgbClr val="3C7D4D"/>
-                      </a:solidFill>
-                      <a:prstDash val="solid"/>
-                    </a:lnT>
-                    <a:lnB w="6350" cap="flat" cmpd="sng" algn="ctr">
-                      <a:solidFill>
-                        <a:srgbClr val="3C7D4D"/>
+                        <a:srgbClr val="E2E6E3"/>
                       </a:solidFill>
                       <a:prstDash val="solid"/>
                     </a:lnB>
@@ -11158,7 +11238,7 @@
                           </a:solidFill>
                           <a:latin typeface="Arial"/>
                         </a:rPr>
-                        <a:t>1.  </a:t>
+                        <a:t>YTD</a:t>
                       </a:r>
                     </a:p>
                   </a:txBody>
@@ -11238,21 +11318,19 @@
                     </a:lnB>
                   </a:tcPr>
                 </a:tc>
-              </a:tr>
-              <a:tr h="265176">
                 <a:tc>
                   <a:txBody>
                     <a:bodyPr/>
                     <a:lstStyle/>
                     <a:p>
                       <a:r>
-                        <a:rPr sz="1000" b="1">
+                        <a:rPr sz="1000" b="0">
                           <a:solidFill>
-                            <a:srgbClr val="15181A"/>
+                            <a:srgbClr val="5B6670"/>
                           </a:solidFill>
                           <a:latin typeface="Arial"/>
                         </a:rPr>
-                        <a:t>2.  </a:t>
+                        <a:t/>
                       </a:r>
                     </a:p>
                   </a:txBody>
@@ -11332,21 +11410,19 @@
                     </a:lnB>
                   </a:tcPr>
                 </a:tc>
-              </a:tr>
-              <a:tr h="265176">
                 <a:tc>
                   <a:txBody>
                     <a:bodyPr/>
                     <a:lstStyle/>
                     <a:p>
                       <a:r>
-                        <a:rPr sz="1000" b="1">
+                        <a:rPr sz="1000" b="0">
                           <a:solidFill>
-                            <a:srgbClr val="15181A"/>
+                            <a:srgbClr val="5B6670"/>
                           </a:solidFill>
                           <a:latin typeface="Arial"/>
                         </a:rPr>
-                        <a:t>3.  </a:t>
+                        <a:t/>
                       </a:r>
                     </a:p>
                   </a:txBody>
@@ -11427,208 +11503,20 @@
                   </a:tcPr>
                 </a:tc>
               </a:tr>
-              <a:tr h="265176">
-                <a:tc>
-                  <a:txBody>
-                    <a:bodyPr/>
-                    <a:lstStyle/>
-                    <a:p>
-                      <a:r>
-                        <a:rPr sz="1000" b="1">
-                          <a:solidFill>
-                            <a:srgbClr val="15181A"/>
-                          </a:solidFill>
-                          <a:latin typeface="Arial"/>
-                        </a:rPr>
-                        <a:t>4.  </a:t>
-                      </a:r>
-                    </a:p>
-                  </a:txBody>
-                  <a:tcPr marL="73152" marR="73152" marT="27432" marB="27432" anchor="t">
-                    <a:solidFill>
-                      <a:srgbClr val="FFFFFF"/>
-                    </a:solidFill>
-                    <a:lnL w="6350" cap="flat" cmpd="sng" algn="ctr">
-                      <a:solidFill>
-                        <a:srgbClr val="E2E6E3"/>
-                      </a:solidFill>
-                      <a:prstDash val="solid"/>
-                    </a:lnL>
-                    <a:lnR w="6350" cap="flat" cmpd="sng" algn="ctr">
-                      <a:solidFill>
-                        <a:srgbClr val="E2E6E3"/>
-                      </a:solidFill>
-                      <a:prstDash val="solid"/>
-                    </a:lnR>
-                    <a:lnT w="6350" cap="flat" cmpd="sng" algn="ctr">
-                      <a:solidFill>
-                        <a:srgbClr val="E2E6E3"/>
-                      </a:solidFill>
-                      <a:prstDash val="solid"/>
-                    </a:lnT>
-                    <a:lnB w="6350" cap="flat" cmpd="sng" algn="ctr">
-                      <a:solidFill>
-                        <a:srgbClr val="E2E6E3"/>
-                      </a:solidFill>
-                      <a:prstDash val="solid"/>
-                    </a:lnB>
-                  </a:tcPr>
-                </a:tc>
-                <a:tc>
-                  <a:txBody>
-                    <a:bodyPr/>
-                    <a:lstStyle/>
-                    <a:p>
-                      <a:r>
-                        <a:rPr sz="1000" b="0">
-                          <a:solidFill>
-                            <a:srgbClr val="5B6670"/>
-                          </a:solidFill>
-                          <a:latin typeface="Arial"/>
-                        </a:rPr>
-                        <a:t/>
-                      </a:r>
-                    </a:p>
-                  </a:txBody>
-                  <a:tcPr marL="73152" marR="73152" marT="27432" marB="27432" anchor="t">
-                    <a:solidFill>
-                      <a:srgbClr val="FFFFFF"/>
-                    </a:solidFill>
-                    <a:lnL w="6350" cap="flat" cmpd="sng" algn="ctr">
-                      <a:solidFill>
-                        <a:srgbClr val="E2E6E3"/>
-                      </a:solidFill>
-                      <a:prstDash val="solid"/>
-                    </a:lnL>
-                    <a:lnR w="6350" cap="flat" cmpd="sng" algn="ctr">
-                      <a:solidFill>
-                        <a:srgbClr val="E2E6E3"/>
-                      </a:solidFill>
-                      <a:prstDash val="solid"/>
-                    </a:lnR>
-                    <a:lnT w="6350" cap="flat" cmpd="sng" algn="ctr">
-                      <a:solidFill>
-                        <a:srgbClr val="E2E6E3"/>
-                      </a:solidFill>
-                      <a:prstDash val="solid"/>
-                    </a:lnT>
-                    <a:lnB w="6350" cap="flat" cmpd="sng" algn="ctr">
-                      <a:solidFill>
-                        <a:srgbClr val="E2E6E3"/>
-                      </a:solidFill>
-                      <a:prstDash val="solid"/>
-                    </a:lnB>
-                  </a:tcPr>
-                </a:tc>
-              </a:tr>
-              <a:tr h="265176">
-                <a:tc>
-                  <a:txBody>
-                    <a:bodyPr/>
-                    <a:lstStyle/>
-                    <a:p>
-                      <a:r>
-                        <a:rPr sz="1000" b="1">
-                          <a:solidFill>
-                            <a:srgbClr val="15181A"/>
-                          </a:solidFill>
-                          <a:latin typeface="Arial"/>
-                        </a:rPr>
-                        <a:t>5.  </a:t>
-                      </a:r>
-                    </a:p>
-                  </a:txBody>
-                  <a:tcPr marL="73152" marR="73152" marT="27432" marB="27432" anchor="t">
-                    <a:solidFill>
-                      <a:srgbClr val="FFFFFF"/>
-                    </a:solidFill>
-                    <a:lnL w="6350" cap="flat" cmpd="sng" algn="ctr">
-                      <a:solidFill>
-                        <a:srgbClr val="E2E6E3"/>
-                      </a:solidFill>
-                      <a:prstDash val="solid"/>
-                    </a:lnL>
-                    <a:lnR w="6350" cap="flat" cmpd="sng" algn="ctr">
-                      <a:solidFill>
-                        <a:srgbClr val="E2E6E3"/>
-                      </a:solidFill>
-                      <a:prstDash val="solid"/>
-                    </a:lnR>
-                    <a:lnT w="6350" cap="flat" cmpd="sng" algn="ctr">
-                      <a:solidFill>
-                        <a:srgbClr val="E2E6E3"/>
-                      </a:solidFill>
-                      <a:prstDash val="solid"/>
-                    </a:lnT>
-                    <a:lnB w="6350" cap="flat" cmpd="sng" algn="ctr">
-                      <a:solidFill>
-                        <a:srgbClr val="E2E6E3"/>
-                      </a:solidFill>
-                      <a:prstDash val="solid"/>
-                    </a:lnB>
-                  </a:tcPr>
-                </a:tc>
-                <a:tc>
-                  <a:txBody>
-                    <a:bodyPr/>
-                    <a:lstStyle/>
-                    <a:p>
-                      <a:r>
-                        <a:rPr sz="1000" b="0">
-                          <a:solidFill>
-                            <a:srgbClr val="5B6670"/>
-                          </a:solidFill>
-                          <a:latin typeface="Arial"/>
-                        </a:rPr>
-                        <a:t/>
-                      </a:r>
-                    </a:p>
-                  </a:txBody>
-                  <a:tcPr marL="73152" marR="73152" marT="27432" marB="27432" anchor="t">
-                    <a:solidFill>
-                      <a:srgbClr val="FFFFFF"/>
-                    </a:solidFill>
-                    <a:lnL w="6350" cap="flat" cmpd="sng" algn="ctr">
-                      <a:solidFill>
-                        <a:srgbClr val="E2E6E3"/>
-                      </a:solidFill>
-                      <a:prstDash val="solid"/>
-                    </a:lnL>
-                    <a:lnR w="6350" cap="flat" cmpd="sng" algn="ctr">
-                      <a:solidFill>
-                        <a:srgbClr val="E2E6E3"/>
-                      </a:solidFill>
-                      <a:prstDash val="solid"/>
-                    </a:lnR>
-                    <a:lnT w="6350" cap="flat" cmpd="sng" algn="ctr">
-                      <a:solidFill>
-                        <a:srgbClr val="E2E6E3"/>
-                      </a:solidFill>
-                      <a:prstDash val="solid"/>
-                    </a:lnT>
-                    <a:lnB w="6350" cap="flat" cmpd="sng" algn="ctr">
-                      <a:solidFill>
-                        <a:srgbClr val="E2E6E3"/>
-                      </a:solidFill>
-                      <a:prstDash val="solid"/>
-                    </a:lnB>
-                  </a:tcPr>
-                </a:tc>
-              </a:tr>
             </a:tbl>
           </a:graphicData>
         </a:graphic>
       </p:graphicFrame>
       <p:sp>
         <p:nvSpPr>
-          <p:cNvPr id="13" name="TextBox 12"/>
+          <p:cNvPr id="9" name="TextBox 8"/>
           <p:cNvSpPr txBox="1"/>
           <p:nvPr/>
         </p:nvSpPr>
         <p:spPr>
           <a:xfrm>
-            <a:off x="6519672" y="4096512"/>
-            <a:ext cx="4937760" cy="237744"/>
+            <a:off x="731520" y="4407408"/>
+            <a:ext cx="10725912" cy="237744"/>
           </a:xfrm>
           <a:prstGeom prst="rect">
             <a:avLst/>
@@ -11648,411 +11536,47 @@
                 </a:solidFill>
                 <a:latin typeface="Arial"/>
               </a:rPr>
-              <a:t>EXCALIBUR DEALERS, YTD BOOKINGS  ·  PRE-FILLED</a:t>
-            </a:r>
-          </a:p>
-        </p:txBody>
-      </p:sp>
-      <p:graphicFrame>
-        <p:nvGraphicFramePr>
-          <p:cNvPr id="14" name="Table 13"/>
-          <p:cNvGraphicFramePr>
-            <a:graphicFrameLocks noGrp="1"/>
-          </p:cNvGraphicFramePr>
+              <a:t>WHAT THE NUMBERS DON'T SHOW  ·  YOU FILL THIS IN</a:t>
+            </a:r>
+          </a:p>
+        </p:txBody>
+      </p:sp>
+      <p:sp>
+        <p:nvSpPr>
+          <p:cNvPr id="10" name="TextBox 9"/>
+          <p:cNvSpPr txBox="1"/>
           <p:nvPr/>
-        </p:nvGraphicFramePr>
-        <p:xfrm>
-          <a:off x="6519672" y="4352544"/>
-          <a:ext cx="4937760" cy="1060704"/>
-        </p:xfrm>
-        <a:graphic>
-          <a:graphicData uri="http://schemas.openxmlformats.org/drawingml/2006/table">
-            <a:tbl>
-              <a:tblPr firstRow="0" bandRow="0"/>
-              <a:tblGrid>
-                <a:gridCol w="3108960"/>
-                <a:gridCol w="1828800"/>
-              </a:tblGrid>
-              <a:tr h="265176">
-                <a:tc>
-                  <a:txBody>
-                    <a:bodyPr/>
-                    <a:lstStyle/>
-                    <a:p>
-                      <a:r>
-                        <a:rPr sz="1000" b="1">
-                          <a:solidFill>
-                            <a:srgbClr val="FFFFFF"/>
-                          </a:solidFill>
-                          <a:latin typeface="Arial"/>
-                        </a:rPr>
-                        <a:t>Dealer</a:t>
-                      </a:r>
-                    </a:p>
-                  </a:txBody>
-                  <a:tcPr marL="73152" marR="73152" marT="27432" marB="27432" anchor="ctr">
-                    <a:solidFill>
-                      <a:srgbClr val="3C7D4D"/>
-                    </a:solidFill>
-                    <a:lnL w="6350" cap="flat" cmpd="sng" algn="ctr">
-                      <a:solidFill>
-                        <a:srgbClr val="3C7D4D"/>
-                      </a:solidFill>
-                      <a:prstDash val="solid"/>
-                    </a:lnL>
-                    <a:lnR w="6350" cap="flat" cmpd="sng" algn="ctr">
-                      <a:solidFill>
-                        <a:srgbClr val="3C7D4D"/>
-                      </a:solidFill>
-                      <a:prstDash val="solid"/>
-                    </a:lnR>
-                    <a:lnT w="6350" cap="flat" cmpd="sng" algn="ctr">
-                      <a:solidFill>
-                        <a:srgbClr val="3C7D4D"/>
-                      </a:solidFill>
-                      <a:prstDash val="solid"/>
-                    </a:lnT>
-                    <a:lnB w="6350" cap="flat" cmpd="sng" algn="ctr">
-                      <a:solidFill>
-                        <a:srgbClr val="3C7D4D"/>
-                      </a:solidFill>
-                      <a:prstDash val="solid"/>
-                    </a:lnB>
-                  </a:tcPr>
-                </a:tc>
-                <a:tc>
-                  <a:txBody>
-                    <a:bodyPr/>
-                    <a:lstStyle/>
-                    <a:p>
-                      <a:r>
-                        <a:rPr sz="1000" b="1">
-                          <a:solidFill>
-                            <a:srgbClr val="FFFFFF"/>
-                          </a:solidFill>
-                          <a:latin typeface="Arial"/>
-                        </a:rPr>
-                        <a:t>YTD bookings</a:t>
-                      </a:r>
-                    </a:p>
-                  </a:txBody>
-                  <a:tcPr marL="73152" marR="73152" marT="27432" marB="27432" anchor="ctr">
-                    <a:solidFill>
-                      <a:srgbClr val="3C7D4D"/>
-                    </a:solidFill>
-                    <a:lnL w="6350" cap="flat" cmpd="sng" algn="ctr">
-                      <a:solidFill>
-                        <a:srgbClr val="3C7D4D"/>
-                      </a:solidFill>
-                      <a:prstDash val="solid"/>
-                    </a:lnL>
-                    <a:lnR w="6350" cap="flat" cmpd="sng" algn="ctr">
-                      <a:solidFill>
-                        <a:srgbClr val="3C7D4D"/>
-                      </a:solidFill>
-                      <a:prstDash val="solid"/>
-                    </a:lnR>
-                    <a:lnT w="6350" cap="flat" cmpd="sng" algn="ctr">
-                      <a:solidFill>
-                        <a:srgbClr val="3C7D4D"/>
-                      </a:solidFill>
-                      <a:prstDash val="solid"/>
-                    </a:lnT>
-                    <a:lnB w="6350" cap="flat" cmpd="sng" algn="ctr">
-                      <a:solidFill>
-                        <a:srgbClr val="3C7D4D"/>
-                      </a:solidFill>
-                      <a:prstDash val="solid"/>
-                    </a:lnB>
-                  </a:tcPr>
-                </a:tc>
-              </a:tr>
-              <a:tr h="265176">
-                <a:tc>
-                  <a:txBody>
-                    <a:bodyPr/>
-                    <a:lstStyle/>
-                    <a:p>
-                      <a:r>
-                        <a:rPr sz="1000" b="1">
-                          <a:solidFill>
-                            <a:srgbClr val="15181A"/>
-                          </a:solidFill>
-                          <a:latin typeface="Arial"/>
-                        </a:rPr>
-                        <a:t/>
-                      </a:r>
-                    </a:p>
-                  </a:txBody>
-                  <a:tcPr marL="73152" marR="73152" marT="27432" marB="27432" anchor="t">
-                    <a:solidFill>
-                      <a:srgbClr val="FFFFFF"/>
-                    </a:solidFill>
-                    <a:lnL w="6350" cap="flat" cmpd="sng" algn="ctr">
-                      <a:solidFill>
-                        <a:srgbClr val="E2E6E3"/>
-                      </a:solidFill>
-                      <a:prstDash val="solid"/>
-                    </a:lnL>
-                    <a:lnR w="6350" cap="flat" cmpd="sng" algn="ctr">
-                      <a:solidFill>
-                        <a:srgbClr val="E2E6E3"/>
-                      </a:solidFill>
-                      <a:prstDash val="solid"/>
-                    </a:lnR>
-                    <a:lnT w="6350" cap="flat" cmpd="sng" algn="ctr">
-                      <a:solidFill>
-                        <a:srgbClr val="E2E6E3"/>
-                      </a:solidFill>
-                      <a:prstDash val="solid"/>
-                    </a:lnT>
-                    <a:lnB w="6350" cap="flat" cmpd="sng" algn="ctr">
-                      <a:solidFill>
-                        <a:srgbClr val="E2E6E3"/>
-                      </a:solidFill>
-                      <a:prstDash val="solid"/>
-                    </a:lnB>
-                  </a:tcPr>
-                </a:tc>
-                <a:tc>
-                  <a:txBody>
-                    <a:bodyPr/>
-                    <a:lstStyle/>
-                    <a:p>
-                      <a:r>
-                        <a:rPr sz="1000" b="0">
-                          <a:solidFill>
-                            <a:srgbClr val="5B6670"/>
-                          </a:solidFill>
-                          <a:latin typeface="Arial"/>
-                        </a:rPr>
-                        <a:t/>
-                      </a:r>
-                    </a:p>
-                  </a:txBody>
-                  <a:tcPr marL="73152" marR="73152" marT="27432" marB="27432" anchor="t">
-                    <a:solidFill>
-                      <a:srgbClr val="FFFFFF"/>
-                    </a:solidFill>
-                    <a:lnL w="6350" cap="flat" cmpd="sng" algn="ctr">
-                      <a:solidFill>
-                        <a:srgbClr val="E2E6E3"/>
-                      </a:solidFill>
-                      <a:prstDash val="solid"/>
-                    </a:lnL>
-                    <a:lnR w="6350" cap="flat" cmpd="sng" algn="ctr">
-                      <a:solidFill>
-                        <a:srgbClr val="E2E6E3"/>
-                      </a:solidFill>
-                      <a:prstDash val="solid"/>
-                    </a:lnR>
-                    <a:lnT w="6350" cap="flat" cmpd="sng" algn="ctr">
-                      <a:solidFill>
-                        <a:srgbClr val="E2E6E3"/>
-                      </a:solidFill>
-                      <a:prstDash val="solid"/>
-                    </a:lnT>
-                    <a:lnB w="6350" cap="flat" cmpd="sng" algn="ctr">
-                      <a:solidFill>
-                        <a:srgbClr val="E2E6E3"/>
-                      </a:solidFill>
-                      <a:prstDash val="solid"/>
-                    </a:lnB>
-                  </a:tcPr>
-                </a:tc>
-              </a:tr>
-              <a:tr h="265176">
-                <a:tc>
-                  <a:txBody>
-                    <a:bodyPr/>
-                    <a:lstStyle/>
-                    <a:p>
-                      <a:r>
-                        <a:rPr sz="1000" b="1">
-                          <a:solidFill>
-                            <a:srgbClr val="15181A"/>
-                          </a:solidFill>
-                          <a:latin typeface="Arial"/>
-                        </a:rPr>
-                        <a:t/>
-                      </a:r>
-                    </a:p>
-                  </a:txBody>
-                  <a:tcPr marL="73152" marR="73152" marT="27432" marB="27432" anchor="t">
-                    <a:solidFill>
-                      <a:srgbClr val="FFFFFF"/>
-                    </a:solidFill>
-                    <a:lnL w="6350" cap="flat" cmpd="sng" algn="ctr">
-                      <a:solidFill>
-                        <a:srgbClr val="E2E6E3"/>
-                      </a:solidFill>
-                      <a:prstDash val="solid"/>
-                    </a:lnL>
-                    <a:lnR w="6350" cap="flat" cmpd="sng" algn="ctr">
-                      <a:solidFill>
-                        <a:srgbClr val="E2E6E3"/>
-                      </a:solidFill>
-                      <a:prstDash val="solid"/>
-                    </a:lnR>
-                    <a:lnT w="6350" cap="flat" cmpd="sng" algn="ctr">
-                      <a:solidFill>
-                        <a:srgbClr val="E2E6E3"/>
-                      </a:solidFill>
-                      <a:prstDash val="solid"/>
-                    </a:lnT>
-                    <a:lnB w="6350" cap="flat" cmpd="sng" algn="ctr">
-                      <a:solidFill>
-                        <a:srgbClr val="E2E6E3"/>
-                      </a:solidFill>
-                      <a:prstDash val="solid"/>
-                    </a:lnB>
-                  </a:tcPr>
-                </a:tc>
-                <a:tc>
-                  <a:txBody>
-                    <a:bodyPr/>
-                    <a:lstStyle/>
-                    <a:p>
-                      <a:r>
-                        <a:rPr sz="1000" b="0">
-                          <a:solidFill>
-                            <a:srgbClr val="5B6670"/>
-                          </a:solidFill>
-                          <a:latin typeface="Arial"/>
-                        </a:rPr>
-                        <a:t/>
-                      </a:r>
-                    </a:p>
-                  </a:txBody>
-                  <a:tcPr marL="73152" marR="73152" marT="27432" marB="27432" anchor="t">
-                    <a:solidFill>
-                      <a:srgbClr val="FFFFFF"/>
-                    </a:solidFill>
-                    <a:lnL w="6350" cap="flat" cmpd="sng" algn="ctr">
-                      <a:solidFill>
-                        <a:srgbClr val="E2E6E3"/>
-                      </a:solidFill>
-                      <a:prstDash val="solid"/>
-                    </a:lnL>
-                    <a:lnR w="6350" cap="flat" cmpd="sng" algn="ctr">
-                      <a:solidFill>
-                        <a:srgbClr val="E2E6E3"/>
-                      </a:solidFill>
-                      <a:prstDash val="solid"/>
-                    </a:lnR>
-                    <a:lnT w="6350" cap="flat" cmpd="sng" algn="ctr">
-                      <a:solidFill>
-                        <a:srgbClr val="E2E6E3"/>
-                      </a:solidFill>
-                      <a:prstDash val="solid"/>
-                    </a:lnT>
-                    <a:lnB w="6350" cap="flat" cmpd="sng" algn="ctr">
-                      <a:solidFill>
-                        <a:srgbClr val="E2E6E3"/>
-                      </a:solidFill>
-                      <a:prstDash val="solid"/>
-                    </a:lnB>
-                  </a:tcPr>
-                </a:tc>
-              </a:tr>
-              <a:tr h="265176">
-                <a:tc>
-                  <a:txBody>
-                    <a:bodyPr/>
-                    <a:lstStyle/>
-                    <a:p>
-                      <a:r>
-                        <a:rPr sz="1000" b="1">
-                          <a:solidFill>
-                            <a:srgbClr val="15181A"/>
-                          </a:solidFill>
-                          <a:latin typeface="Arial"/>
-                        </a:rPr>
-                        <a:t/>
-                      </a:r>
-                    </a:p>
-                  </a:txBody>
-                  <a:tcPr marL="73152" marR="73152" marT="27432" marB="27432" anchor="t">
-                    <a:solidFill>
-                      <a:srgbClr val="FFFFFF"/>
-                    </a:solidFill>
-                    <a:lnL w="6350" cap="flat" cmpd="sng" algn="ctr">
-                      <a:solidFill>
-                        <a:srgbClr val="E2E6E3"/>
-                      </a:solidFill>
-                      <a:prstDash val="solid"/>
-                    </a:lnL>
-                    <a:lnR w="6350" cap="flat" cmpd="sng" algn="ctr">
-                      <a:solidFill>
-                        <a:srgbClr val="E2E6E3"/>
-                      </a:solidFill>
-                      <a:prstDash val="solid"/>
-                    </a:lnR>
-                    <a:lnT w="6350" cap="flat" cmpd="sng" algn="ctr">
-                      <a:solidFill>
-                        <a:srgbClr val="E2E6E3"/>
-                      </a:solidFill>
-                      <a:prstDash val="solid"/>
-                    </a:lnT>
-                    <a:lnB w="6350" cap="flat" cmpd="sng" algn="ctr">
-                      <a:solidFill>
-                        <a:srgbClr val="E2E6E3"/>
-                      </a:solidFill>
-                      <a:prstDash val="solid"/>
-                    </a:lnB>
-                  </a:tcPr>
-                </a:tc>
-                <a:tc>
-                  <a:txBody>
-                    <a:bodyPr/>
-                    <a:lstStyle/>
-                    <a:p>
-                      <a:r>
-                        <a:rPr sz="1000" b="0">
-                          <a:solidFill>
-                            <a:srgbClr val="5B6670"/>
-                          </a:solidFill>
-                          <a:latin typeface="Arial"/>
-                        </a:rPr>
-                        <a:t/>
-                      </a:r>
-                    </a:p>
-                  </a:txBody>
-                  <a:tcPr marL="73152" marR="73152" marT="27432" marB="27432" anchor="t">
-                    <a:solidFill>
-                      <a:srgbClr val="FFFFFF"/>
-                    </a:solidFill>
-                    <a:lnL w="6350" cap="flat" cmpd="sng" algn="ctr">
-                      <a:solidFill>
-                        <a:srgbClr val="E2E6E3"/>
-                      </a:solidFill>
-                      <a:prstDash val="solid"/>
-                    </a:lnL>
-                    <a:lnR w="6350" cap="flat" cmpd="sng" algn="ctr">
-                      <a:solidFill>
-                        <a:srgbClr val="E2E6E3"/>
-                      </a:solidFill>
-                      <a:prstDash val="solid"/>
-                    </a:lnR>
-                    <a:lnT w="6350" cap="flat" cmpd="sng" algn="ctr">
-                      <a:solidFill>
-                        <a:srgbClr val="E2E6E3"/>
-                      </a:solidFill>
-                      <a:prstDash val="solid"/>
-                    </a:lnT>
-                    <a:lnB w="6350" cap="flat" cmpd="sng" algn="ctr">
-                      <a:solidFill>
-                        <a:srgbClr val="E2E6E3"/>
-                      </a:solidFill>
-                      <a:prstDash val="solid"/>
-                    </a:lnB>
-                  </a:tcPr>
-                </a:tc>
-              </a:tr>
-            </a:tbl>
-          </a:graphicData>
-        </a:graphic>
-      </p:graphicFrame>
+        </p:nvSpPr>
+        <p:spPr>
+          <a:xfrm>
+            <a:off x="731520" y="4663440"/>
+            <a:ext cx="10725912" cy="1371600"/>
+          </a:xfrm>
+          <a:prstGeom prst="rect">
+            <a:avLst/>
+          </a:prstGeom>
+          <a:solidFill>
+            <a:srgbClr val="F2F5F2"/>
+          </a:solidFill>
+        </p:spPr>
+        <p:txBody>
+          <a:bodyPr wrap="square" anchor="t" tIns="54864" bIns="54864">
+            <a:noAutofit/>
+          </a:bodyPr>
+          <a:lstStyle/>
+          <a:p>
+            <a:r>
+              <a:rPr sz="1200" b="0">
+                <a:solidFill>
+                  <a:srgbClr val="5B6670"/>
+                </a:solidFill>
+                <a:latin typeface="Arial"/>
+              </a:rPr>
+              <a:t>[Two or three sentences. What happened in the territory that bookings don't capture. If bookings didn't come back when lead time did, say why. If they did, say what you did to get them back.]</a:t>
+            </a:r>
+          </a:p>
+        </p:txBody>
+      </p:sp>
     </p:spTree>
   </p:cSld>
   <p:clrMapOvr>
@@ -12087,7 +11611,7 @@
           <a:lstStyle/>
           <a:p>
             <a:r>
-              <a:t>TERRITORY REVIEW  ·  2 OF 6  ·  NEW CUSTOMERS</a:t>
+              <a:t>TERRITORY REVIEW  ·  2 OF 7  ·  NEW CUSTOMERS</a:t>
             </a:r>
           </a:p>
         </p:txBody>
@@ -13033,7 +12557,7 @@
           <a:lstStyle/>
           <a:p>
             <a:r>
-              <a:t>TERRITORY REVIEW  ·  3 OF 6  ·  WINS</a:t>
+              <a:t>TERRITORY REVIEW  ·  3 OF 7  ·  INHERITED ACCOUNTS</a:t>
             </a:r>
           </a:p>
         </p:txBody>
@@ -13054,7 +12578,7 @@
           <a:lstStyle/>
           <a:p>
             <a:r>
-              <a:t>Three wins</a:t>
+              <a:t>The accounts I took over</a:t>
             </a:r>
           </a:p>
         </p:txBody>
@@ -13075,28 +12599,7 @@
           <a:lstStyle/>
           <a:p>
             <a:r>
-              <a:t>[One line. The pattern across the three, or the one we should be copying.]</a:t>
-            </a:r>
-          </a:p>
-        </p:txBody>
-      </p:sp>
-      <p:sp>
-        <p:nvSpPr>
-          <p:cNvPr id="5" name="Text Placeholder 4"/>
-          <p:cNvSpPr>
-            <a:spLocks noGrp="1"/>
-          </p:cNvSpPr>
-          <p:nvPr>
-            <p:ph type="body" idx="106"/>
-          </p:nvPr>
-        </p:nvSpPr>
-        <p:spPr/>
-        <p:txBody>
-          <a:bodyPr/>
-          <a:lstStyle/>
-          <a:p>
-            <a:r>
-              <a:t>Price</a:t>
+              <a:t>[One line. Which of these are alive, which are gone, and which are worth the time.]</a:t>
             </a:r>
           </a:p>
         </p:txBody>
@@ -13108,7 +12611,7 @@
             <a:spLocks noGrp="1"/>
           </p:cNvSpPr>
           <p:nvPr>
-            <p:ph type="body" idx="107"/>
+            <p:ph type="body" idx="104"/>
           </p:nvPr>
         </p:nvSpPr>
         <p:spPr/>
@@ -13117,140 +12620,1430 @@
           <a:lstStyle/>
           <a:p>
             <a:r>
-              <a:t>Job: [dealer, account, job name]</a:t>
-            </a:r>
-          </a:p>
-          <a:p>
-            <a:r>
-              <a:t>Size: [$ and product]</a:t>
-            </a:r>
-          </a:p>
-          <a:p>
-            <a:r>
-              <a:t>Why we won on price: [ ]</a:t>
-            </a:r>
-          </a:p>
-          <a:p>
-            <a:r>
-              <a:t>Repeatable: [yes or no, and why]</a:t>
-            </a:r>
-          </a:p>
-        </p:txBody>
-      </p:sp>
-      <p:sp>
-        <p:nvSpPr>
-          <p:cNvPr id="7" name="Text Placeholder 6"/>
-          <p:cNvSpPr>
-            <a:spLocks noGrp="1"/>
-          </p:cNvSpPr>
-          <p:nvPr>
-            <p:ph type="body" idx="111"/>
-          </p:nvPr>
-        </p:nvSpPr>
-        <p:spPr/>
-        <p:txBody>
-          <a:bodyPr/>
-          <a:lstStyle/>
-          <a:p>
-            <a:r>
-              <a:t>Product</a:t>
-            </a:r>
-          </a:p>
-        </p:txBody>
-      </p:sp>
-      <p:sp>
-        <p:nvSpPr>
-          <p:cNvPr id="8" name="Text Placeholder 7"/>
-          <p:cNvSpPr>
-            <a:spLocks noGrp="1"/>
-          </p:cNvSpPr>
-          <p:nvPr>
-            <p:ph type="body" idx="112"/>
-          </p:nvPr>
-        </p:nvSpPr>
-        <p:spPr/>
-        <p:txBody>
-          <a:bodyPr/>
-          <a:lstStyle/>
-          <a:p>
-            <a:r>
-              <a:t>Job: [dealer, account, job name]</a:t>
-            </a:r>
-          </a:p>
-          <a:p>
-            <a:r>
-              <a:t>Size: [$ and product]</a:t>
-            </a:r>
-          </a:p>
-          <a:p>
-            <a:r>
-              <a:t>Why we won on product: [ ]</a:t>
-            </a:r>
-          </a:p>
-          <a:p>
-            <a:r>
-              <a:t>Repeatable: [yes or no, and why]</a:t>
-            </a:r>
-          </a:p>
-        </p:txBody>
-      </p:sp>
-      <p:sp>
-        <p:nvSpPr>
-          <p:cNvPr id="9" name="Text Placeholder 8"/>
-          <p:cNvSpPr>
-            <a:spLocks noGrp="1"/>
-          </p:cNvSpPr>
-          <p:nvPr>
-            <p:ph type="body" idx="116"/>
-          </p:nvPr>
-        </p:nvSpPr>
-        <p:spPr/>
-        <p:txBody>
-          <a:bodyPr/>
-          <a:lstStyle/>
-          <a:p>
-            <a:r>
-              <a:t>Speed and support</a:t>
-            </a:r>
-          </a:p>
-        </p:txBody>
-      </p:sp>
-      <p:sp>
-        <p:nvSpPr>
-          <p:cNvPr id="10" name="Text Placeholder 9"/>
-          <p:cNvSpPr>
-            <a:spLocks noGrp="1"/>
-          </p:cNvSpPr>
-          <p:nvPr>
-            <p:ph type="body" idx="117"/>
-          </p:nvPr>
-        </p:nvSpPr>
-        <p:spPr/>
-        <p:txBody>
-          <a:bodyPr/>
-          <a:lstStyle/>
-          <a:p>
-            <a:r>
-              <a:t>Job: [dealer, account, job name]</a:t>
-            </a:r>
-          </a:p>
-          <a:p>
-            <a:r>
-              <a:t>Size: [$ and product]</a:t>
-            </a:r>
-          </a:p>
-          <a:p>
-            <a:r>
-              <a:t>Why we won on speed or support: [ ]</a:t>
-            </a:r>
-          </a:p>
-          <a:p>
-            <a:r>
-              <a:t>Repeatable: [yes or no, and why]</a:t>
-            </a:r>
-          </a:p>
-        </p:txBody>
-      </p:sp>
+              <a:t>Source: bookings pre-filled from [system]. Status and next move are Mac's.</a:t>
+            </a:r>
+          </a:p>
+        </p:txBody>
+      </p:sp>
+      <p:graphicFrame>
+        <p:nvGraphicFramePr>
+          <p:cNvPr id="7" name="Table 6"/>
+          <p:cNvGraphicFramePr>
+            <a:graphicFrameLocks noGrp="1"/>
+          </p:cNvGraphicFramePr>
+          <p:nvPr/>
+        </p:nvGraphicFramePr>
+        <p:xfrm>
+          <a:off x="731520" y="2121408"/>
+          <a:ext cx="10725912" cy="3913630"/>
+        </p:xfrm>
+        <a:graphic>
+          <a:graphicData uri="http://schemas.openxmlformats.org/drawingml/2006/table">
+            <a:tbl>
+              <a:tblPr firstRow="0" bandRow="0"/>
+              <a:tblGrid>
+                <a:gridCol w="2377440"/>
+                <a:gridCol w="1325880"/>
+                <a:gridCol w="1325880"/>
+                <a:gridCol w="2834640"/>
+                <a:gridCol w="2862072"/>
+              </a:tblGrid>
+              <a:tr h="365760">
+                <a:tc>
+                  <a:txBody>
+                    <a:bodyPr/>
+                    <a:lstStyle/>
+                    <a:p>
+                      <a:r>
+                        <a:rPr sz="1100" b="1">
+                          <a:solidFill>
+                            <a:srgbClr val="FFFFFF"/>
+                          </a:solidFill>
+                          <a:latin typeface="Arial"/>
+                        </a:rPr>
+                        <a:t>Account</a:t>
+                      </a:r>
+                    </a:p>
+                  </a:txBody>
+                  <a:tcPr marL="73152" marR="73152" marT="27432" marB="27432" anchor="ctr">
+                    <a:solidFill>
+                      <a:srgbClr val="3C7D4D"/>
+                    </a:solidFill>
+                    <a:lnL w="6350" cap="flat" cmpd="sng" algn="ctr">
+                      <a:solidFill>
+                        <a:srgbClr val="3C7D4D"/>
+                      </a:solidFill>
+                      <a:prstDash val="solid"/>
+                    </a:lnL>
+                    <a:lnR w="6350" cap="flat" cmpd="sng" algn="ctr">
+                      <a:solidFill>
+                        <a:srgbClr val="3C7D4D"/>
+                      </a:solidFill>
+                      <a:prstDash val="solid"/>
+                    </a:lnR>
+                    <a:lnT w="6350" cap="flat" cmpd="sng" algn="ctr">
+                      <a:solidFill>
+                        <a:srgbClr val="3C7D4D"/>
+                      </a:solidFill>
+                      <a:prstDash val="solid"/>
+                    </a:lnT>
+                    <a:lnB w="6350" cap="flat" cmpd="sng" algn="ctr">
+                      <a:solidFill>
+                        <a:srgbClr val="3C7D4D"/>
+                      </a:solidFill>
+                      <a:prstDash val="solid"/>
+                    </a:lnB>
+                  </a:tcPr>
+                </a:tc>
+                <a:tc>
+                  <a:txBody>
+                    <a:bodyPr/>
+                    <a:lstStyle/>
+                    <a:p>
+                      <a:r>
+                        <a:rPr sz="1100" b="1">
+                          <a:solidFill>
+                            <a:srgbClr val="FFFFFF"/>
+                          </a:solidFill>
+                          <a:latin typeface="Arial"/>
+                        </a:rPr>
+                        <a:t>2025</a:t>
+                      </a:r>
+                    </a:p>
+                  </a:txBody>
+                  <a:tcPr marL="73152" marR="73152" marT="27432" marB="27432" anchor="ctr">
+                    <a:solidFill>
+                      <a:srgbClr val="3C7D4D"/>
+                    </a:solidFill>
+                    <a:lnL w="6350" cap="flat" cmpd="sng" algn="ctr">
+                      <a:solidFill>
+                        <a:srgbClr val="3C7D4D"/>
+                      </a:solidFill>
+                      <a:prstDash val="solid"/>
+                    </a:lnL>
+                    <a:lnR w="6350" cap="flat" cmpd="sng" algn="ctr">
+                      <a:solidFill>
+                        <a:srgbClr val="3C7D4D"/>
+                      </a:solidFill>
+                      <a:prstDash val="solid"/>
+                    </a:lnR>
+                    <a:lnT w="6350" cap="flat" cmpd="sng" algn="ctr">
+                      <a:solidFill>
+                        <a:srgbClr val="3C7D4D"/>
+                      </a:solidFill>
+                      <a:prstDash val="solid"/>
+                    </a:lnT>
+                    <a:lnB w="6350" cap="flat" cmpd="sng" algn="ctr">
+                      <a:solidFill>
+                        <a:srgbClr val="3C7D4D"/>
+                      </a:solidFill>
+                      <a:prstDash val="solid"/>
+                    </a:lnB>
+                  </a:tcPr>
+                </a:tc>
+                <a:tc>
+                  <a:txBody>
+                    <a:bodyPr/>
+                    <a:lstStyle/>
+                    <a:p>
+                      <a:r>
+                        <a:rPr sz="1100" b="1">
+                          <a:solidFill>
+                            <a:srgbClr val="FFFFFF"/>
+                          </a:solidFill>
+                          <a:latin typeface="Arial"/>
+                        </a:rPr>
+                        <a:t>2026 YTD</a:t>
+                      </a:r>
+                    </a:p>
+                  </a:txBody>
+                  <a:tcPr marL="73152" marR="73152" marT="27432" marB="27432" anchor="ctr">
+                    <a:solidFill>
+                      <a:srgbClr val="3C7D4D"/>
+                    </a:solidFill>
+                    <a:lnL w="6350" cap="flat" cmpd="sng" algn="ctr">
+                      <a:solidFill>
+                        <a:srgbClr val="3C7D4D"/>
+                      </a:solidFill>
+                      <a:prstDash val="solid"/>
+                    </a:lnL>
+                    <a:lnR w="6350" cap="flat" cmpd="sng" algn="ctr">
+                      <a:solidFill>
+                        <a:srgbClr val="3C7D4D"/>
+                      </a:solidFill>
+                      <a:prstDash val="solid"/>
+                    </a:lnR>
+                    <a:lnT w="6350" cap="flat" cmpd="sng" algn="ctr">
+                      <a:solidFill>
+                        <a:srgbClr val="3C7D4D"/>
+                      </a:solidFill>
+                      <a:prstDash val="solid"/>
+                    </a:lnT>
+                    <a:lnB w="6350" cap="flat" cmpd="sng" algn="ctr">
+                      <a:solidFill>
+                        <a:srgbClr val="3C7D4D"/>
+                      </a:solidFill>
+                      <a:prstDash val="solid"/>
+                    </a:lnB>
+                  </a:tcPr>
+                </a:tc>
+                <a:tc>
+                  <a:txBody>
+                    <a:bodyPr/>
+                    <a:lstStyle/>
+                    <a:p>
+                      <a:r>
+                        <a:rPr sz="1100" b="1">
+                          <a:solidFill>
+                            <a:srgbClr val="FFFFFF"/>
+                          </a:solidFill>
+                          <a:latin typeface="Arial"/>
+                        </a:rPr>
+                        <a:t>Where it stands</a:t>
+                      </a:r>
+                    </a:p>
+                  </a:txBody>
+                  <a:tcPr marL="73152" marR="73152" marT="27432" marB="27432" anchor="ctr">
+                    <a:solidFill>
+                      <a:srgbClr val="3C7D4D"/>
+                    </a:solidFill>
+                    <a:lnL w="6350" cap="flat" cmpd="sng" algn="ctr">
+                      <a:solidFill>
+                        <a:srgbClr val="3C7D4D"/>
+                      </a:solidFill>
+                      <a:prstDash val="solid"/>
+                    </a:lnL>
+                    <a:lnR w="6350" cap="flat" cmpd="sng" algn="ctr">
+                      <a:solidFill>
+                        <a:srgbClr val="3C7D4D"/>
+                      </a:solidFill>
+                      <a:prstDash val="solid"/>
+                    </a:lnR>
+                    <a:lnT w="6350" cap="flat" cmpd="sng" algn="ctr">
+                      <a:solidFill>
+                        <a:srgbClr val="3C7D4D"/>
+                      </a:solidFill>
+                      <a:prstDash val="solid"/>
+                    </a:lnT>
+                    <a:lnB w="6350" cap="flat" cmpd="sng" algn="ctr">
+                      <a:solidFill>
+                        <a:srgbClr val="3C7D4D"/>
+                      </a:solidFill>
+                      <a:prstDash val="solid"/>
+                    </a:lnB>
+                  </a:tcPr>
+                </a:tc>
+                <a:tc>
+                  <a:txBody>
+                    <a:bodyPr/>
+                    <a:lstStyle/>
+                    <a:p>
+                      <a:r>
+                        <a:rPr sz="1100" b="1">
+                          <a:solidFill>
+                            <a:srgbClr val="FFFFFF"/>
+                          </a:solidFill>
+                          <a:latin typeface="Arial"/>
+                        </a:rPr>
+                        <a:t>Next move</a:t>
+                      </a:r>
+                    </a:p>
+                  </a:txBody>
+                  <a:tcPr marL="73152" marR="73152" marT="27432" marB="27432" anchor="ctr">
+                    <a:solidFill>
+                      <a:srgbClr val="3C7D4D"/>
+                    </a:solidFill>
+                    <a:lnL w="6350" cap="flat" cmpd="sng" algn="ctr">
+                      <a:solidFill>
+                        <a:srgbClr val="3C7D4D"/>
+                      </a:solidFill>
+                      <a:prstDash val="solid"/>
+                    </a:lnL>
+                    <a:lnR w="6350" cap="flat" cmpd="sng" algn="ctr">
+                      <a:solidFill>
+                        <a:srgbClr val="3C7D4D"/>
+                      </a:solidFill>
+                      <a:prstDash val="solid"/>
+                    </a:lnR>
+                    <a:lnT w="6350" cap="flat" cmpd="sng" algn="ctr">
+                      <a:solidFill>
+                        <a:srgbClr val="3C7D4D"/>
+                      </a:solidFill>
+                      <a:prstDash val="solid"/>
+                    </a:lnT>
+                    <a:lnB w="6350" cap="flat" cmpd="sng" algn="ctr">
+                      <a:solidFill>
+                        <a:srgbClr val="3C7D4D"/>
+                      </a:solidFill>
+                      <a:prstDash val="solid"/>
+                    </a:lnB>
+                  </a:tcPr>
+                </a:tc>
+              </a:tr>
+              <a:tr h="709574">
+                <a:tc>
+                  <a:txBody>
+                    <a:bodyPr/>
+                    <a:lstStyle/>
+                    <a:p>
+                      <a:r>
+                        <a:rPr sz="1100" b="1">
+                          <a:solidFill>
+                            <a:srgbClr val="15181A"/>
+                          </a:solidFill>
+                          <a:latin typeface="Arial"/>
+                        </a:rPr>
+                        <a:t>1.  </a:t>
+                      </a:r>
+                    </a:p>
+                  </a:txBody>
+                  <a:tcPr marL="73152" marR="73152" marT="27432" marB="27432" anchor="t">
+                    <a:solidFill>
+                      <a:srgbClr val="FFFFFF"/>
+                    </a:solidFill>
+                    <a:lnL w="6350" cap="flat" cmpd="sng" algn="ctr">
+                      <a:solidFill>
+                        <a:srgbClr val="E2E6E3"/>
+                      </a:solidFill>
+                      <a:prstDash val="solid"/>
+                    </a:lnL>
+                    <a:lnR w="6350" cap="flat" cmpd="sng" algn="ctr">
+                      <a:solidFill>
+                        <a:srgbClr val="E2E6E3"/>
+                      </a:solidFill>
+                      <a:prstDash val="solid"/>
+                    </a:lnR>
+                    <a:lnT w="6350" cap="flat" cmpd="sng" algn="ctr">
+                      <a:solidFill>
+                        <a:srgbClr val="E2E6E3"/>
+                      </a:solidFill>
+                      <a:prstDash val="solid"/>
+                    </a:lnT>
+                    <a:lnB w="6350" cap="flat" cmpd="sng" algn="ctr">
+                      <a:solidFill>
+                        <a:srgbClr val="E2E6E3"/>
+                      </a:solidFill>
+                      <a:prstDash val="solid"/>
+                    </a:lnB>
+                  </a:tcPr>
+                </a:tc>
+                <a:tc>
+                  <a:txBody>
+                    <a:bodyPr/>
+                    <a:lstStyle/>
+                    <a:p>
+                      <a:r>
+                        <a:rPr sz="1100" b="0">
+                          <a:solidFill>
+                            <a:srgbClr val="5B6670"/>
+                          </a:solidFill>
+                          <a:latin typeface="Arial"/>
+                        </a:rPr>
+                        <a:t/>
+                      </a:r>
+                    </a:p>
+                  </a:txBody>
+                  <a:tcPr marL="73152" marR="73152" marT="27432" marB="27432" anchor="t">
+                    <a:solidFill>
+                      <a:srgbClr val="FFFFFF"/>
+                    </a:solidFill>
+                    <a:lnL w="6350" cap="flat" cmpd="sng" algn="ctr">
+                      <a:solidFill>
+                        <a:srgbClr val="E2E6E3"/>
+                      </a:solidFill>
+                      <a:prstDash val="solid"/>
+                    </a:lnL>
+                    <a:lnR w="6350" cap="flat" cmpd="sng" algn="ctr">
+                      <a:solidFill>
+                        <a:srgbClr val="E2E6E3"/>
+                      </a:solidFill>
+                      <a:prstDash val="solid"/>
+                    </a:lnR>
+                    <a:lnT w="6350" cap="flat" cmpd="sng" algn="ctr">
+                      <a:solidFill>
+                        <a:srgbClr val="E2E6E3"/>
+                      </a:solidFill>
+                      <a:prstDash val="solid"/>
+                    </a:lnT>
+                    <a:lnB w="6350" cap="flat" cmpd="sng" algn="ctr">
+                      <a:solidFill>
+                        <a:srgbClr val="E2E6E3"/>
+                      </a:solidFill>
+                      <a:prstDash val="solid"/>
+                    </a:lnB>
+                  </a:tcPr>
+                </a:tc>
+                <a:tc>
+                  <a:txBody>
+                    <a:bodyPr/>
+                    <a:lstStyle/>
+                    <a:p>
+                      <a:r>
+                        <a:rPr sz="1100" b="0">
+                          <a:solidFill>
+                            <a:srgbClr val="5B6670"/>
+                          </a:solidFill>
+                          <a:latin typeface="Arial"/>
+                        </a:rPr>
+                        <a:t/>
+                      </a:r>
+                    </a:p>
+                  </a:txBody>
+                  <a:tcPr marL="73152" marR="73152" marT="27432" marB="27432" anchor="t">
+                    <a:solidFill>
+                      <a:srgbClr val="FFFFFF"/>
+                    </a:solidFill>
+                    <a:lnL w="6350" cap="flat" cmpd="sng" algn="ctr">
+                      <a:solidFill>
+                        <a:srgbClr val="E2E6E3"/>
+                      </a:solidFill>
+                      <a:prstDash val="solid"/>
+                    </a:lnL>
+                    <a:lnR w="6350" cap="flat" cmpd="sng" algn="ctr">
+                      <a:solidFill>
+                        <a:srgbClr val="E2E6E3"/>
+                      </a:solidFill>
+                      <a:prstDash val="solid"/>
+                    </a:lnR>
+                    <a:lnT w="6350" cap="flat" cmpd="sng" algn="ctr">
+                      <a:solidFill>
+                        <a:srgbClr val="E2E6E3"/>
+                      </a:solidFill>
+                      <a:prstDash val="solid"/>
+                    </a:lnT>
+                    <a:lnB w="6350" cap="flat" cmpd="sng" algn="ctr">
+                      <a:solidFill>
+                        <a:srgbClr val="E2E6E3"/>
+                      </a:solidFill>
+                      <a:prstDash val="solid"/>
+                    </a:lnB>
+                  </a:tcPr>
+                </a:tc>
+                <a:tc>
+                  <a:txBody>
+                    <a:bodyPr/>
+                    <a:lstStyle/>
+                    <a:p>
+                      <a:r>
+                        <a:rPr sz="1100" b="0">
+                          <a:solidFill>
+                            <a:srgbClr val="5B6670"/>
+                          </a:solidFill>
+                          <a:latin typeface="Arial"/>
+                        </a:rPr>
+                        <a:t/>
+                      </a:r>
+                    </a:p>
+                  </a:txBody>
+                  <a:tcPr marL="73152" marR="73152" marT="27432" marB="27432" anchor="t">
+                    <a:solidFill>
+                      <a:srgbClr val="FFFFFF"/>
+                    </a:solidFill>
+                    <a:lnL w="6350" cap="flat" cmpd="sng" algn="ctr">
+                      <a:solidFill>
+                        <a:srgbClr val="E2E6E3"/>
+                      </a:solidFill>
+                      <a:prstDash val="solid"/>
+                    </a:lnL>
+                    <a:lnR w="6350" cap="flat" cmpd="sng" algn="ctr">
+                      <a:solidFill>
+                        <a:srgbClr val="E2E6E3"/>
+                      </a:solidFill>
+                      <a:prstDash val="solid"/>
+                    </a:lnR>
+                    <a:lnT w="6350" cap="flat" cmpd="sng" algn="ctr">
+                      <a:solidFill>
+                        <a:srgbClr val="E2E6E3"/>
+                      </a:solidFill>
+                      <a:prstDash val="solid"/>
+                    </a:lnT>
+                    <a:lnB w="6350" cap="flat" cmpd="sng" algn="ctr">
+                      <a:solidFill>
+                        <a:srgbClr val="E2E6E3"/>
+                      </a:solidFill>
+                      <a:prstDash val="solid"/>
+                    </a:lnB>
+                  </a:tcPr>
+                </a:tc>
+                <a:tc>
+                  <a:txBody>
+                    <a:bodyPr/>
+                    <a:lstStyle/>
+                    <a:p>
+                      <a:r>
+                        <a:rPr sz="1100" b="0">
+                          <a:solidFill>
+                            <a:srgbClr val="5B6670"/>
+                          </a:solidFill>
+                          <a:latin typeface="Arial"/>
+                        </a:rPr>
+                        <a:t/>
+                      </a:r>
+                    </a:p>
+                  </a:txBody>
+                  <a:tcPr marL="73152" marR="73152" marT="27432" marB="27432" anchor="t">
+                    <a:solidFill>
+                      <a:srgbClr val="FFFFFF"/>
+                    </a:solidFill>
+                    <a:lnL w="6350" cap="flat" cmpd="sng" algn="ctr">
+                      <a:solidFill>
+                        <a:srgbClr val="E2E6E3"/>
+                      </a:solidFill>
+                      <a:prstDash val="solid"/>
+                    </a:lnL>
+                    <a:lnR w="6350" cap="flat" cmpd="sng" algn="ctr">
+                      <a:solidFill>
+                        <a:srgbClr val="E2E6E3"/>
+                      </a:solidFill>
+                      <a:prstDash val="solid"/>
+                    </a:lnR>
+                    <a:lnT w="6350" cap="flat" cmpd="sng" algn="ctr">
+                      <a:solidFill>
+                        <a:srgbClr val="E2E6E3"/>
+                      </a:solidFill>
+                      <a:prstDash val="solid"/>
+                    </a:lnT>
+                    <a:lnB w="6350" cap="flat" cmpd="sng" algn="ctr">
+                      <a:solidFill>
+                        <a:srgbClr val="E2E6E3"/>
+                      </a:solidFill>
+                      <a:prstDash val="solid"/>
+                    </a:lnB>
+                  </a:tcPr>
+                </a:tc>
+              </a:tr>
+              <a:tr h="709574">
+                <a:tc>
+                  <a:txBody>
+                    <a:bodyPr/>
+                    <a:lstStyle/>
+                    <a:p>
+                      <a:r>
+                        <a:rPr sz="1100" b="1">
+                          <a:solidFill>
+                            <a:srgbClr val="15181A"/>
+                          </a:solidFill>
+                          <a:latin typeface="Arial"/>
+                        </a:rPr>
+                        <a:t>2.  </a:t>
+                      </a:r>
+                    </a:p>
+                  </a:txBody>
+                  <a:tcPr marL="73152" marR="73152" marT="27432" marB="27432" anchor="t">
+                    <a:solidFill>
+                      <a:srgbClr val="FFFFFF"/>
+                    </a:solidFill>
+                    <a:lnL w="6350" cap="flat" cmpd="sng" algn="ctr">
+                      <a:solidFill>
+                        <a:srgbClr val="E2E6E3"/>
+                      </a:solidFill>
+                      <a:prstDash val="solid"/>
+                    </a:lnL>
+                    <a:lnR w="6350" cap="flat" cmpd="sng" algn="ctr">
+                      <a:solidFill>
+                        <a:srgbClr val="E2E6E3"/>
+                      </a:solidFill>
+                      <a:prstDash val="solid"/>
+                    </a:lnR>
+                    <a:lnT w="6350" cap="flat" cmpd="sng" algn="ctr">
+                      <a:solidFill>
+                        <a:srgbClr val="E2E6E3"/>
+                      </a:solidFill>
+                      <a:prstDash val="solid"/>
+                    </a:lnT>
+                    <a:lnB w="6350" cap="flat" cmpd="sng" algn="ctr">
+                      <a:solidFill>
+                        <a:srgbClr val="E2E6E3"/>
+                      </a:solidFill>
+                      <a:prstDash val="solid"/>
+                    </a:lnB>
+                  </a:tcPr>
+                </a:tc>
+                <a:tc>
+                  <a:txBody>
+                    <a:bodyPr/>
+                    <a:lstStyle/>
+                    <a:p>
+                      <a:r>
+                        <a:rPr sz="1100" b="0">
+                          <a:solidFill>
+                            <a:srgbClr val="5B6670"/>
+                          </a:solidFill>
+                          <a:latin typeface="Arial"/>
+                        </a:rPr>
+                        <a:t/>
+                      </a:r>
+                    </a:p>
+                  </a:txBody>
+                  <a:tcPr marL="73152" marR="73152" marT="27432" marB="27432" anchor="t">
+                    <a:solidFill>
+                      <a:srgbClr val="FFFFFF"/>
+                    </a:solidFill>
+                    <a:lnL w="6350" cap="flat" cmpd="sng" algn="ctr">
+                      <a:solidFill>
+                        <a:srgbClr val="E2E6E3"/>
+                      </a:solidFill>
+                      <a:prstDash val="solid"/>
+                    </a:lnL>
+                    <a:lnR w="6350" cap="flat" cmpd="sng" algn="ctr">
+                      <a:solidFill>
+                        <a:srgbClr val="E2E6E3"/>
+                      </a:solidFill>
+                      <a:prstDash val="solid"/>
+                    </a:lnR>
+                    <a:lnT w="6350" cap="flat" cmpd="sng" algn="ctr">
+                      <a:solidFill>
+                        <a:srgbClr val="E2E6E3"/>
+                      </a:solidFill>
+                      <a:prstDash val="solid"/>
+                    </a:lnT>
+                    <a:lnB w="6350" cap="flat" cmpd="sng" algn="ctr">
+                      <a:solidFill>
+                        <a:srgbClr val="E2E6E3"/>
+                      </a:solidFill>
+                      <a:prstDash val="solid"/>
+                    </a:lnB>
+                  </a:tcPr>
+                </a:tc>
+                <a:tc>
+                  <a:txBody>
+                    <a:bodyPr/>
+                    <a:lstStyle/>
+                    <a:p>
+                      <a:r>
+                        <a:rPr sz="1100" b="0">
+                          <a:solidFill>
+                            <a:srgbClr val="5B6670"/>
+                          </a:solidFill>
+                          <a:latin typeface="Arial"/>
+                        </a:rPr>
+                        <a:t/>
+                      </a:r>
+                    </a:p>
+                  </a:txBody>
+                  <a:tcPr marL="73152" marR="73152" marT="27432" marB="27432" anchor="t">
+                    <a:solidFill>
+                      <a:srgbClr val="FFFFFF"/>
+                    </a:solidFill>
+                    <a:lnL w="6350" cap="flat" cmpd="sng" algn="ctr">
+                      <a:solidFill>
+                        <a:srgbClr val="E2E6E3"/>
+                      </a:solidFill>
+                      <a:prstDash val="solid"/>
+                    </a:lnL>
+                    <a:lnR w="6350" cap="flat" cmpd="sng" algn="ctr">
+                      <a:solidFill>
+                        <a:srgbClr val="E2E6E3"/>
+                      </a:solidFill>
+                      <a:prstDash val="solid"/>
+                    </a:lnR>
+                    <a:lnT w="6350" cap="flat" cmpd="sng" algn="ctr">
+                      <a:solidFill>
+                        <a:srgbClr val="E2E6E3"/>
+                      </a:solidFill>
+                      <a:prstDash val="solid"/>
+                    </a:lnT>
+                    <a:lnB w="6350" cap="flat" cmpd="sng" algn="ctr">
+                      <a:solidFill>
+                        <a:srgbClr val="E2E6E3"/>
+                      </a:solidFill>
+                      <a:prstDash val="solid"/>
+                    </a:lnB>
+                  </a:tcPr>
+                </a:tc>
+                <a:tc>
+                  <a:txBody>
+                    <a:bodyPr/>
+                    <a:lstStyle/>
+                    <a:p>
+                      <a:r>
+                        <a:rPr sz="1100" b="0">
+                          <a:solidFill>
+                            <a:srgbClr val="5B6670"/>
+                          </a:solidFill>
+                          <a:latin typeface="Arial"/>
+                        </a:rPr>
+                        <a:t/>
+                      </a:r>
+                    </a:p>
+                  </a:txBody>
+                  <a:tcPr marL="73152" marR="73152" marT="27432" marB="27432" anchor="t">
+                    <a:solidFill>
+                      <a:srgbClr val="FFFFFF"/>
+                    </a:solidFill>
+                    <a:lnL w="6350" cap="flat" cmpd="sng" algn="ctr">
+                      <a:solidFill>
+                        <a:srgbClr val="E2E6E3"/>
+                      </a:solidFill>
+                      <a:prstDash val="solid"/>
+                    </a:lnL>
+                    <a:lnR w="6350" cap="flat" cmpd="sng" algn="ctr">
+                      <a:solidFill>
+                        <a:srgbClr val="E2E6E3"/>
+                      </a:solidFill>
+                      <a:prstDash val="solid"/>
+                    </a:lnR>
+                    <a:lnT w="6350" cap="flat" cmpd="sng" algn="ctr">
+                      <a:solidFill>
+                        <a:srgbClr val="E2E6E3"/>
+                      </a:solidFill>
+                      <a:prstDash val="solid"/>
+                    </a:lnT>
+                    <a:lnB w="6350" cap="flat" cmpd="sng" algn="ctr">
+                      <a:solidFill>
+                        <a:srgbClr val="E2E6E3"/>
+                      </a:solidFill>
+                      <a:prstDash val="solid"/>
+                    </a:lnB>
+                  </a:tcPr>
+                </a:tc>
+                <a:tc>
+                  <a:txBody>
+                    <a:bodyPr/>
+                    <a:lstStyle/>
+                    <a:p>
+                      <a:r>
+                        <a:rPr sz="1100" b="0">
+                          <a:solidFill>
+                            <a:srgbClr val="5B6670"/>
+                          </a:solidFill>
+                          <a:latin typeface="Arial"/>
+                        </a:rPr>
+                        <a:t/>
+                      </a:r>
+                    </a:p>
+                  </a:txBody>
+                  <a:tcPr marL="73152" marR="73152" marT="27432" marB="27432" anchor="t">
+                    <a:solidFill>
+                      <a:srgbClr val="FFFFFF"/>
+                    </a:solidFill>
+                    <a:lnL w="6350" cap="flat" cmpd="sng" algn="ctr">
+                      <a:solidFill>
+                        <a:srgbClr val="E2E6E3"/>
+                      </a:solidFill>
+                      <a:prstDash val="solid"/>
+                    </a:lnL>
+                    <a:lnR w="6350" cap="flat" cmpd="sng" algn="ctr">
+                      <a:solidFill>
+                        <a:srgbClr val="E2E6E3"/>
+                      </a:solidFill>
+                      <a:prstDash val="solid"/>
+                    </a:lnR>
+                    <a:lnT w="6350" cap="flat" cmpd="sng" algn="ctr">
+                      <a:solidFill>
+                        <a:srgbClr val="E2E6E3"/>
+                      </a:solidFill>
+                      <a:prstDash val="solid"/>
+                    </a:lnT>
+                    <a:lnB w="6350" cap="flat" cmpd="sng" algn="ctr">
+                      <a:solidFill>
+                        <a:srgbClr val="E2E6E3"/>
+                      </a:solidFill>
+                      <a:prstDash val="solid"/>
+                    </a:lnB>
+                  </a:tcPr>
+                </a:tc>
+              </a:tr>
+              <a:tr h="709574">
+                <a:tc>
+                  <a:txBody>
+                    <a:bodyPr/>
+                    <a:lstStyle/>
+                    <a:p>
+                      <a:r>
+                        <a:rPr sz="1100" b="1">
+                          <a:solidFill>
+                            <a:srgbClr val="15181A"/>
+                          </a:solidFill>
+                          <a:latin typeface="Arial"/>
+                        </a:rPr>
+                        <a:t>3.  </a:t>
+                      </a:r>
+                    </a:p>
+                  </a:txBody>
+                  <a:tcPr marL="73152" marR="73152" marT="27432" marB="27432" anchor="t">
+                    <a:solidFill>
+                      <a:srgbClr val="FFFFFF"/>
+                    </a:solidFill>
+                    <a:lnL w="6350" cap="flat" cmpd="sng" algn="ctr">
+                      <a:solidFill>
+                        <a:srgbClr val="E2E6E3"/>
+                      </a:solidFill>
+                      <a:prstDash val="solid"/>
+                    </a:lnL>
+                    <a:lnR w="6350" cap="flat" cmpd="sng" algn="ctr">
+                      <a:solidFill>
+                        <a:srgbClr val="E2E6E3"/>
+                      </a:solidFill>
+                      <a:prstDash val="solid"/>
+                    </a:lnR>
+                    <a:lnT w="6350" cap="flat" cmpd="sng" algn="ctr">
+                      <a:solidFill>
+                        <a:srgbClr val="E2E6E3"/>
+                      </a:solidFill>
+                      <a:prstDash val="solid"/>
+                    </a:lnT>
+                    <a:lnB w="6350" cap="flat" cmpd="sng" algn="ctr">
+                      <a:solidFill>
+                        <a:srgbClr val="E2E6E3"/>
+                      </a:solidFill>
+                      <a:prstDash val="solid"/>
+                    </a:lnB>
+                  </a:tcPr>
+                </a:tc>
+                <a:tc>
+                  <a:txBody>
+                    <a:bodyPr/>
+                    <a:lstStyle/>
+                    <a:p>
+                      <a:r>
+                        <a:rPr sz="1100" b="0">
+                          <a:solidFill>
+                            <a:srgbClr val="5B6670"/>
+                          </a:solidFill>
+                          <a:latin typeface="Arial"/>
+                        </a:rPr>
+                        <a:t/>
+                      </a:r>
+                    </a:p>
+                  </a:txBody>
+                  <a:tcPr marL="73152" marR="73152" marT="27432" marB="27432" anchor="t">
+                    <a:solidFill>
+                      <a:srgbClr val="FFFFFF"/>
+                    </a:solidFill>
+                    <a:lnL w="6350" cap="flat" cmpd="sng" algn="ctr">
+                      <a:solidFill>
+                        <a:srgbClr val="E2E6E3"/>
+                      </a:solidFill>
+                      <a:prstDash val="solid"/>
+                    </a:lnL>
+                    <a:lnR w="6350" cap="flat" cmpd="sng" algn="ctr">
+                      <a:solidFill>
+                        <a:srgbClr val="E2E6E3"/>
+                      </a:solidFill>
+                      <a:prstDash val="solid"/>
+                    </a:lnR>
+                    <a:lnT w="6350" cap="flat" cmpd="sng" algn="ctr">
+                      <a:solidFill>
+                        <a:srgbClr val="E2E6E3"/>
+                      </a:solidFill>
+                      <a:prstDash val="solid"/>
+                    </a:lnT>
+                    <a:lnB w="6350" cap="flat" cmpd="sng" algn="ctr">
+                      <a:solidFill>
+                        <a:srgbClr val="E2E6E3"/>
+                      </a:solidFill>
+                      <a:prstDash val="solid"/>
+                    </a:lnB>
+                  </a:tcPr>
+                </a:tc>
+                <a:tc>
+                  <a:txBody>
+                    <a:bodyPr/>
+                    <a:lstStyle/>
+                    <a:p>
+                      <a:r>
+                        <a:rPr sz="1100" b="0">
+                          <a:solidFill>
+                            <a:srgbClr val="5B6670"/>
+                          </a:solidFill>
+                          <a:latin typeface="Arial"/>
+                        </a:rPr>
+                        <a:t/>
+                      </a:r>
+                    </a:p>
+                  </a:txBody>
+                  <a:tcPr marL="73152" marR="73152" marT="27432" marB="27432" anchor="t">
+                    <a:solidFill>
+                      <a:srgbClr val="FFFFFF"/>
+                    </a:solidFill>
+                    <a:lnL w="6350" cap="flat" cmpd="sng" algn="ctr">
+                      <a:solidFill>
+                        <a:srgbClr val="E2E6E3"/>
+                      </a:solidFill>
+                      <a:prstDash val="solid"/>
+                    </a:lnL>
+                    <a:lnR w="6350" cap="flat" cmpd="sng" algn="ctr">
+                      <a:solidFill>
+                        <a:srgbClr val="E2E6E3"/>
+                      </a:solidFill>
+                      <a:prstDash val="solid"/>
+                    </a:lnR>
+                    <a:lnT w="6350" cap="flat" cmpd="sng" algn="ctr">
+                      <a:solidFill>
+                        <a:srgbClr val="E2E6E3"/>
+                      </a:solidFill>
+                      <a:prstDash val="solid"/>
+                    </a:lnT>
+                    <a:lnB w="6350" cap="flat" cmpd="sng" algn="ctr">
+                      <a:solidFill>
+                        <a:srgbClr val="E2E6E3"/>
+                      </a:solidFill>
+                      <a:prstDash val="solid"/>
+                    </a:lnB>
+                  </a:tcPr>
+                </a:tc>
+                <a:tc>
+                  <a:txBody>
+                    <a:bodyPr/>
+                    <a:lstStyle/>
+                    <a:p>
+                      <a:r>
+                        <a:rPr sz="1100" b="0">
+                          <a:solidFill>
+                            <a:srgbClr val="5B6670"/>
+                          </a:solidFill>
+                          <a:latin typeface="Arial"/>
+                        </a:rPr>
+                        <a:t/>
+                      </a:r>
+                    </a:p>
+                  </a:txBody>
+                  <a:tcPr marL="73152" marR="73152" marT="27432" marB="27432" anchor="t">
+                    <a:solidFill>
+                      <a:srgbClr val="FFFFFF"/>
+                    </a:solidFill>
+                    <a:lnL w="6350" cap="flat" cmpd="sng" algn="ctr">
+                      <a:solidFill>
+                        <a:srgbClr val="E2E6E3"/>
+                      </a:solidFill>
+                      <a:prstDash val="solid"/>
+                    </a:lnL>
+                    <a:lnR w="6350" cap="flat" cmpd="sng" algn="ctr">
+                      <a:solidFill>
+                        <a:srgbClr val="E2E6E3"/>
+                      </a:solidFill>
+                      <a:prstDash val="solid"/>
+                    </a:lnR>
+                    <a:lnT w="6350" cap="flat" cmpd="sng" algn="ctr">
+                      <a:solidFill>
+                        <a:srgbClr val="E2E6E3"/>
+                      </a:solidFill>
+                      <a:prstDash val="solid"/>
+                    </a:lnT>
+                    <a:lnB w="6350" cap="flat" cmpd="sng" algn="ctr">
+                      <a:solidFill>
+                        <a:srgbClr val="E2E6E3"/>
+                      </a:solidFill>
+                      <a:prstDash val="solid"/>
+                    </a:lnB>
+                  </a:tcPr>
+                </a:tc>
+                <a:tc>
+                  <a:txBody>
+                    <a:bodyPr/>
+                    <a:lstStyle/>
+                    <a:p>
+                      <a:r>
+                        <a:rPr sz="1100" b="0">
+                          <a:solidFill>
+                            <a:srgbClr val="5B6670"/>
+                          </a:solidFill>
+                          <a:latin typeface="Arial"/>
+                        </a:rPr>
+                        <a:t/>
+                      </a:r>
+                    </a:p>
+                  </a:txBody>
+                  <a:tcPr marL="73152" marR="73152" marT="27432" marB="27432" anchor="t">
+                    <a:solidFill>
+                      <a:srgbClr val="FFFFFF"/>
+                    </a:solidFill>
+                    <a:lnL w="6350" cap="flat" cmpd="sng" algn="ctr">
+                      <a:solidFill>
+                        <a:srgbClr val="E2E6E3"/>
+                      </a:solidFill>
+                      <a:prstDash val="solid"/>
+                    </a:lnL>
+                    <a:lnR w="6350" cap="flat" cmpd="sng" algn="ctr">
+                      <a:solidFill>
+                        <a:srgbClr val="E2E6E3"/>
+                      </a:solidFill>
+                      <a:prstDash val="solid"/>
+                    </a:lnR>
+                    <a:lnT w="6350" cap="flat" cmpd="sng" algn="ctr">
+                      <a:solidFill>
+                        <a:srgbClr val="E2E6E3"/>
+                      </a:solidFill>
+                      <a:prstDash val="solid"/>
+                    </a:lnT>
+                    <a:lnB w="6350" cap="flat" cmpd="sng" algn="ctr">
+                      <a:solidFill>
+                        <a:srgbClr val="E2E6E3"/>
+                      </a:solidFill>
+                      <a:prstDash val="solid"/>
+                    </a:lnB>
+                  </a:tcPr>
+                </a:tc>
+              </a:tr>
+              <a:tr h="709574">
+                <a:tc>
+                  <a:txBody>
+                    <a:bodyPr/>
+                    <a:lstStyle/>
+                    <a:p>
+                      <a:r>
+                        <a:rPr sz="1100" b="1">
+                          <a:solidFill>
+                            <a:srgbClr val="15181A"/>
+                          </a:solidFill>
+                          <a:latin typeface="Arial"/>
+                        </a:rPr>
+                        <a:t>4.  </a:t>
+                      </a:r>
+                    </a:p>
+                  </a:txBody>
+                  <a:tcPr marL="73152" marR="73152" marT="27432" marB="27432" anchor="t">
+                    <a:solidFill>
+                      <a:srgbClr val="FFFFFF"/>
+                    </a:solidFill>
+                    <a:lnL w="6350" cap="flat" cmpd="sng" algn="ctr">
+                      <a:solidFill>
+                        <a:srgbClr val="E2E6E3"/>
+                      </a:solidFill>
+                      <a:prstDash val="solid"/>
+                    </a:lnL>
+                    <a:lnR w="6350" cap="flat" cmpd="sng" algn="ctr">
+                      <a:solidFill>
+                        <a:srgbClr val="E2E6E3"/>
+                      </a:solidFill>
+                      <a:prstDash val="solid"/>
+                    </a:lnR>
+                    <a:lnT w="6350" cap="flat" cmpd="sng" algn="ctr">
+                      <a:solidFill>
+                        <a:srgbClr val="E2E6E3"/>
+                      </a:solidFill>
+                      <a:prstDash val="solid"/>
+                    </a:lnT>
+                    <a:lnB w="6350" cap="flat" cmpd="sng" algn="ctr">
+                      <a:solidFill>
+                        <a:srgbClr val="E2E6E3"/>
+                      </a:solidFill>
+                      <a:prstDash val="solid"/>
+                    </a:lnB>
+                  </a:tcPr>
+                </a:tc>
+                <a:tc>
+                  <a:txBody>
+                    <a:bodyPr/>
+                    <a:lstStyle/>
+                    <a:p>
+                      <a:r>
+                        <a:rPr sz="1100" b="0">
+                          <a:solidFill>
+                            <a:srgbClr val="5B6670"/>
+                          </a:solidFill>
+                          <a:latin typeface="Arial"/>
+                        </a:rPr>
+                        <a:t/>
+                      </a:r>
+                    </a:p>
+                  </a:txBody>
+                  <a:tcPr marL="73152" marR="73152" marT="27432" marB="27432" anchor="t">
+                    <a:solidFill>
+                      <a:srgbClr val="FFFFFF"/>
+                    </a:solidFill>
+                    <a:lnL w="6350" cap="flat" cmpd="sng" algn="ctr">
+                      <a:solidFill>
+                        <a:srgbClr val="E2E6E3"/>
+                      </a:solidFill>
+                      <a:prstDash val="solid"/>
+                    </a:lnL>
+                    <a:lnR w="6350" cap="flat" cmpd="sng" algn="ctr">
+                      <a:solidFill>
+                        <a:srgbClr val="E2E6E3"/>
+                      </a:solidFill>
+                      <a:prstDash val="solid"/>
+                    </a:lnR>
+                    <a:lnT w="6350" cap="flat" cmpd="sng" algn="ctr">
+                      <a:solidFill>
+                        <a:srgbClr val="E2E6E3"/>
+                      </a:solidFill>
+                      <a:prstDash val="solid"/>
+                    </a:lnT>
+                    <a:lnB w="6350" cap="flat" cmpd="sng" algn="ctr">
+                      <a:solidFill>
+                        <a:srgbClr val="E2E6E3"/>
+                      </a:solidFill>
+                      <a:prstDash val="solid"/>
+                    </a:lnB>
+                  </a:tcPr>
+                </a:tc>
+                <a:tc>
+                  <a:txBody>
+                    <a:bodyPr/>
+                    <a:lstStyle/>
+                    <a:p>
+                      <a:r>
+                        <a:rPr sz="1100" b="0">
+                          <a:solidFill>
+                            <a:srgbClr val="5B6670"/>
+                          </a:solidFill>
+                          <a:latin typeface="Arial"/>
+                        </a:rPr>
+                        <a:t/>
+                      </a:r>
+                    </a:p>
+                  </a:txBody>
+                  <a:tcPr marL="73152" marR="73152" marT="27432" marB="27432" anchor="t">
+                    <a:solidFill>
+                      <a:srgbClr val="FFFFFF"/>
+                    </a:solidFill>
+                    <a:lnL w="6350" cap="flat" cmpd="sng" algn="ctr">
+                      <a:solidFill>
+                        <a:srgbClr val="E2E6E3"/>
+                      </a:solidFill>
+                      <a:prstDash val="solid"/>
+                    </a:lnL>
+                    <a:lnR w="6350" cap="flat" cmpd="sng" algn="ctr">
+                      <a:solidFill>
+                        <a:srgbClr val="E2E6E3"/>
+                      </a:solidFill>
+                      <a:prstDash val="solid"/>
+                    </a:lnR>
+                    <a:lnT w="6350" cap="flat" cmpd="sng" algn="ctr">
+                      <a:solidFill>
+                        <a:srgbClr val="E2E6E3"/>
+                      </a:solidFill>
+                      <a:prstDash val="solid"/>
+                    </a:lnT>
+                    <a:lnB w="6350" cap="flat" cmpd="sng" algn="ctr">
+                      <a:solidFill>
+                        <a:srgbClr val="E2E6E3"/>
+                      </a:solidFill>
+                      <a:prstDash val="solid"/>
+                    </a:lnB>
+                  </a:tcPr>
+                </a:tc>
+                <a:tc>
+                  <a:txBody>
+                    <a:bodyPr/>
+                    <a:lstStyle/>
+                    <a:p>
+                      <a:r>
+                        <a:rPr sz="1100" b="0">
+                          <a:solidFill>
+                            <a:srgbClr val="5B6670"/>
+                          </a:solidFill>
+                          <a:latin typeface="Arial"/>
+                        </a:rPr>
+                        <a:t/>
+                      </a:r>
+                    </a:p>
+                  </a:txBody>
+                  <a:tcPr marL="73152" marR="73152" marT="27432" marB="27432" anchor="t">
+                    <a:solidFill>
+                      <a:srgbClr val="FFFFFF"/>
+                    </a:solidFill>
+                    <a:lnL w="6350" cap="flat" cmpd="sng" algn="ctr">
+                      <a:solidFill>
+                        <a:srgbClr val="E2E6E3"/>
+                      </a:solidFill>
+                      <a:prstDash val="solid"/>
+                    </a:lnL>
+                    <a:lnR w="6350" cap="flat" cmpd="sng" algn="ctr">
+                      <a:solidFill>
+                        <a:srgbClr val="E2E6E3"/>
+                      </a:solidFill>
+                      <a:prstDash val="solid"/>
+                    </a:lnR>
+                    <a:lnT w="6350" cap="flat" cmpd="sng" algn="ctr">
+                      <a:solidFill>
+                        <a:srgbClr val="E2E6E3"/>
+                      </a:solidFill>
+                      <a:prstDash val="solid"/>
+                    </a:lnT>
+                    <a:lnB w="6350" cap="flat" cmpd="sng" algn="ctr">
+                      <a:solidFill>
+                        <a:srgbClr val="E2E6E3"/>
+                      </a:solidFill>
+                      <a:prstDash val="solid"/>
+                    </a:lnB>
+                  </a:tcPr>
+                </a:tc>
+                <a:tc>
+                  <a:txBody>
+                    <a:bodyPr/>
+                    <a:lstStyle/>
+                    <a:p>
+                      <a:r>
+                        <a:rPr sz="1100" b="0">
+                          <a:solidFill>
+                            <a:srgbClr val="5B6670"/>
+                          </a:solidFill>
+                          <a:latin typeface="Arial"/>
+                        </a:rPr>
+                        <a:t/>
+                      </a:r>
+                    </a:p>
+                  </a:txBody>
+                  <a:tcPr marL="73152" marR="73152" marT="27432" marB="27432" anchor="t">
+                    <a:solidFill>
+                      <a:srgbClr val="FFFFFF"/>
+                    </a:solidFill>
+                    <a:lnL w="6350" cap="flat" cmpd="sng" algn="ctr">
+                      <a:solidFill>
+                        <a:srgbClr val="E2E6E3"/>
+                      </a:solidFill>
+                      <a:prstDash val="solid"/>
+                    </a:lnL>
+                    <a:lnR w="6350" cap="flat" cmpd="sng" algn="ctr">
+                      <a:solidFill>
+                        <a:srgbClr val="E2E6E3"/>
+                      </a:solidFill>
+                      <a:prstDash val="solid"/>
+                    </a:lnR>
+                    <a:lnT w="6350" cap="flat" cmpd="sng" algn="ctr">
+                      <a:solidFill>
+                        <a:srgbClr val="E2E6E3"/>
+                      </a:solidFill>
+                      <a:prstDash val="solid"/>
+                    </a:lnT>
+                    <a:lnB w="6350" cap="flat" cmpd="sng" algn="ctr">
+                      <a:solidFill>
+                        <a:srgbClr val="E2E6E3"/>
+                      </a:solidFill>
+                      <a:prstDash val="solid"/>
+                    </a:lnB>
+                  </a:tcPr>
+                </a:tc>
+              </a:tr>
+              <a:tr h="709574">
+                <a:tc>
+                  <a:txBody>
+                    <a:bodyPr/>
+                    <a:lstStyle/>
+                    <a:p>
+                      <a:r>
+                        <a:rPr sz="1100" b="1">
+                          <a:solidFill>
+                            <a:srgbClr val="15181A"/>
+                          </a:solidFill>
+                          <a:latin typeface="Arial"/>
+                        </a:rPr>
+                        <a:t>5.  </a:t>
+                      </a:r>
+                    </a:p>
+                  </a:txBody>
+                  <a:tcPr marL="73152" marR="73152" marT="27432" marB="27432" anchor="t">
+                    <a:solidFill>
+                      <a:srgbClr val="FFFFFF"/>
+                    </a:solidFill>
+                    <a:lnL w="6350" cap="flat" cmpd="sng" algn="ctr">
+                      <a:solidFill>
+                        <a:srgbClr val="E2E6E3"/>
+                      </a:solidFill>
+                      <a:prstDash val="solid"/>
+                    </a:lnL>
+                    <a:lnR w="6350" cap="flat" cmpd="sng" algn="ctr">
+                      <a:solidFill>
+                        <a:srgbClr val="E2E6E3"/>
+                      </a:solidFill>
+                      <a:prstDash val="solid"/>
+                    </a:lnR>
+                    <a:lnT w="6350" cap="flat" cmpd="sng" algn="ctr">
+                      <a:solidFill>
+                        <a:srgbClr val="E2E6E3"/>
+                      </a:solidFill>
+                      <a:prstDash val="solid"/>
+                    </a:lnT>
+                    <a:lnB w="6350" cap="flat" cmpd="sng" algn="ctr">
+                      <a:solidFill>
+                        <a:srgbClr val="E2E6E3"/>
+                      </a:solidFill>
+                      <a:prstDash val="solid"/>
+                    </a:lnB>
+                  </a:tcPr>
+                </a:tc>
+                <a:tc>
+                  <a:txBody>
+                    <a:bodyPr/>
+                    <a:lstStyle/>
+                    <a:p>
+                      <a:r>
+                        <a:rPr sz="1100" b="0">
+                          <a:solidFill>
+                            <a:srgbClr val="5B6670"/>
+                          </a:solidFill>
+                          <a:latin typeface="Arial"/>
+                        </a:rPr>
+                        <a:t/>
+                      </a:r>
+                    </a:p>
+                  </a:txBody>
+                  <a:tcPr marL="73152" marR="73152" marT="27432" marB="27432" anchor="t">
+                    <a:solidFill>
+                      <a:srgbClr val="FFFFFF"/>
+                    </a:solidFill>
+                    <a:lnL w="6350" cap="flat" cmpd="sng" algn="ctr">
+                      <a:solidFill>
+                        <a:srgbClr val="E2E6E3"/>
+                      </a:solidFill>
+                      <a:prstDash val="solid"/>
+                    </a:lnL>
+                    <a:lnR w="6350" cap="flat" cmpd="sng" algn="ctr">
+                      <a:solidFill>
+                        <a:srgbClr val="E2E6E3"/>
+                      </a:solidFill>
+                      <a:prstDash val="solid"/>
+                    </a:lnR>
+                    <a:lnT w="6350" cap="flat" cmpd="sng" algn="ctr">
+                      <a:solidFill>
+                        <a:srgbClr val="E2E6E3"/>
+                      </a:solidFill>
+                      <a:prstDash val="solid"/>
+                    </a:lnT>
+                    <a:lnB w="6350" cap="flat" cmpd="sng" algn="ctr">
+                      <a:solidFill>
+                        <a:srgbClr val="E2E6E3"/>
+                      </a:solidFill>
+                      <a:prstDash val="solid"/>
+                    </a:lnB>
+                  </a:tcPr>
+                </a:tc>
+                <a:tc>
+                  <a:txBody>
+                    <a:bodyPr/>
+                    <a:lstStyle/>
+                    <a:p>
+                      <a:r>
+                        <a:rPr sz="1100" b="0">
+                          <a:solidFill>
+                            <a:srgbClr val="5B6670"/>
+                          </a:solidFill>
+                          <a:latin typeface="Arial"/>
+                        </a:rPr>
+                        <a:t/>
+                      </a:r>
+                    </a:p>
+                  </a:txBody>
+                  <a:tcPr marL="73152" marR="73152" marT="27432" marB="27432" anchor="t">
+                    <a:solidFill>
+                      <a:srgbClr val="FFFFFF"/>
+                    </a:solidFill>
+                    <a:lnL w="6350" cap="flat" cmpd="sng" algn="ctr">
+                      <a:solidFill>
+                        <a:srgbClr val="E2E6E3"/>
+                      </a:solidFill>
+                      <a:prstDash val="solid"/>
+                    </a:lnL>
+                    <a:lnR w="6350" cap="flat" cmpd="sng" algn="ctr">
+                      <a:solidFill>
+                        <a:srgbClr val="E2E6E3"/>
+                      </a:solidFill>
+                      <a:prstDash val="solid"/>
+                    </a:lnR>
+                    <a:lnT w="6350" cap="flat" cmpd="sng" algn="ctr">
+                      <a:solidFill>
+                        <a:srgbClr val="E2E6E3"/>
+                      </a:solidFill>
+                      <a:prstDash val="solid"/>
+                    </a:lnT>
+                    <a:lnB w="6350" cap="flat" cmpd="sng" algn="ctr">
+                      <a:solidFill>
+                        <a:srgbClr val="E2E6E3"/>
+                      </a:solidFill>
+                      <a:prstDash val="solid"/>
+                    </a:lnB>
+                  </a:tcPr>
+                </a:tc>
+                <a:tc>
+                  <a:txBody>
+                    <a:bodyPr/>
+                    <a:lstStyle/>
+                    <a:p>
+                      <a:r>
+                        <a:rPr sz="1100" b="0">
+                          <a:solidFill>
+                            <a:srgbClr val="5B6670"/>
+                          </a:solidFill>
+                          <a:latin typeface="Arial"/>
+                        </a:rPr>
+                        <a:t/>
+                      </a:r>
+                    </a:p>
+                  </a:txBody>
+                  <a:tcPr marL="73152" marR="73152" marT="27432" marB="27432" anchor="t">
+                    <a:solidFill>
+                      <a:srgbClr val="FFFFFF"/>
+                    </a:solidFill>
+                    <a:lnL w="6350" cap="flat" cmpd="sng" algn="ctr">
+                      <a:solidFill>
+                        <a:srgbClr val="E2E6E3"/>
+                      </a:solidFill>
+                      <a:prstDash val="solid"/>
+                    </a:lnL>
+                    <a:lnR w="6350" cap="flat" cmpd="sng" algn="ctr">
+                      <a:solidFill>
+                        <a:srgbClr val="E2E6E3"/>
+                      </a:solidFill>
+                      <a:prstDash val="solid"/>
+                    </a:lnR>
+                    <a:lnT w="6350" cap="flat" cmpd="sng" algn="ctr">
+                      <a:solidFill>
+                        <a:srgbClr val="E2E6E3"/>
+                      </a:solidFill>
+                      <a:prstDash val="solid"/>
+                    </a:lnT>
+                    <a:lnB w="6350" cap="flat" cmpd="sng" algn="ctr">
+                      <a:solidFill>
+                        <a:srgbClr val="E2E6E3"/>
+                      </a:solidFill>
+                      <a:prstDash val="solid"/>
+                    </a:lnB>
+                  </a:tcPr>
+                </a:tc>
+                <a:tc>
+                  <a:txBody>
+                    <a:bodyPr/>
+                    <a:lstStyle/>
+                    <a:p>
+                      <a:r>
+                        <a:rPr sz="1100" b="0">
+                          <a:solidFill>
+                            <a:srgbClr val="5B6670"/>
+                          </a:solidFill>
+                          <a:latin typeface="Arial"/>
+                        </a:rPr>
+                        <a:t/>
+                      </a:r>
+                    </a:p>
+                  </a:txBody>
+                  <a:tcPr marL="73152" marR="73152" marT="27432" marB="27432" anchor="t">
+                    <a:solidFill>
+                      <a:srgbClr val="FFFFFF"/>
+                    </a:solidFill>
+                    <a:lnL w="6350" cap="flat" cmpd="sng" algn="ctr">
+                      <a:solidFill>
+                        <a:srgbClr val="E2E6E3"/>
+                      </a:solidFill>
+                      <a:prstDash val="solid"/>
+                    </a:lnL>
+                    <a:lnR w="6350" cap="flat" cmpd="sng" algn="ctr">
+                      <a:solidFill>
+                        <a:srgbClr val="E2E6E3"/>
+                      </a:solidFill>
+                      <a:prstDash val="solid"/>
+                    </a:lnR>
+                    <a:lnT w="6350" cap="flat" cmpd="sng" algn="ctr">
+                      <a:solidFill>
+                        <a:srgbClr val="E2E6E3"/>
+                      </a:solidFill>
+                      <a:prstDash val="solid"/>
+                    </a:lnT>
+                    <a:lnB w="6350" cap="flat" cmpd="sng" algn="ctr">
+                      <a:solidFill>
+                        <a:srgbClr val="E2E6E3"/>
+                      </a:solidFill>
+                      <a:prstDash val="solid"/>
+                    </a:lnB>
+                  </a:tcPr>
+                </a:tc>
+              </a:tr>
+            </a:tbl>
+          </a:graphicData>
+        </a:graphic>
+      </p:graphicFrame>
     </p:spTree>
   </p:cSld>
   <p:clrMapOvr>
@@ -13285,7 +14078,7 @@
           <a:lstStyle/>
           <a:p>
             <a:r>
-              <a:t>TERRITORY REVIEW  ·  4 OF 6  ·  LOSSES</a:t>
+              <a:t>TERRITORY REVIEW  ·  4 OF 7  ·  WINS</a:t>
             </a:r>
           </a:p>
         </p:txBody>
@@ -13306,7 +14099,7 @@
           <a:lstStyle/>
           <a:p>
             <a:r>
-              <a:t>Three losses</a:t>
+              <a:t>Three wins</a:t>
             </a:r>
           </a:p>
         </p:txBody>
@@ -13327,7 +14120,7 @@
           <a:lstStyle/>
           <a:p>
             <a:r>
-              <a:t>[One line. Which loss hurt most and whether we'd lose it again today.]</a:t>
+              <a:t>[One line. The pattern across the three, or the one we should be copying.]</a:t>
             </a:r>
           </a:p>
         </p:txBody>
@@ -13369,38 +14162,22 @@
           <a:lstStyle/>
           <a:p>
             <a:r>
-              <a:rPr sz="1400"/>
-              <a:t>Job: [dealer, account, job]</a:t>
-            </a:r>
-          </a:p>
-          <a:p>
-            <a:r>
-              <a:rPr sz="1400"/>
-              <a:t>Who won: [competitor]</a:t>
-            </a:r>
-          </a:p>
-          <a:p>
-            <a:r>
-              <a:rPr sz="1400"/>
-              <a:t>Their price: [$ or unknown]</a:t>
-            </a:r>
-          </a:p>
-          <a:p>
-            <a:r>
-              <a:rPr sz="1400"/>
-              <a:t>Lead time: ours / theirs [wks]</a:t>
-            </a:r>
-          </a:p>
-          <a:p>
-            <a:r>
-              <a:rPr sz="1400"/>
-              <a:t>Why: [ ]</a:t>
-            </a:r>
-          </a:p>
-          <a:p>
-            <a:r>
-              <a:rPr sz="1400"/>
-              <a:t>Lose it again today: [yes/no]</a:t>
+              <a:t>Job: [dealer, account, job name]</a:t>
+            </a:r>
+          </a:p>
+          <a:p>
+            <a:r>
+              <a:t>Size: [$ and product]</a:t>
+            </a:r>
+          </a:p>
+          <a:p>
+            <a:r>
+              <a:t>Why we won on price: [ ]</a:t>
+            </a:r>
+          </a:p>
+          <a:p>
+            <a:r>
+              <a:t>Repeatable: [yes or no, and why]</a:t>
             </a:r>
           </a:p>
         </p:txBody>
@@ -13442,38 +14219,22 @@
           <a:lstStyle/>
           <a:p>
             <a:r>
-              <a:rPr sz="1400"/>
-              <a:t>Job: [dealer, account, job]</a:t>
-            </a:r>
-          </a:p>
-          <a:p>
-            <a:r>
-              <a:rPr sz="1400"/>
-              <a:t>Who won: [competitor]</a:t>
-            </a:r>
-          </a:p>
-          <a:p>
-            <a:r>
-              <a:rPr sz="1400"/>
-              <a:t>Why: [what they had, we didn't]</a:t>
-            </a:r>
-          </a:p>
-          <a:p>
-            <a:r>
-              <a:rPr sz="1400"/>
-              <a:t>Lead time: ours / theirs [wks]</a:t>
-            </a:r>
-          </a:p>
-          <a:p>
-            <a:r>
-              <a:rPr sz="1400"/>
-              <a:t>Lose it again today: [yes/no]</a:t>
-            </a:r>
-          </a:p>
-          <a:p>
-            <a:r>
-              <a:rPr sz="1400"/>
-              <a:t>No product loss? Say so here.</a:t>
+              <a:t>Job: [dealer, account, job name]</a:t>
+            </a:r>
+          </a:p>
+          <a:p>
+            <a:r>
+              <a:t>Size: [$ and product]</a:t>
+            </a:r>
+          </a:p>
+          <a:p>
+            <a:r>
+              <a:t>Why we won on product: [ ]</a:t>
+            </a:r>
+          </a:p>
+          <a:p>
+            <a:r>
+              <a:t>Repeatable: [yes or no, and why]</a:t>
             </a:r>
           </a:p>
         </p:txBody>
@@ -13515,38 +14276,22 @@
           <a:lstStyle/>
           <a:p>
             <a:r>
-              <a:rPr sz="1400"/>
-              <a:t>Job: [dealer, account, job]</a:t>
-            </a:r>
-          </a:p>
-          <a:p>
-            <a:r>
-              <a:rPr sz="1400"/>
-              <a:t>Who won: [competitor]</a:t>
-            </a:r>
-          </a:p>
-          <a:p>
-            <a:r>
-              <a:rPr sz="1400"/>
-              <a:t>Lead time: ours / theirs [wks]</a:t>
-            </a:r>
-          </a:p>
-          <a:p>
-            <a:r>
-              <a:rPr sz="1400"/>
-              <a:t>Why: [quoting or service]</a:t>
-            </a:r>
-          </a:p>
-          <a:p>
-            <a:r>
-              <a:rPr sz="1400"/>
-              <a:t>Lose it again today: [yes/no]</a:t>
-            </a:r>
-          </a:p>
-          <a:p>
-            <a:r>
-              <a:rPr sz="1400"/>
-              <a:t>No speed loss? Say so here.</a:t>
+              <a:t>Job: [dealer, account, job name]</a:t>
+            </a:r>
+          </a:p>
+          <a:p>
+            <a:r>
+              <a:t>Size: [$ and product]</a:t>
+            </a:r>
+          </a:p>
+          <a:p>
+            <a:r>
+              <a:t>Why we won on speed or support: [ ]</a:t>
+            </a:r>
+          </a:p>
+          <a:p>
+            <a:r>
+              <a:t>Repeatable: [yes or no, and why]</a:t>
             </a:r>
           </a:p>
         </p:txBody>
@@ -13585,7 +14330,307 @@
           <a:lstStyle/>
           <a:p>
             <a:r>
-              <a:t>TERRITORY REVIEW  ·  5 OF 6  ·  STRAIGHT TALK</a:t>
+              <a:t>TERRITORY REVIEW  ·  5 OF 7  ·  LOSSES</a:t>
+            </a:r>
+          </a:p>
+        </p:txBody>
+      </p:sp>
+      <p:sp>
+        <p:nvSpPr>
+          <p:cNvPr id="3" name="Title 2"/>
+          <p:cNvSpPr>
+            <a:spLocks noGrp="1"/>
+          </p:cNvSpPr>
+          <p:nvPr>
+            <p:ph type="title" idx="101"/>
+          </p:nvPr>
+        </p:nvSpPr>
+        <p:spPr/>
+        <p:txBody>
+          <a:bodyPr/>
+          <a:lstStyle/>
+          <a:p>
+            <a:r>
+              <a:t>Three losses</a:t>
+            </a:r>
+          </a:p>
+        </p:txBody>
+      </p:sp>
+      <p:sp>
+        <p:nvSpPr>
+          <p:cNvPr id="4" name="Text Placeholder 3"/>
+          <p:cNvSpPr>
+            <a:spLocks noGrp="1"/>
+          </p:cNvSpPr>
+          <p:nvPr>
+            <p:ph type="body" idx="102"/>
+          </p:nvPr>
+        </p:nvSpPr>
+        <p:spPr/>
+        <p:txBody>
+          <a:bodyPr/>
+          <a:lstStyle/>
+          <a:p>
+            <a:r>
+              <a:t>[One line. Which loss hurt most and whether we'd lose it again today.]</a:t>
+            </a:r>
+          </a:p>
+        </p:txBody>
+      </p:sp>
+      <p:sp>
+        <p:nvSpPr>
+          <p:cNvPr id="5" name="Text Placeholder 4"/>
+          <p:cNvSpPr>
+            <a:spLocks noGrp="1"/>
+          </p:cNvSpPr>
+          <p:nvPr>
+            <p:ph type="body" idx="106"/>
+          </p:nvPr>
+        </p:nvSpPr>
+        <p:spPr/>
+        <p:txBody>
+          <a:bodyPr/>
+          <a:lstStyle/>
+          <a:p>
+            <a:r>
+              <a:t>Price</a:t>
+            </a:r>
+          </a:p>
+        </p:txBody>
+      </p:sp>
+      <p:sp>
+        <p:nvSpPr>
+          <p:cNvPr id="6" name="Text Placeholder 5"/>
+          <p:cNvSpPr>
+            <a:spLocks noGrp="1"/>
+          </p:cNvSpPr>
+          <p:nvPr>
+            <p:ph type="body" idx="107"/>
+          </p:nvPr>
+        </p:nvSpPr>
+        <p:spPr/>
+        <p:txBody>
+          <a:bodyPr/>
+          <a:lstStyle/>
+          <a:p>
+            <a:r>
+              <a:rPr sz="1400"/>
+              <a:t>Job: [dealer, account, job]</a:t>
+            </a:r>
+          </a:p>
+          <a:p>
+            <a:r>
+              <a:rPr sz="1400"/>
+              <a:t>Who won: [competitor]</a:t>
+            </a:r>
+          </a:p>
+          <a:p>
+            <a:r>
+              <a:rPr sz="1400"/>
+              <a:t>Their price: [$ or unknown]</a:t>
+            </a:r>
+          </a:p>
+          <a:p>
+            <a:r>
+              <a:rPr sz="1400"/>
+              <a:t>Lead time: ours / theirs [wks]</a:t>
+            </a:r>
+          </a:p>
+          <a:p>
+            <a:r>
+              <a:rPr sz="1400"/>
+              <a:t>Why: [ ]</a:t>
+            </a:r>
+          </a:p>
+          <a:p>
+            <a:r>
+              <a:rPr sz="1400"/>
+              <a:t>Lose it again today: [yes/no]</a:t>
+            </a:r>
+          </a:p>
+        </p:txBody>
+      </p:sp>
+      <p:sp>
+        <p:nvSpPr>
+          <p:cNvPr id="7" name="Text Placeholder 6"/>
+          <p:cNvSpPr>
+            <a:spLocks noGrp="1"/>
+          </p:cNvSpPr>
+          <p:nvPr>
+            <p:ph type="body" idx="111"/>
+          </p:nvPr>
+        </p:nvSpPr>
+        <p:spPr/>
+        <p:txBody>
+          <a:bodyPr/>
+          <a:lstStyle/>
+          <a:p>
+            <a:r>
+              <a:t>Product</a:t>
+            </a:r>
+          </a:p>
+        </p:txBody>
+      </p:sp>
+      <p:sp>
+        <p:nvSpPr>
+          <p:cNvPr id="8" name="Text Placeholder 7"/>
+          <p:cNvSpPr>
+            <a:spLocks noGrp="1"/>
+          </p:cNvSpPr>
+          <p:nvPr>
+            <p:ph type="body" idx="112"/>
+          </p:nvPr>
+        </p:nvSpPr>
+        <p:spPr/>
+        <p:txBody>
+          <a:bodyPr/>
+          <a:lstStyle/>
+          <a:p>
+            <a:r>
+              <a:rPr sz="1400"/>
+              <a:t>Job: [dealer, account, job]</a:t>
+            </a:r>
+          </a:p>
+          <a:p>
+            <a:r>
+              <a:rPr sz="1400"/>
+              <a:t>Who won: [competitor]</a:t>
+            </a:r>
+          </a:p>
+          <a:p>
+            <a:r>
+              <a:rPr sz="1400"/>
+              <a:t>Why: [what they had, we didn't]</a:t>
+            </a:r>
+          </a:p>
+          <a:p>
+            <a:r>
+              <a:rPr sz="1400"/>
+              <a:t>Lead time: ours / theirs [wks]</a:t>
+            </a:r>
+          </a:p>
+          <a:p>
+            <a:r>
+              <a:rPr sz="1400"/>
+              <a:t>Lose it again today: [yes/no]</a:t>
+            </a:r>
+          </a:p>
+          <a:p>
+            <a:r>
+              <a:rPr sz="1400"/>
+              <a:t>No product loss? Say so here.</a:t>
+            </a:r>
+          </a:p>
+        </p:txBody>
+      </p:sp>
+      <p:sp>
+        <p:nvSpPr>
+          <p:cNvPr id="9" name="Text Placeholder 8"/>
+          <p:cNvSpPr>
+            <a:spLocks noGrp="1"/>
+          </p:cNvSpPr>
+          <p:nvPr>
+            <p:ph type="body" idx="116"/>
+          </p:nvPr>
+        </p:nvSpPr>
+        <p:spPr/>
+        <p:txBody>
+          <a:bodyPr/>
+          <a:lstStyle/>
+          <a:p>
+            <a:r>
+              <a:t>Speed and support</a:t>
+            </a:r>
+          </a:p>
+        </p:txBody>
+      </p:sp>
+      <p:sp>
+        <p:nvSpPr>
+          <p:cNvPr id="10" name="Text Placeholder 9"/>
+          <p:cNvSpPr>
+            <a:spLocks noGrp="1"/>
+          </p:cNvSpPr>
+          <p:nvPr>
+            <p:ph type="body" idx="117"/>
+          </p:nvPr>
+        </p:nvSpPr>
+        <p:spPr/>
+        <p:txBody>
+          <a:bodyPr/>
+          <a:lstStyle/>
+          <a:p>
+            <a:r>
+              <a:rPr sz="1400"/>
+              <a:t>Job: [dealer, account, job]</a:t>
+            </a:r>
+          </a:p>
+          <a:p>
+            <a:r>
+              <a:rPr sz="1400"/>
+              <a:t>Who won: [competitor]</a:t>
+            </a:r>
+          </a:p>
+          <a:p>
+            <a:r>
+              <a:rPr sz="1400"/>
+              <a:t>Lead time: ours / theirs [wks]</a:t>
+            </a:r>
+          </a:p>
+          <a:p>
+            <a:r>
+              <a:rPr sz="1400"/>
+              <a:t>Why: [quoting or service]</a:t>
+            </a:r>
+          </a:p>
+          <a:p>
+            <a:r>
+              <a:rPr sz="1400"/>
+              <a:t>Lose it again today: [yes/no]</a:t>
+            </a:r>
+          </a:p>
+          <a:p>
+            <a:r>
+              <a:rPr sz="1400"/>
+              <a:t>No speed loss? Say so here.</a:t>
+            </a:r>
+          </a:p>
+        </p:txBody>
+      </p:sp>
+    </p:spTree>
+  </p:cSld>
+  <p:clrMapOvr>
+    <a:masterClrMapping/>
+  </p:clrMapOvr>
+</p:sld>
+</file>
+
+<file path=ppt/slides/slide7.xml><?xml version="1.0" encoding="utf-8"?>
+<p:sld xmlns:a="http://schemas.openxmlformats.org/drawingml/2006/main" xmlns:p="http://schemas.openxmlformats.org/presentationml/2006/main" xmlns:r="http://schemas.openxmlformats.org/officeDocument/2006/relationships">
+  <p:cSld>
+    <p:spTree>
+      <p:nvGrpSpPr>
+        <p:cNvPr id="1" name=""/>
+        <p:cNvGrpSpPr/>
+        <p:nvPr/>
+      </p:nvGrpSpPr>
+      <p:grpSpPr/>
+      <p:sp>
+        <p:nvSpPr>
+          <p:cNvPr id="2" name="Text Placeholder 1"/>
+          <p:cNvSpPr>
+            <a:spLocks noGrp="1"/>
+          </p:cNvSpPr>
+          <p:nvPr>
+            <p:ph type="body" idx="100"/>
+          </p:nvPr>
+        </p:nvSpPr>
+        <p:spPr/>
+        <p:txBody>
+          <a:bodyPr/>
+          <a:lstStyle/>
+          <a:p>
+            <a:r>
+              <a:t>TERRITORY REVIEW  ·  6 OF 7  ·  STRAIGHT TALK</a:t>
             </a:r>
           </a:p>
         </p:txBody>
@@ -14225,7 +15270,7 @@
 </p:sld>
 </file>
 
-<file path=ppt/slides/slide7.xml><?xml version="1.0" encoding="utf-8"?>
+<file path=ppt/slides/slide8.xml><?xml version="1.0" encoding="utf-8"?>
 <p:sld xmlns:a="http://schemas.openxmlformats.org/drawingml/2006/main" xmlns:p="http://schemas.openxmlformats.org/presentationml/2006/main" xmlns:r="http://schemas.openxmlformats.org/officeDocument/2006/relationships">
   <p:cSld>
     <p:spTree>
@@ -14251,7 +15296,7 @@
           <a:lstStyle/>
           <a:p>
             <a:r>
-              <a:t>TERRITORY REVIEW  ·  6 OF 6  ·  FOCUS</a:t>
+              <a:t>TERRITORY REVIEW  ·  7 OF 7  ·  FOCUS</a:t>
             </a:r>
           </a:p>
         </p:txBody>

</xml_diff>